<commit_message>
Add extended real-data results and update presentation
Co-Authored-By: Claude Sonnet 5.5 <noreply@anthropic.com>
Claude-Session: https://claude.ai/code/session_01PXyVqdKG827WeN1ceWaNxA
</commit_message>
<xml_diff>
--- a/presentation/progress_update.pptx
+++ b/presentation/progress_update.pptx
@@ -12,9 +12,10 @@
     <p:sldId id="260" r:id="rId6"/>
     <p:sldId id="261" r:id="rId7"/>
     <p:sldId id="262" r:id="rId8"/>
+    <p:sldId id="263" r:id="rId9"/>
   </p:sldIdLst>
   <p:notesMasterIdLst>
-    <p:notesMasterId r:id="rId9"/>
+    <p:notesMasterId r:id="rId10"/>
   </p:notesMasterIdLst>
   <p:sldSz cx="9144000" cy="5143500"/>
   <p:notesSz cx="5143500" cy="9144000"/>
@@ -540,6 +541,420 @@
 </c:chartSpace>
 </file>
 
+<file path=ppt/charts/chart2.xml><?xml version="1.0" encoding="utf-8"?>
+<c:chartSpace xmlns:c="http://schemas.openxmlformats.org/drawingml/2006/chart" xmlns:a="http://schemas.openxmlformats.org/drawingml/2006/main" xmlns:r="http://schemas.openxmlformats.org/officeDocument/2006/relationships">
+  <c:date1904 val="0"/>
+  <c:roundedCorners val="1"/>
+  <c:chart>
+    <c:autoTitleDeleted val="1"/>
+    <c:plotArea>
+      <c:layout/>
+      <c:barChart>
+        <c:barDir val="col"/>
+        <c:grouping val="clustered"/>
+        <c:varyColors val="0"/>
+        <c:ser>
+          <c:idx val="0"/>
+          <c:order val="0"/>
+          <c:tx>
+            <c:strRef>
+              <c:f>Sheet1!$B$1</c:f>
+              <c:strCache>
+                <c:ptCount val="1"/>
+                <c:pt idx="0">
+                  <c:v>Per-sender</c:v>
+                </c:pt>
+              </c:strCache>
+            </c:strRef>
+          </c:tx>
+          <c:spPr>
+            <a:solidFill>
+              <a:srgbClr val="9AA9B5"/>
+            </a:solidFill>
+            <a:effectLst/>
+          </c:spPr>
+          <c:invertIfNegative val="0"/>
+          <c:dLbls>
+            <c:numFmt formatCode="0.000" sourceLinked="0"/>
+            <c:txPr>
+              <a:bodyPr/>
+              <a:lstStyle/>
+              <a:p>
+                <a:pPr>
+                  <a:defRPr b="0" i="0" strike="noStrike" sz="900" u="none">
+                    <a:solidFill>
+                      <a:srgbClr val="1B2A38"/>
+                    </a:solidFill>
+                    <a:latin typeface="Arial"/>
+                  </a:defRPr>
+                </a:pPr>
+              </a:p>
+            </c:txPr>
+            <c:showLegendKey val="0"/>
+            <c:showVal val="1"/>
+            <c:showCatName val="0"/>
+            <c:showSerName val="0"/>
+            <c:showPercent val="0"/>
+            <c:showBubbleSize val="0"/>
+            <c:showLeaderLines val="0"/>
+          </c:dLbls>
+          <c:cat>
+            <c:multiLvlStrRef>
+              <c:f>Sheet1!$A$2:$A$5</c:f>
+              <c:multiLvlStrCache>
+                <c:ptCount val="4"/>
+                <c:lvl>
+                  <c:pt idx="0">
+                    <c:v>0-10%</c:v>
+                  </c:pt>
+                  <c:pt idx="1">
+                    <c:v>10-30%</c:v>
+                  </c:pt>
+                  <c:pt idx="2">
+                    <c:v>30-50%</c:v>
+                  </c:pt>
+                  <c:pt idx="3">
+                    <c:v>50-100%</c:v>
+                  </c:pt>
+                </c:lvl>
+              </c:multiLvlStrCache>
+            </c:multiLvlStrRef>
+          </c:cat>
+          <c:val>
+            <c:numRef>
+              <c:f>Sheet1!$B$2:$B$5</c:f>
+              <c:numCache>
+                <c:formatCode>General</c:formatCode>
+                <c:ptCount val="4"/>
+                <c:pt idx="0">
+                  <c:v>0.956</c:v>
+                </c:pt>
+                <c:pt idx="1">
+                  <c:v>0.966</c:v>
+                </c:pt>
+                <c:pt idx="2">
+                  <c:v>0.959</c:v>
+                </c:pt>
+                <c:pt idx="3">
+                  <c:v>0.953</c:v>
+                </c:pt>
+              </c:numCache>
+            </c:numRef>
+          </c:val>
+        </c:ser>
+        <c:ser>
+          <c:idx val="1"/>
+          <c:order val="1"/>
+          <c:tx>
+            <c:strRef>
+              <c:f>Sheet1!$C$1</c:f>
+              <c:strCache>
+                <c:ptCount val="1"/>
+                <c:pt idx="0">
+                  <c:v>Full model</c:v>
+                </c:pt>
+              </c:strCache>
+            </c:strRef>
+          </c:tx>
+          <c:spPr>
+            <a:solidFill>
+              <a:srgbClr val="1C7C7D"/>
+            </a:solidFill>
+            <a:effectLst/>
+          </c:spPr>
+          <c:invertIfNegative val="0"/>
+          <c:dLbls>
+            <c:numFmt formatCode="0.000" sourceLinked="0"/>
+            <c:txPr>
+              <a:bodyPr/>
+              <a:lstStyle/>
+              <a:p>
+                <a:pPr>
+                  <a:defRPr b="0" i="0" strike="noStrike" sz="900" u="none">
+                    <a:solidFill>
+                      <a:srgbClr val="1B2A38"/>
+                    </a:solidFill>
+                    <a:latin typeface="Arial"/>
+                  </a:defRPr>
+                </a:pPr>
+              </a:p>
+            </c:txPr>
+            <c:showLegendKey val="0"/>
+            <c:showVal val="1"/>
+            <c:showCatName val="0"/>
+            <c:showSerName val="0"/>
+            <c:showPercent val="0"/>
+            <c:showBubbleSize val="0"/>
+            <c:showLeaderLines val="0"/>
+          </c:dLbls>
+          <c:cat>
+            <c:multiLvlStrRef>
+              <c:f>Sheet1!$A$2:$A$5</c:f>
+              <c:multiLvlStrCache>
+                <c:ptCount val="4"/>
+                <c:lvl>
+                  <c:pt idx="0">
+                    <c:v>0-10%</c:v>
+                  </c:pt>
+                  <c:pt idx="1">
+                    <c:v>10-30%</c:v>
+                  </c:pt>
+                  <c:pt idx="2">
+                    <c:v>30-50%</c:v>
+                  </c:pt>
+                  <c:pt idx="3">
+                    <c:v>50-100%</c:v>
+                  </c:pt>
+                </c:lvl>
+              </c:multiLvlStrCache>
+            </c:multiLvlStrRef>
+          </c:cat>
+          <c:val>
+            <c:numRef>
+              <c:f>Sheet1!$C$2:$C$5</c:f>
+              <c:numCache>
+                <c:formatCode>General</c:formatCode>
+                <c:ptCount val="4"/>
+                <c:pt idx="0">
+                  <c:v>0.973</c:v>
+                </c:pt>
+                <c:pt idx="1">
+                  <c:v>0.981</c:v>
+                </c:pt>
+                <c:pt idx="2">
+                  <c:v>0.974</c:v>
+                </c:pt>
+                <c:pt idx="3">
+                  <c:v>0.971</c:v>
+                </c:pt>
+              </c:numCache>
+            </c:numRef>
+          </c:val>
+        </c:ser>
+        <c:dLbls>
+          <c:numFmt formatCode="0.000" sourceLinked="0"/>
+          <c:txPr>
+            <a:bodyPr/>
+            <a:lstStyle/>
+            <a:p>
+              <a:pPr>
+                <a:defRPr b="0" i="0" strike="noStrike" sz="900" u="none">
+                  <a:solidFill>
+                    <a:srgbClr val="1B2A38"/>
+                  </a:solidFill>
+                  <a:latin typeface="Arial"/>
+                </a:defRPr>
+              </a:pPr>
+            </a:p>
+          </c:txPr>
+          <c:showLegendKey val="0"/>
+          <c:showVal val="1"/>
+          <c:showCatName val="0"/>
+          <c:showSerName val="0"/>
+          <c:showPercent val="0"/>
+          <c:showBubbleSize val="0"/>
+          <c:showLeaderLines val="0"/>
+        </c:dLbls>
+        <c:gapWidth val="150"/>
+        <c:overlap val="0"/>
+        <c:axId val="2094734554"/>
+        <c:axId val="2094734552"/>
+        <c:axId val="2094734556"/>
+      </c:barChart>
+      <c:catAx>
+        <c:axId val="2094734554"/>
+        <c:scaling>
+          <c:orientation val="minMax"/>
+        </c:scaling>
+        <c:delete val="0"/>
+        <c:axPos val="b"/>
+        <c:title>
+          <c:tx>
+            <c:rich>
+              <a:bodyPr/>
+              <a:lstStyle/>
+              <a:p>
+                <a:pPr>
+                  <a:defRPr sz="1100" b="0" i="0" u="none" strike="noStrike">
+                    <a:solidFill>
+                      <a:srgbClr val="5B6B7A"/>
+                    </a:solidFill>
+                    <a:latin typeface="Arial"/>
+                  </a:defRPr>
+                </a:pPr>
+                <a:r>
+                  <a:rPr sz="1100" b="0" i="0" u="none" strike="noStrike">
+                    <a:solidFill>
+                      <a:srgbClr val="5B6B7A"/>
+                    </a:solidFill>
+                    <a:latin typeface="Arial"/>
+                  </a:rPr>
+                  <a:t>Share of a sender's neighbours that are malicious</a:t>
+                </a:r>
+              </a:p>
+            </c:rich>
+          </c:tx>
+          <c:layout/>
+          <c:overlay val="0"/>
+        </c:title>
+        <c:numFmt formatCode="General" sourceLinked="1"/>
+        <c:majorTickMark val="out"/>
+        <c:minorTickMark val="none"/>
+        <c:tickLblPos val="low"/>
+        <c:spPr>
+          <a:ln w="12700" cap="flat">
+            <a:solidFill>
+              <a:srgbClr val="888888"/>
+            </a:solidFill>
+            <a:prstDash val="solid"/>
+            <a:round/>
+          </a:ln>
+        </c:spPr>
+        <c:txPr>
+          <a:bodyPr/>
+          <a:lstStyle/>
+          <a:p>
+            <a:pPr>
+              <a:defRPr sz="1200" b="0" i="0" u="none" strike="noStrike">
+                <a:solidFill>
+                  <a:srgbClr val="1B2A38"/>
+                </a:solidFill>
+                <a:latin typeface="Arial"/>
+              </a:defRPr>
+            </a:pPr>
+            <a:endParaRPr lang="en-US"/>
+          </a:p>
+        </c:txPr>
+        <c:crossAx val="2094734552"/>
+        <c:crosses val="autoZero"/>
+        <c:auto val="1"/>
+        <c:lblAlgn val="ctr"/>
+        <c:noMultiLvlLbl val="1"/>
+      </c:catAx>
+      <c:valAx>
+        <c:axId val="2094734552"/>
+        <c:scaling>
+          <c:orientation val="minMax"/>
+          <c:max val="1"/>
+          <c:min val="0.9"/>
+        </c:scaling>
+        <c:delete val="0"/>
+        <c:axPos val="l"/>
+        <c:majorGridlines>
+          <c:spPr>
+            <a:ln w="6350" cap="flat">
+              <a:solidFill>
+                <a:srgbClr val="E3E8EC"/>
+              </a:solidFill>
+              <a:prstDash val="solid"/>
+              <a:round/>
+            </a:ln>
+          </c:spPr>
+        </c:majorGridlines>
+        <c:title>
+          <c:tx>
+            <c:rich>
+              <a:bodyPr/>
+              <a:lstStyle/>
+              <a:p>
+                <a:pPr>
+                  <a:defRPr sz="1100" b="0" i="0" u="none" strike="noStrike">
+                    <a:solidFill>
+                      <a:srgbClr val="5B6B7A"/>
+                    </a:solidFill>
+                    <a:latin typeface="Arial"/>
+                  </a:defRPr>
+                </a:pPr>
+                <a:r>
+                  <a:rPr sz="1100" b="0" i="0" u="none" strike="noStrike">
+                    <a:solidFill>
+                      <a:srgbClr val="5B6B7A"/>
+                    </a:solidFill>
+                    <a:latin typeface="Arial"/>
+                  </a:rPr>
+                  <a:t>Recall</a:t>
+                </a:r>
+              </a:p>
+            </c:rich>
+          </c:tx>
+          <c:layout/>
+          <c:overlay val="0"/>
+        </c:title>
+        <c:numFmt formatCode="0.00" sourceLinked="0"/>
+        <c:majorTickMark val="out"/>
+        <c:minorTickMark val="none"/>
+        <c:tickLblPos val="nextTo"/>
+        <c:spPr>
+          <a:ln w="12700" cap="flat">
+            <a:solidFill>
+              <a:srgbClr val="888888"/>
+            </a:solidFill>
+            <a:prstDash val="solid"/>
+            <a:round/>
+          </a:ln>
+        </c:spPr>
+        <c:txPr>
+          <a:bodyPr/>
+          <a:lstStyle/>
+          <a:p>
+            <a:pPr>
+              <a:defRPr sz="1100" b="0" i="0" u="none" strike="noStrike">
+                <a:solidFill>
+                  <a:srgbClr val="5B6B7A"/>
+                </a:solidFill>
+                <a:latin typeface="Arial"/>
+              </a:defRPr>
+            </a:pPr>
+            <a:endParaRPr lang="en-US"/>
+          </a:p>
+        </c:txPr>
+        <c:crossAx val="2094734554"/>
+        <c:crosses val="autoZero"/>
+        <c:crossBetween val="between"/>
+        <c:majorUnit val="0.02"/>
+      </c:valAx>
+      <c:spPr>
+        <a:noFill/>
+        <a:ln>
+          <a:noFill/>
+        </a:ln>
+        <a:effectLst/>
+      </c:spPr>
+    </c:plotArea>
+    <c:legend>
+      <c:legendPos val="b"/>
+      <c:overlay val="0"/>
+      <c:txPr>
+        <a:bodyPr/>
+        <a:lstStyle/>
+        <a:p>
+          <a:pPr>
+            <a:defRPr sz="1100">
+              <a:solidFill>
+                <a:srgbClr val="1B2A38"/>
+              </a:solidFill>
+            </a:defRPr>
+          </a:pPr>
+          <a:endParaRPr lang="en-US"/>
+        </a:p>
+      </c:txPr>
+    </c:legend>
+    <c:plotVisOnly val="1"/>
+    <c:dispBlanksAs val="span"/>
+  </c:chart>
+  <c:spPr>
+    <a:noFill/>
+    <a:ln>
+      <a:noFill/>
+    </a:ln>
+    <a:effectLst/>
+  </c:spPr>
+  <c:externalData r:id="rId1">
+    <c:autoUpdate val="0"/>
+  </c:externalData>
+</c:chartSpace>
+</file>
+
 <file path=ppt/notesMasters/notesMaster1.xml><?xml version="1.0" encoding="utf-8"?>
 <p:notesMaster xmlns:a="http://schemas.openxmlformats.org/drawingml/2006/main" xmlns:r="http://schemas.openxmlformats.org/officeDocument/2006/relationships" xmlns:p="http://schemas.openxmlformats.org/presentationml/2006/main">
   <p:cSld>
@@ -1375,7 +1790,7 @@
           <a:p>
             <a:r>
               <a:rPr lang="en-US" dirty="0"/>
-              <a:t/>
+              <a:t>Addresses professor point 1: precision, recall, F1, FPR and detection latency.</a:t>
             </a:r>
             <a:endParaRPr lang="en-US" dirty="0"/>
           </a:p>
@@ -1463,7 +1878,7 @@
           <a:p>
             <a:r>
               <a:rPr lang="en-US" dirty="0"/>
-              <a:t/>
+              <a:t>Addresses professor point 2. Recall by share of malicious neighbours; false-positive rate stays below 0.8% in every bucket.</a:t>
             </a:r>
             <a:endParaRPr lang="en-US" dirty="0"/>
           </a:p>
@@ -1487,6 +1902,94 @@
             <a:fld id="{F7021451-1387-4CA6-816F-3879F97B5CBC}" type="slidenum">
               <a:rPr lang="en-US"/>
               <a:t>7</a:t>
+            </a:fld>
+            <a:endParaRPr lang="en-US"/>
+          </a:p>
+        </p:txBody>
+      </p:sp>
+    </p:spTree>
+    <p:extLst>
+      <p:ext uri="{BB962C8B-B14F-4D97-AF65-F5344CB8AC3E}">
+        <p14:creationId xmlns:p14="http://schemas.microsoft.com/office/powerpoint/2010/main" val="1024086991"/>
+      </p:ext>
+    </p:extLst>
+  </p:cSld>
+  <p:clrMapOvr>
+    <a:masterClrMapping/>
+  </p:clrMapOvr>
+</p:notes>
+</file>
+
+<file path=ppt/notesSlides/notesSlide8.xml><?xml version="1.0" encoding="utf-8"?>
+<p:notes xmlns:a="http://schemas.openxmlformats.org/drawingml/2006/main" xmlns:r="http://schemas.openxmlformats.org/officeDocument/2006/relationships" xmlns:p="http://schemas.openxmlformats.org/presentationml/2006/main">
+  <p:cSld>
+    <p:spTree>
+      <p:nvGrpSpPr>
+        <p:cNvPr id="1" name=""/>
+        <p:cNvGrpSpPr/>
+        <p:nvPr/>
+      </p:nvGrpSpPr>
+      <p:grpSpPr>
+        <a:xfrm>
+          <a:off x="0" y="0"/>
+          <a:ext cx="0" cy="0"/>
+          <a:chOff x="0" y="0"/>
+          <a:chExt cx="0" cy="0"/>
+        </a:xfrm>
+      </p:grpSpPr>
+      <p:sp>
+        <p:nvSpPr>
+          <p:cNvPr id="2" name="Slide Image Placeholder 1"/>
+          <p:cNvSpPr>
+            <a:spLocks noGrp="1" noRot="1" noChangeAspect="1"/>
+          </p:cNvSpPr>
+          <p:nvPr>
+            <p:ph type="sldImg"/>
+          </p:nvPr>
+        </p:nvSpPr>
+        <p:spPr/>
+      </p:sp>
+      <p:sp>
+        <p:nvSpPr>
+          <p:cNvPr id="3" name="Notes Placeholder 2"/>
+          <p:cNvSpPr>
+            <a:spLocks noGrp="1"/>
+          </p:cNvSpPr>
+          <p:nvPr>
+            <p:ph type="body" idx="1"/>
+          </p:nvPr>
+        </p:nvSpPr>
+        <p:spPr/>
+        <p:txBody>
+          <a:bodyPr/>
+          <a:lstStyle/>
+          <a:p>
+            <a:r>
+              <a:rPr lang="en-US" dirty="0"/>
+              <a:t/>
+            </a:r>
+            <a:endParaRPr lang="en-US" dirty="0"/>
+          </a:p>
+        </p:txBody>
+      </p:sp>
+      <p:sp>
+        <p:nvSpPr>
+          <p:cNvPr id="4" name="Slide Number Placeholder 3"/>
+          <p:cNvSpPr>
+            <a:spLocks noGrp="1"/>
+          </p:cNvSpPr>
+          <p:nvPr>
+            <p:ph type="sldNum" sz="quarter" idx="10"/>
+          </p:nvPr>
+        </p:nvSpPr>
+        <p:spPr/>
+        <p:txBody>
+          <a:bodyPr/>
+          <a:lstStyle/>
+          <a:p>
+            <a:fld id="{F7021451-1387-4CA6-816F-3879F97B5CBC}" type="slidenum">
+              <a:rPr lang="en-US"/>
+              <a:t>8</a:t>
             </a:fld>
             <a:endParaRPr lang="en-US"/>
           </a:p>
@@ -3528,49 +4031,1051 @@
                 <a:ea typeface="Cambria" pitchFamily="34" charset="-122"/>
                 <a:cs typeface="Cambria" pitchFamily="34" charset="-120"/>
               </a:rPr>
-              <a:t>Professor feedback: in progress</a:t>
+              <a:t>Full metric set and detection latency</a:t>
             </a:r>
             <a:endParaRPr lang="en-US" sz="3200" dirty="0"/>
           </a:p>
         </p:txBody>
       </p:sp>
-      <p:sp>
-        <p:nvSpPr>
-          <p:cNvPr id="3" name="card"/>
-          <p:cNvSpPr/>
+      <p:graphicFrame>
+        <p:nvGraphicFramePr>
+          <p:cNvPr id="7" name="Table 0"/>
+          <p:cNvGraphicFramePr>
+            <a:graphicFrameLocks noGrp="1"/>
+          </p:cNvGraphicFramePr>
+          <p:nvPr>
+            <p:extLst>
+              <p:ext uri="{D42A27DB-BD31-4B8C-83A1-F6EECF244321}">
+                <p14:modId xmlns:p14="http://schemas.microsoft.com/office/powerpoint/2010/main" val="1579011935"/>
+              </p:ext>
+            </p:extLst>
+          </p:nvPr>
+        </p:nvGraphicFramePr>
+        <p:xfrm>
+          <a:off x="548640" y="1188720"/>
+          <a:ext cx="8046720" cy="914400"/>
+        </p:xfrm>
+        <a:graphic>
+          <a:graphicData uri="http://schemas.openxmlformats.org/drawingml/2006/table">
+            <a:tbl>
+              <a:tblPr/>
+              <a:tblGrid>
+                <a:gridCol w="2194560"/>
+                <a:gridCol w="1463040"/>
+                <a:gridCol w="1463040"/>
+                <a:gridCol w="1463040"/>
+                <a:gridCol w="1463040"/>
+              </a:tblGrid>
+              <a:tr h="384048">
+                <a:tc>
+                  <a:txBody>
+                    <a:bodyPr/>
+                    <a:lstStyle/>
+                    <a:p>
+                      <a:pPr algn="ctr" indent="0" marL="0">
+                        <a:buNone/>
+                      </a:pPr>
+                      <a:r>
+                        <a:rPr lang="en-US" sz="1300" b="1" dirty="0">
+                          <a:solidFill>
+                            <a:srgbClr val="FFFFFF"/>
+                          </a:solidFill>
+                          <a:latin typeface="Calibri" pitchFamily="34" charset="0"/>
+                          <a:ea typeface="Calibri" pitchFamily="34" charset="-122"/>
+                          <a:cs typeface="Calibri" pitchFamily="34" charset="-120"/>
+                        </a:rPr>
+                        <a:t>Model</a:t>
+                      </a:r>
+                      <a:endParaRPr lang="en-US" sz="1300" dirty="0">
+                        <a:latin typeface="Calibri" charset="0"/>
+                        <a:ea typeface="Calibri" charset="0"/>
+                        <a:cs typeface="Calibri" charset="0"/>
+                      </a:endParaRPr>
+                    </a:p>
+                  </a:txBody>
+                  <a:tcPr marL="91440" marR="91440" marT="45720" marB="45720">
+                    <a:lnL w="9525" cap="flat" cmpd="sng" algn="ctr">
+                      <a:solidFill>
+                        <a:srgbClr val="D5DDE3"/>
+                      </a:solidFill>
+                      <a:prstDash val="solid"/>
+                      <a:round/>
+                      <a:headEnd type="none" w="med" len="med"/>
+                      <a:tailEnd type="none" w="med" len="med"/>
+                    </a:lnL>
+                    <a:lnR w="9525" cap="flat" cmpd="sng" algn="ctr">
+                      <a:solidFill>
+                        <a:srgbClr val="D5DDE3"/>
+                      </a:solidFill>
+                      <a:prstDash val="solid"/>
+                      <a:round/>
+                      <a:headEnd type="none" w="med" len="med"/>
+                      <a:tailEnd type="none" w="med" len="med"/>
+                    </a:lnR>
+                    <a:lnT w="9525" cap="flat" cmpd="sng" algn="ctr">
+                      <a:solidFill>
+                        <a:srgbClr val="D5DDE3"/>
+                      </a:solidFill>
+                      <a:prstDash val="solid"/>
+                      <a:round/>
+                      <a:headEnd type="none" w="med" len="med"/>
+                      <a:tailEnd type="none" w="med" len="med"/>
+                    </a:lnT>
+                    <a:lnB w="9525" cap="flat" cmpd="sng" algn="ctr">
+                      <a:solidFill>
+                        <a:srgbClr val="D5DDE3"/>
+                      </a:solidFill>
+                      <a:prstDash val="solid"/>
+                      <a:round/>
+                      <a:headEnd type="none" w="med" len="med"/>
+                      <a:tailEnd type="none" w="med" len="med"/>
+                    </a:lnB>
+                    <a:solidFill>
+                      <a:srgbClr val="0B1F33"/>
+                    </a:solidFill>
+                  </a:tcPr>
+                </a:tc>
+                <a:tc>
+                  <a:txBody>
+                    <a:bodyPr/>
+                    <a:lstStyle/>
+                    <a:p>
+                      <a:pPr algn="ctr" indent="0" marL="0">
+                        <a:buNone/>
+                      </a:pPr>
+                      <a:r>
+                        <a:rPr lang="en-US" sz="1300" b="1" dirty="0">
+                          <a:solidFill>
+                            <a:srgbClr val="FFFFFF"/>
+                          </a:solidFill>
+                          <a:latin typeface="Calibri" pitchFamily="34" charset="0"/>
+                          <a:ea typeface="Calibri" pitchFamily="34" charset="-122"/>
+                          <a:cs typeface="Calibri" pitchFamily="34" charset="-120"/>
+                        </a:rPr>
+                        <a:t>Precision</a:t>
+                      </a:r>
+                      <a:endParaRPr lang="en-US" sz="1300" dirty="0">
+                        <a:latin typeface="Calibri" charset="0"/>
+                        <a:ea typeface="Calibri" charset="0"/>
+                        <a:cs typeface="Calibri" charset="0"/>
+                      </a:endParaRPr>
+                    </a:p>
+                  </a:txBody>
+                  <a:tcPr marL="91440" marR="91440" marT="45720" marB="45720">
+                    <a:lnL w="9525" cap="flat" cmpd="sng" algn="ctr">
+                      <a:solidFill>
+                        <a:srgbClr val="D5DDE3"/>
+                      </a:solidFill>
+                      <a:prstDash val="solid"/>
+                      <a:round/>
+                      <a:headEnd type="none" w="med" len="med"/>
+                      <a:tailEnd type="none" w="med" len="med"/>
+                    </a:lnL>
+                    <a:lnR w="9525" cap="flat" cmpd="sng" algn="ctr">
+                      <a:solidFill>
+                        <a:srgbClr val="D5DDE3"/>
+                      </a:solidFill>
+                      <a:prstDash val="solid"/>
+                      <a:round/>
+                      <a:headEnd type="none" w="med" len="med"/>
+                      <a:tailEnd type="none" w="med" len="med"/>
+                    </a:lnR>
+                    <a:lnT w="9525" cap="flat" cmpd="sng" algn="ctr">
+                      <a:solidFill>
+                        <a:srgbClr val="D5DDE3"/>
+                      </a:solidFill>
+                      <a:prstDash val="solid"/>
+                      <a:round/>
+                      <a:headEnd type="none" w="med" len="med"/>
+                      <a:tailEnd type="none" w="med" len="med"/>
+                    </a:lnT>
+                    <a:lnB w="9525" cap="flat" cmpd="sng" algn="ctr">
+                      <a:solidFill>
+                        <a:srgbClr val="D5DDE3"/>
+                      </a:solidFill>
+                      <a:prstDash val="solid"/>
+                      <a:round/>
+                      <a:headEnd type="none" w="med" len="med"/>
+                      <a:tailEnd type="none" w="med" len="med"/>
+                    </a:lnB>
+                    <a:solidFill>
+                      <a:srgbClr val="0B1F33"/>
+                    </a:solidFill>
+                  </a:tcPr>
+                </a:tc>
+                <a:tc>
+                  <a:txBody>
+                    <a:bodyPr/>
+                    <a:lstStyle/>
+                    <a:p>
+                      <a:pPr algn="ctr" indent="0" marL="0">
+                        <a:buNone/>
+                      </a:pPr>
+                      <a:r>
+                        <a:rPr lang="en-US" sz="1300" b="1" dirty="0">
+                          <a:solidFill>
+                            <a:srgbClr val="FFFFFF"/>
+                          </a:solidFill>
+                          <a:latin typeface="Calibri" pitchFamily="34" charset="0"/>
+                          <a:ea typeface="Calibri" pitchFamily="34" charset="-122"/>
+                          <a:cs typeface="Calibri" pitchFamily="34" charset="-120"/>
+                        </a:rPr>
+                        <a:t>Recall</a:t>
+                      </a:r>
+                      <a:endParaRPr lang="en-US" sz="1300" dirty="0">
+                        <a:latin typeface="Calibri" charset="0"/>
+                        <a:ea typeface="Calibri" charset="0"/>
+                        <a:cs typeface="Calibri" charset="0"/>
+                      </a:endParaRPr>
+                    </a:p>
+                  </a:txBody>
+                  <a:tcPr marL="91440" marR="91440" marT="45720" marB="45720">
+                    <a:lnL w="9525" cap="flat" cmpd="sng" algn="ctr">
+                      <a:solidFill>
+                        <a:srgbClr val="D5DDE3"/>
+                      </a:solidFill>
+                      <a:prstDash val="solid"/>
+                      <a:round/>
+                      <a:headEnd type="none" w="med" len="med"/>
+                      <a:tailEnd type="none" w="med" len="med"/>
+                    </a:lnL>
+                    <a:lnR w="9525" cap="flat" cmpd="sng" algn="ctr">
+                      <a:solidFill>
+                        <a:srgbClr val="D5DDE3"/>
+                      </a:solidFill>
+                      <a:prstDash val="solid"/>
+                      <a:round/>
+                      <a:headEnd type="none" w="med" len="med"/>
+                      <a:tailEnd type="none" w="med" len="med"/>
+                    </a:lnR>
+                    <a:lnT w="9525" cap="flat" cmpd="sng" algn="ctr">
+                      <a:solidFill>
+                        <a:srgbClr val="D5DDE3"/>
+                      </a:solidFill>
+                      <a:prstDash val="solid"/>
+                      <a:round/>
+                      <a:headEnd type="none" w="med" len="med"/>
+                      <a:tailEnd type="none" w="med" len="med"/>
+                    </a:lnT>
+                    <a:lnB w="9525" cap="flat" cmpd="sng" algn="ctr">
+                      <a:solidFill>
+                        <a:srgbClr val="D5DDE3"/>
+                      </a:solidFill>
+                      <a:prstDash val="solid"/>
+                      <a:round/>
+                      <a:headEnd type="none" w="med" len="med"/>
+                      <a:tailEnd type="none" w="med" len="med"/>
+                    </a:lnB>
+                    <a:solidFill>
+                      <a:srgbClr val="0B1F33"/>
+                    </a:solidFill>
+                  </a:tcPr>
+                </a:tc>
+                <a:tc>
+                  <a:txBody>
+                    <a:bodyPr/>
+                    <a:lstStyle/>
+                    <a:p>
+                      <a:pPr algn="ctr" indent="0" marL="0">
+                        <a:buNone/>
+                      </a:pPr>
+                      <a:r>
+                        <a:rPr lang="en-US" sz="1300" b="1" dirty="0">
+                          <a:solidFill>
+                            <a:srgbClr val="FFFFFF"/>
+                          </a:solidFill>
+                          <a:latin typeface="Calibri" pitchFamily="34" charset="0"/>
+                          <a:ea typeface="Calibri" pitchFamily="34" charset="-122"/>
+                          <a:cs typeface="Calibri" pitchFamily="34" charset="-120"/>
+                        </a:rPr>
+                        <a:t>F1</a:t>
+                      </a:r>
+                      <a:endParaRPr lang="en-US" sz="1300" dirty="0">
+                        <a:latin typeface="Calibri" charset="0"/>
+                        <a:ea typeface="Calibri" charset="0"/>
+                        <a:cs typeface="Calibri" charset="0"/>
+                      </a:endParaRPr>
+                    </a:p>
+                  </a:txBody>
+                  <a:tcPr marL="91440" marR="91440" marT="45720" marB="45720">
+                    <a:lnL w="9525" cap="flat" cmpd="sng" algn="ctr">
+                      <a:solidFill>
+                        <a:srgbClr val="D5DDE3"/>
+                      </a:solidFill>
+                      <a:prstDash val="solid"/>
+                      <a:round/>
+                      <a:headEnd type="none" w="med" len="med"/>
+                      <a:tailEnd type="none" w="med" len="med"/>
+                    </a:lnL>
+                    <a:lnR w="9525" cap="flat" cmpd="sng" algn="ctr">
+                      <a:solidFill>
+                        <a:srgbClr val="D5DDE3"/>
+                      </a:solidFill>
+                      <a:prstDash val="solid"/>
+                      <a:round/>
+                      <a:headEnd type="none" w="med" len="med"/>
+                      <a:tailEnd type="none" w="med" len="med"/>
+                    </a:lnR>
+                    <a:lnT w="9525" cap="flat" cmpd="sng" algn="ctr">
+                      <a:solidFill>
+                        <a:srgbClr val="D5DDE3"/>
+                      </a:solidFill>
+                      <a:prstDash val="solid"/>
+                      <a:round/>
+                      <a:headEnd type="none" w="med" len="med"/>
+                      <a:tailEnd type="none" w="med" len="med"/>
+                    </a:lnT>
+                    <a:lnB w="9525" cap="flat" cmpd="sng" algn="ctr">
+                      <a:solidFill>
+                        <a:srgbClr val="D5DDE3"/>
+                      </a:solidFill>
+                      <a:prstDash val="solid"/>
+                      <a:round/>
+                      <a:headEnd type="none" w="med" len="med"/>
+                      <a:tailEnd type="none" w="med" len="med"/>
+                    </a:lnB>
+                    <a:solidFill>
+                      <a:srgbClr val="0B1F33"/>
+                    </a:solidFill>
+                  </a:tcPr>
+                </a:tc>
+                <a:tc>
+                  <a:txBody>
+                    <a:bodyPr/>
+                    <a:lstStyle/>
+                    <a:p>
+                      <a:pPr algn="ctr" indent="0" marL="0">
+                        <a:buNone/>
+                      </a:pPr>
+                      <a:r>
+                        <a:rPr lang="en-US" sz="1300" b="1" dirty="0">
+                          <a:solidFill>
+                            <a:srgbClr val="FFFFFF"/>
+                          </a:solidFill>
+                          <a:latin typeface="Calibri" pitchFamily="34" charset="0"/>
+                          <a:ea typeface="Calibri" pitchFamily="34" charset="-122"/>
+                          <a:cs typeface="Calibri" pitchFamily="34" charset="-120"/>
+                        </a:rPr>
+                        <a:t>False-pos. rate</a:t>
+                      </a:r>
+                      <a:endParaRPr lang="en-US" sz="1300" dirty="0">
+                        <a:latin typeface="Calibri" charset="0"/>
+                        <a:ea typeface="Calibri" charset="0"/>
+                        <a:cs typeface="Calibri" charset="0"/>
+                      </a:endParaRPr>
+                    </a:p>
+                  </a:txBody>
+                  <a:tcPr marL="91440" marR="91440" marT="45720" marB="45720">
+                    <a:lnL w="9525" cap="flat" cmpd="sng" algn="ctr">
+                      <a:solidFill>
+                        <a:srgbClr val="D5DDE3"/>
+                      </a:solidFill>
+                      <a:prstDash val="solid"/>
+                      <a:round/>
+                      <a:headEnd type="none" w="med" len="med"/>
+                      <a:tailEnd type="none" w="med" len="med"/>
+                    </a:lnL>
+                    <a:lnR w="9525" cap="flat" cmpd="sng" algn="ctr">
+                      <a:solidFill>
+                        <a:srgbClr val="D5DDE3"/>
+                      </a:solidFill>
+                      <a:prstDash val="solid"/>
+                      <a:round/>
+                      <a:headEnd type="none" w="med" len="med"/>
+                      <a:tailEnd type="none" w="med" len="med"/>
+                    </a:lnR>
+                    <a:lnT w="9525" cap="flat" cmpd="sng" algn="ctr">
+                      <a:solidFill>
+                        <a:srgbClr val="D5DDE3"/>
+                      </a:solidFill>
+                      <a:prstDash val="solid"/>
+                      <a:round/>
+                      <a:headEnd type="none" w="med" len="med"/>
+                      <a:tailEnd type="none" w="med" len="med"/>
+                    </a:lnT>
+                    <a:lnB w="9525" cap="flat" cmpd="sng" algn="ctr">
+                      <a:solidFill>
+                        <a:srgbClr val="D5DDE3"/>
+                      </a:solidFill>
+                      <a:prstDash val="solid"/>
+                      <a:round/>
+                      <a:headEnd type="none" w="med" len="med"/>
+                      <a:tailEnd type="none" w="med" len="med"/>
+                    </a:lnB>
+                    <a:solidFill>
+                      <a:srgbClr val="0B1F33"/>
+                    </a:solidFill>
+                  </a:tcPr>
+                </a:tc>
+              </a:tr>
+              <a:tr h="384048">
+                <a:tc>
+                  <a:txBody>
+                    <a:bodyPr/>
+                    <a:lstStyle/>
+                    <a:p>
+                      <a:pPr algn="l" indent="0" marL="0">
+                        <a:buNone/>
+                      </a:pPr>
+                      <a:r>
+                        <a:rPr lang="en-US" sz="1300" dirty="0">
+                          <a:solidFill>
+                            <a:srgbClr val="1B2A38"/>
+                          </a:solidFill>
+                          <a:latin typeface="Calibri" pitchFamily="34" charset="0"/>
+                          <a:ea typeface="Calibri" pitchFamily="34" charset="-122"/>
+                          <a:cs typeface="Calibri" pitchFamily="34" charset="-120"/>
+                        </a:rPr>
+                        <a:t>Per-sender</a:t>
+                      </a:r>
+                      <a:endParaRPr lang="en-US" sz="1300" dirty="0">
+                        <a:latin typeface="Calibri" charset="0"/>
+                        <a:ea typeface="Calibri" charset="0"/>
+                        <a:cs typeface="Calibri" charset="0"/>
+                      </a:endParaRPr>
+                    </a:p>
+                  </a:txBody>
+                  <a:tcPr marL="91440" marR="91440" marT="45720" marB="45720">
+                    <a:lnL w="9525" cap="flat" cmpd="sng" algn="ctr">
+                      <a:solidFill>
+                        <a:srgbClr val="D5DDE3"/>
+                      </a:solidFill>
+                      <a:prstDash val="solid"/>
+                      <a:round/>
+                      <a:headEnd type="none" w="med" len="med"/>
+                      <a:tailEnd type="none" w="med" len="med"/>
+                    </a:lnL>
+                    <a:lnR w="9525" cap="flat" cmpd="sng" algn="ctr">
+                      <a:solidFill>
+                        <a:srgbClr val="D5DDE3"/>
+                      </a:solidFill>
+                      <a:prstDash val="solid"/>
+                      <a:round/>
+                      <a:headEnd type="none" w="med" len="med"/>
+                      <a:tailEnd type="none" w="med" len="med"/>
+                    </a:lnR>
+                    <a:lnT w="9525" cap="flat" cmpd="sng" algn="ctr">
+                      <a:solidFill>
+                        <a:srgbClr val="D5DDE3"/>
+                      </a:solidFill>
+                      <a:prstDash val="solid"/>
+                      <a:round/>
+                      <a:headEnd type="none" w="med" len="med"/>
+                      <a:tailEnd type="none" w="med" len="med"/>
+                    </a:lnT>
+                    <a:lnB w="9525" cap="flat" cmpd="sng" algn="ctr">
+                      <a:solidFill>
+                        <a:srgbClr val="D5DDE3"/>
+                      </a:solidFill>
+                      <a:prstDash val="solid"/>
+                      <a:round/>
+                      <a:headEnd type="none" w="med" len="med"/>
+                      <a:tailEnd type="none" w="med" len="med"/>
+                    </a:lnB>
+                  </a:tcPr>
+                </a:tc>
+                <a:tc>
+                  <a:txBody>
+                    <a:bodyPr/>
+                    <a:lstStyle/>
+                    <a:p>
+                      <a:pPr algn="ctr" indent="0" marL="0">
+                        <a:buNone/>
+                      </a:pPr>
+                      <a:r>
+                        <a:rPr lang="en-US" sz="1300" dirty="0">
+                          <a:solidFill>
+                            <a:srgbClr val="1B2A38"/>
+                          </a:solidFill>
+                          <a:latin typeface="Calibri" pitchFamily="34" charset="0"/>
+                          <a:ea typeface="Calibri" pitchFamily="34" charset="-122"/>
+                          <a:cs typeface="Calibri" pitchFamily="34" charset="-120"/>
+                        </a:rPr>
+                        <a:t>0.987</a:t>
+                      </a:r>
+                      <a:endParaRPr lang="en-US" sz="1300" dirty="0">
+                        <a:latin typeface="Calibri" charset="0"/>
+                        <a:ea typeface="Calibri" charset="0"/>
+                        <a:cs typeface="Calibri" charset="0"/>
+                      </a:endParaRPr>
+                    </a:p>
+                  </a:txBody>
+                  <a:tcPr marL="91440" marR="91440" marT="45720" marB="45720">
+                    <a:lnL w="9525" cap="flat" cmpd="sng" algn="ctr">
+                      <a:solidFill>
+                        <a:srgbClr val="D5DDE3"/>
+                      </a:solidFill>
+                      <a:prstDash val="solid"/>
+                      <a:round/>
+                      <a:headEnd type="none" w="med" len="med"/>
+                      <a:tailEnd type="none" w="med" len="med"/>
+                    </a:lnL>
+                    <a:lnR w="9525" cap="flat" cmpd="sng" algn="ctr">
+                      <a:solidFill>
+                        <a:srgbClr val="D5DDE3"/>
+                      </a:solidFill>
+                      <a:prstDash val="solid"/>
+                      <a:round/>
+                      <a:headEnd type="none" w="med" len="med"/>
+                      <a:tailEnd type="none" w="med" len="med"/>
+                    </a:lnR>
+                    <a:lnT w="9525" cap="flat" cmpd="sng" algn="ctr">
+                      <a:solidFill>
+                        <a:srgbClr val="D5DDE3"/>
+                      </a:solidFill>
+                      <a:prstDash val="solid"/>
+                      <a:round/>
+                      <a:headEnd type="none" w="med" len="med"/>
+                      <a:tailEnd type="none" w="med" len="med"/>
+                    </a:lnT>
+                    <a:lnB w="9525" cap="flat" cmpd="sng" algn="ctr">
+                      <a:solidFill>
+                        <a:srgbClr val="D5DDE3"/>
+                      </a:solidFill>
+                      <a:prstDash val="solid"/>
+                      <a:round/>
+                      <a:headEnd type="none" w="med" len="med"/>
+                      <a:tailEnd type="none" w="med" len="med"/>
+                    </a:lnB>
+                  </a:tcPr>
+                </a:tc>
+                <a:tc>
+                  <a:txBody>
+                    <a:bodyPr/>
+                    <a:lstStyle/>
+                    <a:p>
+                      <a:pPr algn="ctr" indent="0" marL="0">
+                        <a:buNone/>
+                      </a:pPr>
+                      <a:r>
+                        <a:rPr lang="en-US" sz="1300" dirty="0">
+                          <a:solidFill>
+                            <a:srgbClr val="1B2A38"/>
+                          </a:solidFill>
+                          <a:latin typeface="Calibri" pitchFamily="34" charset="0"/>
+                          <a:ea typeface="Calibri" pitchFamily="34" charset="-122"/>
+                          <a:cs typeface="Calibri" pitchFamily="34" charset="-120"/>
+                        </a:rPr>
+                        <a:t>0.959</a:t>
+                      </a:r>
+                      <a:endParaRPr lang="en-US" sz="1300" dirty="0">
+                        <a:latin typeface="Calibri" charset="0"/>
+                        <a:ea typeface="Calibri" charset="0"/>
+                        <a:cs typeface="Calibri" charset="0"/>
+                      </a:endParaRPr>
+                    </a:p>
+                  </a:txBody>
+                  <a:tcPr marL="91440" marR="91440" marT="45720" marB="45720">
+                    <a:lnL w="9525" cap="flat" cmpd="sng" algn="ctr">
+                      <a:solidFill>
+                        <a:srgbClr val="D5DDE3"/>
+                      </a:solidFill>
+                      <a:prstDash val="solid"/>
+                      <a:round/>
+                      <a:headEnd type="none" w="med" len="med"/>
+                      <a:tailEnd type="none" w="med" len="med"/>
+                    </a:lnL>
+                    <a:lnR w="9525" cap="flat" cmpd="sng" algn="ctr">
+                      <a:solidFill>
+                        <a:srgbClr val="D5DDE3"/>
+                      </a:solidFill>
+                      <a:prstDash val="solid"/>
+                      <a:round/>
+                      <a:headEnd type="none" w="med" len="med"/>
+                      <a:tailEnd type="none" w="med" len="med"/>
+                    </a:lnR>
+                    <a:lnT w="9525" cap="flat" cmpd="sng" algn="ctr">
+                      <a:solidFill>
+                        <a:srgbClr val="D5DDE3"/>
+                      </a:solidFill>
+                      <a:prstDash val="solid"/>
+                      <a:round/>
+                      <a:headEnd type="none" w="med" len="med"/>
+                      <a:tailEnd type="none" w="med" len="med"/>
+                    </a:lnT>
+                    <a:lnB w="9525" cap="flat" cmpd="sng" algn="ctr">
+                      <a:solidFill>
+                        <a:srgbClr val="D5DDE3"/>
+                      </a:solidFill>
+                      <a:prstDash val="solid"/>
+                      <a:round/>
+                      <a:headEnd type="none" w="med" len="med"/>
+                      <a:tailEnd type="none" w="med" len="med"/>
+                    </a:lnB>
+                  </a:tcPr>
+                </a:tc>
+                <a:tc>
+                  <a:txBody>
+                    <a:bodyPr/>
+                    <a:lstStyle/>
+                    <a:p>
+                      <a:pPr algn="ctr" indent="0" marL="0">
+                        <a:buNone/>
+                      </a:pPr>
+                      <a:r>
+                        <a:rPr lang="en-US" sz="1300" dirty="0">
+                          <a:solidFill>
+                            <a:srgbClr val="1B2A38"/>
+                          </a:solidFill>
+                          <a:latin typeface="Calibri" pitchFamily="34" charset="0"/>
+                          <a:ea typeface="Calibri" pitchFamily="34" charset="-122"/>
+                          <a:cs typeface="Calibri" pitchFamily="34" charset="-120"/>
+                        </a:rPr>
+                        <a:t>0.973</a:t>
+                      </a:r>
+                      <a:endParaRPr lang="en-US" sz="1300" dirty="0">
+                        <a:latin typeface="Calibri" charset="0"/>
+                        <a:ea typeface="Calibri" charset="0"/>
+                        <a:cs typeface="Calibri" charset="0"/>
+                      </a:endParaRPr>
+                    </a:p>
+                  </a:txBody>
+                  <a:tcPr marL="91440" marR="91440" marT="45720" marB="45720">
+                    <a:lnL w="9525" cap="flat" cmpd="sng" algn="ctr">
+                      <a:solidFill>
+                        <a:srgbClr val="D5DDE3"/>
+                      </a:solidFill>
+                      <a:prstDash val="solid"/>
+                      <a:round/>
+                      <a:headEnd type="none" w="med" len="med"/>
+                      <a:tailEnd type="none" w="med" len="med"/>
+                    </a:lnL>
+                    <a:lnR w="9525" cap="flat" cmpd="sng" algn="ctr">
+                      <a:solidFill>
+                        <a:srgbClr val="D5DDE3"/>
+                      </a:solidFill>
+                      <a:prstDash val="solid"/>
+                      <a:round/>
+                      <a:headEnd type="none" w="med" len="med"/>
+                      <a:tailEnd type="none" w="med" len="med"/>
+                    </a:lnR>
+                    <a:lnT w="9525" cap="flat" cmpd="sng" algn="ctr">
+                      <a:solidFill>
+                        <a:srgbClr val="D5DDE3"/>
+                      </a:solidFill>
+                      <a:prstDash val="solid"/>
+                      <a:round/>
+                      <a:headEnd type="none" w="med" len="med"/>
+                      <a:tailEnd type="none" w="med" len="med"/>
+                    </a:lnT>
+                    <a:lnB w="9525" cap="flat" cmpd="sng" algn="ctr">
+                      <a:solidFill>
+                        <a:srgbClr val="D5DDE3"/>
+                      </a:solidFill>
+                      <a:prstDash val="solid"/>
+                      <a:round/>
+                      <a:headEnd type="none" w="med" len="med"/>
+                      <a:tailEnd type="none" w="med" len="med"/>
+                    </a:lnB>
+                  </a:tcPr>
+                </a:tc>
+                <a:tc>
+                  <a:txBody>
+                    <a:bodyPr/>
+                    <a:lstStyle/>
+                    <a:p>
+                      <a:pPr algn="ctr" indent="0" marL="0">
+                        <a:buNone/>
+                      </a:pPr>
+                      <a:r>
+                        <a:rPr lang="en-US" sz="1300" dirty="0">
+                          <a:solidFill>
+                            <a:srgbClr val="1B2A38"/>
+                          </a:solidFill>
+                          <a:latin typeface="Calibri" pitchFamily="34" charset="0"/>
+                          <a:ea typeface="Calibri" pitchFamily="34" charset="-122"/>
+                          <a:cs typeface="Calibri" pitchFamily="34" charset="-120"/>
+                        </a:rPr>
+                        <a:t>0.5%</a:t>
+                      </a:r>
+                      <a:endParaRPr lang="en-US" sz="1300" dirty="0">
+                        <a:latin typeface="Calibri" charset="0"/>
+                        <a:ea typeface="Calibri" charset="0"/>
+                        <a:cs typeface="Calibri" charset="0"/>
+                      </a:endParaRPr>
+                    </a:p>
+                  </a:txBody>
+                  <a:tcPr marL="91440" marR="91440" marT="45720" marB="45720">
+                    <a:lnL w="9525" cap="flat" cmpd="sng" algn="ctr">
+                      <a:solidFill>
+                        <a:srgbClr val="D5DDE3"/>
+                      </a:solidFill>
+                      <a:prstDash val="solid"/>
+                      <a:round/>
+                      <a:headEnd type="none" w="med" len="med"/>
+                      <a:tailEnd type="none" w="med" len="med"/>
+                    </a:lnL>
+                    <a:lnR w="9525" cap="flat" cmpd="sng" algn="ctr">
+                      <a:solidFill>
+                        <a:srgbClr val="D5DDE3"/>
+                      </a:solidFill>
+                      <a:prstDash val="solid"/>
+                      <a:round/>
+                      <a:headEnd type="none" w="med" len="med"/>
+                      <a:tailEnd type="none" w="med" len="med"/>
+                    </a:lnR>
+                    <a:lnT w="9525" cap="flat" cmpd="sng" algn="ctr">
+                      <a:solidFill>
+                        <a:srgbClr val="D5DDE3"/>
+                      </a:solidFill>
+                      <a:prstDash val="solid"/>
+                      <a:round/>
+                      <a:headEnd type="none" w="med" len="med"/>
+                      <a:tailEnd type="none" w="med" len="med"/>
+                    </a:lnT>
+                    <a:lnB w="9525" cap="flat" cmpd="sng" algn="ctr">
+                      <a:solidFill>
+                        <a:srgbClr val="D5DDE3"/>
+                      </a:solidFill>
+                      <a:prstDash val="solid"/>
+                      <a:round/>
+                      <a:headEnd type="none" w="med" len="med"/>
+                      <a:tailEnd type="none" w="med" len="med"/>
+                    </a:lnB>
+                  </a:tcPr>
+                </a:tc>
+              </a:tr>
+              <a:tr h="384048">
+                <a:tc>
+                  <a:txBody>
+                    <a:bodyPr/>
+                    <a:lstStyle/>
+                    <a:p>
+                      <a:pPr algn="l" indent="0" marL="0">
+                        <a:buNone/>
+                      </a:pPr>
+                      <a:r>
+                        <a:rPr lang="en-US" sz="1300" dirty="0">
+                          <a:solidFill>
+                            <a:srgbClr val="1B2A38"/>
+                          </a:solidFill>
+                          <a:latin typeface="Calibri" pitchFamily="34" charset="0"/>
+                          <a:ea typeface="Calibri" pitchFamily="34" charset="-122"/>
+                          <a:cs typeface="Calibri" pitchFamily="34" charset="-120"/>
+                        </a:rPr>
+                        <a:t>Full model</a:t>
+                      </a:r>
+                      <a:endParaRPr lang="en-US" sz="1300" dirty="0">
+                        <a:latin typeface="Calibri" charset="0"/>
+                        <a:ea typeface="Calibri" charset="0"/>
+                        <a:cs typeface="Calibri" charset="0"/>
+                      </a:endParaRPr>
+                    </a:p>
+                  </a:txBody>
+                  <a:tcPr marL="91440" marR="91440" marT="45720" marB="45720">
+                    <a:lnL w="9525" cap="flat" cmpd="sng" algn="ctr">
+                      <a:solidFill>
+                        <a:srgbClr val="D5DDE3"/>
+                      </a:solidFill>
+                      <a:prstDash val="solid"/>
+                      <a:round/>
+                      <a:headEnd type="none" w="med" len="med"/>
+                      <a:tailEnd type="none" w="med" len="med"/>
+                    </a:lnL>
+                    <a:lnR w="9525" cap="flat" cmpd="sng" algn="ctr">
+                      <a:solidFill>
+                        <a:srgbClr val="D5DDE3"/>
+                      </a:solidFill>
+                      <a:prstDash val="solid"/>
+                      <a:round/>
+                      <a:headEnd type="none" w="med" len="med"/>
+                      <a:tailEnd type="none" w="med" len="med"/>
+                    </a:lnR>
+                    <a:lnT w="9525" cap="flat" cmpd="sng" algn="ctr">
+                      <a:solidFill>
+                        <a:srgbClr val="D5DDE3"/>
+                      </a:solidFill>
+                      <a:prstDash val="solid"/>
+                      <a:round/>
+                      <a:headEnd type="none" w="med" len="med"/>
+                      <a:tailEnd type="none" w="med" len="med"/>
+                    </a:lnT>
+                    <a:lnB w="9525" cap="flat" cmpd="sng" algn="ctr">
+                      <a:solidFill>
+                        <a:srgbClr val="D5DDE3"/>
+                      </a:solidFill>
+                      <a:prstDash val="solid"/>
+                      <a:round/>
+                      <a:headEnd type="none" w="med" len="med"/>
+                      <a:tailEnd type="none" w="med" len="med"/>
+                    </a:lnB>
+                  </a:tcPr>
+                </a:tc>
+                <a:tc>
+                  <a:txBody>
+                    <a:bodyPr/>
+                    <a:lstStyle/>
+                    <a:p>
+                      <a:pPr algn="ctr" indent="0" marL="0">
+                        <a:buNone/>
+                      </a:pPr>
+                      <a:r>
+                        <a:rPr lang="en-US" sz="1300" b="1" dirty="0">
+                          <a:solidFill>
+                            <a:srgbClr val="1B2A38"/>
+                          </a:solidFill>
+                          <a:latin typeface="Calibri" pitchFamily="34" charset="0"/>
+                          <a:ea typeface="Calibri" pitchFamily="34" charset="-122"/>
+                          <a:cs typeface="Calibri" pitchFamily="34" charset="-120"/>
+                        </a:rPr>
+                        <a:t>0.989</a:t>
+                      </a:r>
+                      <a:endParaRPr lang="en-US" sz="1300" dirty="0">
+                        <a:latin typeface="Calibri" charset="0"/>
+                        <a:ea typeface="Calibri" charset="0"/>
+                        <a:cs typeface="Calibri" charset="0"/>
+                      </a:endParaRPr>
+                    </a:p>
+                  </a:txBody>
+                  <a:tcPr marL="91440" marR="91440" marT="45720" marB="45720">
+                    <a:lnL w="9525" cap="flat" cmpd="sng" algn="ctr">
+                      <a:solidFill>
+                        <a:srgbClr val="D5DDE3"/>
+                      </a:solidFill>
+                      <a:prstDash val="solid"/>
+                      <a:round/>
+                      <a:headEnd type="none" w="med" len="med"/>
+                      <a:tailEnd type="none" w="med" len="med"/>
+                    </a:lnL>
+                    <a:lnR w="9525" cap="flat" cmpd="sng" algn="ctr">
+                      <a:solidFill>
+                        <a:srgbClr val="D5DDE3"/>
+                      </a:solidFill>
+                      <a:prstDash val="solid"/>
+                      <a:round/>
+                      <a:headEnd type="none" w="med" len="med"/>
+                      <a:tailEnd type="none" w="med" len="med"/>
+                    </a:lnR>
+                    <a:lnT w="9525" cap="flat" cmpd="sng" algn="ctr">
+                      <a:solidFill>
+                        <a:srgbClr val="D5DDE3"/>
+                      </a:solidFill>
+                      <a:prstDash val="solid"/>
+                      <a:round/>
+                      <a:headEnd type="none" w="med" len="med"/>
+                      <a:tailEnd type="none" w="med" len="med"/>
+                    </a:lnT>
+                    <a:lnB w="9525" cap="flat" cmpd="sng" algn="ctr">
+                      <a:solidFill>
+                        <a:srgbClr val="D5DDE3"/>
+                      </a:solidFill>
+                      <a:prstDash val="solid"/>
+                      <a:round/>
+                      <a:headEnd type="none" w="med" len="med"/>
+                      <a:tailEnd type="none" w="med" len="med"/>
+                    </a:lnB>
+                  </a:tcPr>
+                </a:tc>
+                <a:tc>
+                  <a:txBody>
+                    <a:bodyPr/>
+                    <a:lstStyle/>
+                    <a:p>
+                      <a:pPr algn="ctr" indent="0" marL="0">
+                        <a:buNone/>
+                      </a:pPr>
+                      <a:r>
+                        <a:rPr lang="en-US" sz="1300" b="1" dirty="0">
+                          <a:solidFill>
+                            <a:srgbClr val="1B2A38"/>
+                          </a:solidFill>
+                          <a:latin typeface="Calibri" pitchFamily="34" charset="0"/>
+                          <a:ea typeface="Calibri" pitchFamily="34" charset="-122"/>
+                          <a:cs typeface="Calibri" pitchFamily="34" charset="-120"/>
+                        </a:rPr>
+                        <a:t>0.975</a:t>
+                      </a:r>
+                      <a:endParaRPr lang="en-US" sz="1300" dirty="0">
+                        <a:latin typeface="Calibri" charset="0"/>
+                        <a:ea typeface="Calibri" charset="0"/>
+                        <a:cs typeface="Calibri" charset="0"/>
+                      </a:endParaRPr>
+                    </a:p>
+                  </a:txBody>
+                  <a:tcPr marL="91440" marR="91440" marT="45720" marB="45720">
+                    <a:lnL w="9525" cap="flat" cmpd="sng" algn="ctr">
+                      <a:solidFill>
+                        <a:srgbClr val="D5DDE3"/>
+                      </a:solidFill>
+                      <a:prstDash val="solid"/>
+                      <a:round/>
+                      <a:headEnd type="none" w="med" len="med"/>
+                      <a:tailEnd type="none" w="med" len="med"/>
+                    </a:lnL>
+                    <a:lnR w="9525" cap="flat" cmpd="sng" algn="ctr">
+                      <a:solidFill>
+                        <a:srgbClr val="D5DDE3"/>
+                      </a:solidFill>
+                      <a:prstDash val="solid"/>
+                      <a:round/>
+                      <a:headEnd type="none" w="med" len="med"/>
+                      <a:tailEnd type="none" w="med" len="med"/>
+                    </a:lnR>
+                    <a:lnT w="9525" cap="flat" cmpd="sng" algn="ctr">
+                      <a:solidFill>
+                        <a:srgbClr val="D5DDE3"/>
+                      </a:solidFill>
+                      <a:prstDash val="solid"/>
+                      <a:round/>
+                      <a:headEnd type="none" w="med" len="med"/>
+                      <a:tailEnd type="none" w="med" len="med"/>
+                    </a:lnT>
+                    <a:lnB w="9525" cap="flat" cmpd="sng" algn="ctr">
+                      <a:solidFill>
+                        <a:srgbClr val="D5DDE3"/>
+                      </a:solidFill>
+                      <a:prstDash val="solid"/>
+                      <a:round/>
+                      <a:headEnd type="none" w="med" len="med"/>
+                      <a:tailEnd type="none" w="med" len="med"/>
+                    </a:lnB>
+                  </a:tcPr>
+                </a:tc>
+                <a:tc>
+                  <a:txBody>
+                    <a:bodyPr/>
+                    <a:lstStyle/>
+                    <a:p>
+                      <a:pPr algn="ctr" indent="0" marL="0">
+                        <a:buNone/>
+                      </a:pPr>
+                      <a:r>
+                        <a:rPr lang="en-US" sz="1300" b="1" dirty="0">
+                          <a:solidFill>
+                            <a:srgbClr val="1B2A38"/>
+                          </a:solidFill>
+                          <a:latin typeface="Calibri" pitchFamily="34" charset="0"/>
+                          <a:ea typeface="Calibri" pitchFamily="34" charset="-122"/>
+                          <a:cs typeface="Calibri" pitchFamily="34" charset="-120"/>
+                        </a:rPr>
+                        <a:t>0.982</a:t>
+                      </a:r>
+                      <a:endParaRPr lang="en-US" sz="1300" dirty="0">
+                        <a:latin typeface="Calibri" charset="0"/>
+                        <a:ea typeface="Calibri" charset="0"/>
+                        <a:cs typeface="Calibri" charset="0"/>
+                      </a:endParaRPr>
+                    </a:p>
+                  </a:txBody>
+                  <a:tcPr marL="91440" marR="91440" marT="45720" marB="45720">
+                    <a:lnL w="9525" cap="flat" cmpd="sng" algn="ctr">
+                      <a:solidFill>
+                        <a:srgbClr val="D5DDE3"/>
+                      </a:solidFill>
+                      <a:prstDash val="solid"/>
+                      <a:round/>
+                      <a:headEnd type="none" w="med" len="med"/>
+                      <a:tailEnd type="none" w="med" len="med"/>
+                    </a:lnL>
+                    <a:lnR w="9525" cap="flat" cmpd="sng" algn="ctr">
+                      <a:solidFill>
+                        <a:srgbClr val="D5DDE3"/>
+                      </a:solidFill>
+                      <a:prstDash val="solid"/>
+                      <a:round/>
+                      <a:headEnd type="none" w="med" len="med"/>
+                      <a:tailEnd type="none" w="med" len="med"/>
+                    </a:lnR>
+                    <a:lnT w="9525" cap="flat" cmpd="sng" algn="ctr">
+                      <a:solidFill>
+                        <a:srgbClr val="D5DDE3"/>
+                      </a:solidFill>
+                      <a:prstDash val="solid"/>
+                      <a:round/>
+                      <a:headEnd type="none" w="med" len="med"/>
+                      <a:tailEnd type="none" w="med" len="med"/>
+                    </a:lnT>
+                    <a:lnB w="9525" cap="flat" cmpd="sng" algn="ctr">
+                      <a:solidFill>
+                        <a:srgbClr val="D5DDE3"/>
+                      </a:solidFill>
+                      <a:prstDash val="solid"/>
+                      <a:round/>
+                      <a:headEnd type="none" w="med" len="med"/>
+                      <a:tailEnd type="none" w="med" len="med"/>
+                    </a:lnB>
+                  </a:tcPr>
+                </a:tc>
+                <a:tc>
+                  <a:txBody>
+                    <a:bodyPr/>
+                    <a:lstStyle/>
+                    <a:p>
+                      <a:pPr algn="ctr" indent="0" marL="0">
+                        <a:buNone/>
+                      </a:pPr>
+                      <a:r>
+                        <a:rPr lang="en-US" sz="1300" b="1" dirty="0">
+                          <a:solidFill>
+                            <a:srgbClr val="1B2A38"/>
+                          </a:solidFill>
+                          <a:latin typeface="Calibri" pitchFamily="34" charset="0"/>
+                          <a:ea typeface="Calibri" pitchFamily="34" charset="-122"/>
+                          <a:cs typeface="Calibri" pitchFamily="34" charset="-120"/>
+                        </a:rPr>
+                        <a:t>0.5%</a:t>
+                      </a:r>
+                      <a:endParaRPr lang="en-US" sz="1300" dirty="0">
+                        <a:latin typeface="Calibri" charset="0"/>
+                        <a:ea typeface="Calibri" charset="0"/>
+                        <a:cs typeface="Calibri" charset="0"/>
+                      </a:endParaRPr>
+                    </a:p>
+                  </a:txBody>
+                  <a:tcPr marL="91440" marR="91440" marT="45720" marB="45720">
+                    <a:lnL w="9525" cap="flat" cmpd="sng" algn="ctr">
+                      <a:solidFill>
+                        <a:srgbClr val="D5DDE3"/>
+                      </a:solidFill>
+                      <a:prstDash val="solid"/>
+                      <a:round/>
+                      <a:headEnd type="none" w="med" len="med"/>
+                      <a:tailEnd type="none" w="med" len="med"/>
+                    </a:lnL>
+                    <a:lnR w="9525" cap="flat" cmpd="sng" algn="ctr">
+                      <a:solidFill>
+                        <a:srgbClr val="D5DDE3"/>
+                      </a:solidFill>
+                      <a:prstDash val="solid"/>
+                      <a:round/>
+                      <a:headEnd type="none" w="med" len="med"/>
+                      <a:tailEnd type="none" w="med" len="med"/>
+                    </a:lnR>
+                    <a:lnT w="9525" cap="flat" cmpd="sng" algn="ctr">
+                      <a:solidFill>
+                        <a:srgbClr val="D5DDE3"/>
+                      </a:solidFill>
+                      <a:prstDash val="solid"/>
+                      <a:round/>
+                      <a:headEnd type="none" w="med" len="med"/>
+                      <a:tailEnd type="none" w="med" len="med"/>
+                    </a:lnT>
+                    <a:lnB w="9525" cap="flat" cmpd="sng" algn="ctr">
+                      <a:solidFill>
+                        <a:srgbClr val="D5DDE3"/>
+                      </a:solidFill>
+                      <a:prstDash val="solid"/>
+                      <a:round/>
+                      <a:headEnd type="none" w="med" len="med"/>
+                      <a:tailEnd type="none" w="med" len="med"/>
+                    </a:lnB>
+                  </a:tcPr>
+                </a:tc>
+              </a:tr>
+            </a:tbl>
+          </a:graphicData>
+        </a:graphic>
+      </p:graphicFrame>
+      <p:sp>
+        <p:nvSpPr>
+          <p:cNvPr id="4" name="Text 1"/>
+          <p:cNvSpPr txBox="1"/>
           <p:nvPr/>
         </p:nvSpPr>
         <p:spPr>
           <a:xfrm>
-            <a:off x="548640" y="1188720"/>
-            <a:ext cx="3840480" cy="2286000"/>
-          </a:xfrm>
-          <a:prstGeom prst="roundRect">
-            <a:avLst>
-              <a:gd name="adj" fmla="val 3200"/>
-            </a:avLst>
-          </a:prstGeom>
-          <a:solidFill>
-            <a:srgbClr val="EAF2F3"/>
-          </a:solidFill>
-          <a:ln w="12700">
-            <a:solidFill>
-              <a:srgbClr val="EAF2F3"/>
-            </a:solidFill>
-            <a:prstDash val="solid"/>
-          </a:ln>
-        </p:spPr>
-      </p:sp>
-      <p:sp>
-        <p:nvSpPr>
-          <p:cNvPr id="4" name="Text 2"/>
-          <p:cNvSpPr txBox="1"/>
-          <p:nvPr/>
-        </p:nvSpPr>
-        <p:spPr>
-          <a:xfrm>
-            <a:off x="731520" y="1325880"/>
-            <a:ext cx="3474720" cy="365760"/>
+            <a:off x="548640" y="2606040"/>
+            <a:ext cx="8046720" cy="320040"/>
           </a:xfrm>
           <a:prstGeom prst="rect">
             <a:avLst/>
@@ -3586,7 +5091,7 @@
               <a:buNone/>
             </a:pPr>
             <a:r>
-              <a:rPr lang="en-US" sz="1600" b="1" dirty="0">
+              <a:rPr lang="en-US" sz="1800" b="1" dirty="0">
                 <a:solidFill>
                   <a:srgbClr val="1C7C7D"/>
                 </a:solidFill>
@@ -3594,22 +5099,22 @@
                 <a:ea typeface="Cambria" pitchFamily="34" charset="-122"/>
                 <a:cs typeface="Cambria" pitchFamily="34" charset="-120"/>
               </a:rPr>
-              <a:t>1. Full metric set</a:t>
-            </a:r>
-            <a:endParaRPr lang="en-US" sz="1600" dirty="0"/>
-          </a:p>
-        </p:txBody>
-      </p:sp>
-      <p:sp>
-        <p:nvSpPr>
-          <p:cNvPr id="5" name="Text 3"/>
+              <a:t>Detection latency</a:t>
+            </a:r>
+            <a:endParaRPr lang="en-US" sz="1800" dirty="0"/>
+          </a:p>
+        </p:txBody>
+      </p:sp>
+      <p:sp>
+        <p:nvSpPr>
+          <p:cNvPr id="5" name="Text 2"/>
           <p:cNvSpPr txBox="1"/>
           <p:nvPr/>
         </p:nvSpPr>
         <p:spPr>
           <a:xfrm>
-            <a:off x="731520" y="1737360"/>
-            <a:ext cx="3474720" cy="1600200"/>
+            <a:off x="548640" y="2971800"/>
+            <a:ext cx="2560320" cy="640080"/>
           </a:xfrm>
           <a:prstGeom prst="rect">
             <a:avLst/>
@@ -3618,14 +5123,53 @@
           <a:ln/>
         </p:spPr>
         <p:txBody>
-          <a:bodyPr wrap="square" lIns="0" tIns="0" rIns="0" bIns="0" rtlCol="0" anchor="t"/>
+          <a:bodyPr wrap="square" lIns="0" tIns="0" rIns="0" bIns="0" rtlCol="0" anchor="ctr"/>
           <a:lstStyle/>
           <a:p>
             <a:pPr indent="0" marL="0">
               <a:buNone/>
             </a:pPr>
             <a:r>
-              <a:rPr lang="en-US" sz="1400" dirty="0">
+              <a:rPr lang="en-US" sz="3600" b="1" dirty="0">
+                <a:solidFill>
+                  <a:srgbClr val="0B1F33"/>
+                </a:solidFill>
+                <a:latin typeface="Cambria" pitchFamily="34" charset="0"/>
+                <a:ea typeface="Cambria" pitchFamily="34" charset="-122"/>
+                <a:cs typeface="Cambria" pitchFamily="34" charset="-120"/>
+              </a:rPr>
+              <a:t>0.15 s</a:t>
+            </a:r>
+            <a:endParaRPr lang="en-US" sz="3600" dirty="0"/>
+          </a:p>
+        </p:txBody>
+      </p:sp>
+      <p:sp>
+        <p:nvSpPr>
+          <p:cNvPr id="6" name="Text 3"/>
+          <p:cNvSpPr txBox="1"/>
+          <p:nvPr/>
+        </p:nvSpPr>
+        <p:spPr>
+          <a:xfrm>
+            <a:off x="548640" y="3611880"/>
+            <a:ext cx="2468880" cy="640080"/>
+          </a:xfrm>
+          <a:prstGeom prst="rect">
+            <a:avLst/>
+          </a:prstGeom>
+          <a:noFill/>
+          <a:ln/>
+        </p:spPr>
+        <p:txBody>
+          <a:bodyPr wrap="square" lIns="0" tIns="0" rIns="0" bIns="0" rtlCol="0" anchor="t"/>
+          <a:lstStyle/>
+          <a:p>
+            <a:pPr indent="0" marL="0">
+              <a:buNone/>
+            </a:pPr>
+            <a:r>
+              <a:rPr lang="en-US" sz="1200" dirty="0">
                 <a:solidFill>
                   <a:srgbClr val="1B2A38"/>
                 </a:solidFill>
@@ -3633,49 +5177,22 @@
                 <a:ea typeface="Calibri" pitchFamily="34" charset="-122"/>
                 <a:cs typeface="Calibri" pitchFamily="34" charset="-120"/>
               </a:rPr>
-              <a:t>Precision, recall, F1, false-positive rate and detection latency (seconds to first alarm). Evaluation is running now.</a:t>
-            </a:r>
-            <a:endParaRPr lang="en-US" sz="1400" dirty="0"/>
-          </a:p>
-        </p:txBody>
-      </p:sp>
-      <p:sp>
-        <p:nvSpPr>
-          <p:cNvPr id="6" name="card"/>
-          <p:cNvSpPr/>
+              <a:t>mean time to first alarm, full model (baseline 0.70 s)</a:t>
+            </a:r>
+            <a:endParaRPr lang="en-US" sz="1200" dirty="0"/>
+          </a:p>
+        </p:txBody>
+      </p:sp>
+      <p:sp>
+        <p:nvSpPr>
+          <p:cNvPr id="7" name="Text 4"/>
+          <p:cNvSpPr txBox="1"/>
           <p:nvPr/>
         </p:nvSpPr>
         <p:spPr>
           <a:xfrm>
-            <a:off x="4754880" y="1188720"/>
-            <a:ext cx="3840480" cy="2286000"/>
-          </a:xfrm>
-          <a:prstGeom prst="roundRect">
-            <a:avLst>
-              <a:gd name="adj" fmla="val 3200"/>
-            </a:avLst>
-          </a:prstGeom>
-          <a:solidFill>
-            <a:srgbClr val="EAF2F3"/>
-          </a:solidFill>
-          <a:ln w="12700">
-            <a:solidFill>
-              <a:srgbClr val="EAF2F3"/>
-            </a:solidFill>
-            <a:prstDash val="solid"/>
-          </a:ln>
-        </p:spPr>
-      </p:sp>
-      <p:sp>
-        <p:nvSpPr>
-          <p:cNvPr id="7" name="Text 5"/>
-          <p:cNvSpPr txBox="1"/>
-          <p:nvPr/>
-        </p:nvSpPr>
-        <p:spPr>
-          <a:xfrm>
-            <a:off x="4937760" y="1325880"/>
-            <a:ext cx="3474720" cy="365760"/>
+            <a:off x="3291840" y="2971800"/>
+            <a:ext cx="2560320" cy="640080"/>
           </a:xfrm>
           <a:prstGeom prst="rect">
             <a:avLst/>
@@ -3691,30 +5208,30 @@
               <a:buNone/>
             </a:pPr>
             <a:r>
-              <a:rPr lang="en-US" sz="1600" b="1" dirty="0">
+              <a:rPr lang="en-US" sz="3600" b="1" dirty="0">
                 <a:solidFill>
-                  <a:srgbClr val="1C7C7D"/>
+                  <a:srgbClr val="0B1F33"/>
                 </a:solidFill>
                 <a:latin typeface="Cambria" pitchFamily="34" charset="0"/>
                 <a:ea typeface="Cambria" pitchFamily="34" charset="-122"/>
                 <a:cs typeface="Cambria" pitchFamily="34" charset="-120"/>
               </a:rPr>
-              <a:t>2. Malicious neighbours</a:t>
-            </a:r>
-            <a:endParaRPr lang="en-US" sz="1600" dirty="0"/>
-          </a:p>
-        </p:txBody>
-      </p:sp>
-      <p:sp>
-        <p:nvSpPr>
-          <p:cNvPr id="8" name="Text 6"/>
+              <a:t>99%</a:t>
+            </a:r>
+            <a:endParaRPr lang="en-US" sz="3600" dirty="0"/>
+          </a:p>
+        </p:txBody>
+      </p:sp>
+      <p:sp>
+        <p:nvSpPr>
+          <p:cNvPr id="8" name="Text 5"/>
           <p:cNvSpPr txBox="1"/>
           <p:nvPr/>
         </p:nvSpPr>
         <p:spPr>
           <a:xfrm>
-            <a:off x="4937760" y="1737360"/>
-            <a:ext cx="3474720" cy="1600200"/>
+            <a:off x="3291840" y="3611880"/>
+            <a:ext cx="2468880" cy="640080"/>
           </a:xfrm>
           <a:prstGeom prst="rect">
             <a:avLst/>
@@ -3730,7 +5247,7 @@
               <a:buNone/>
             </a:pPr>
             <a:r>
-              <a:rPr lang="en-US" sz="1400" dirty="0">
+              <a:rPr lang="en-US" sz="1200" dirty="0">
                 <a:solidFill>
                   <a:srgbClr val="1B2A38"/>
                 </a:solidFill>
@@ -3738,22 +5255,22 @@
                 <a:ea typeface="Calibri" pitchFamily="34" charset="-122"/>
                 <a:cs typeface="Calibri" pitchFamily="34" charset="-120"/>
               </a:rPr>
-              <a:t>Results split by the share of neighbours that are themselves attackers: does the context get poisoned? Running now.</a:t>
-            </a:r>
-            <a:endParaRPr lang="en-US" sz="1400" dirty="0"/>
-          </a:p>
-        </p:txBody>
-      </p:sp>
-      <p:sp>
-        <p:nvSpPr>
-          <p:cNvPr id="9" name="Text 7"/>
+              <a:t>of malicious sender-receiver pairs eventually flagged (baseline 96%)</a:t>
+            </a:r>
+            <a:endParaRPr lang="en-US" sz="1200" dirty="0"/>
+          </a:p>
+        </p:txBody>
+      </p:sp>
+      <p:sp>
+        <p:nvSpPr>
+          <p:cNvPr id="9" name="Text 6"/>
           <p:cNvSpPr txBox="1"/>
           <p:nvPr/>
         </p:nvSpPr>
         <p:spPr>
           <a:xfrm>
-            <a:off x="548640" y="3749040"/>
-            <a:ext cx="8046720" cy="731520"/>
+            <a:off x="6035040" y="2971800"/>
+            <a:ext cx="2560320" cy="640080"/>
           </a:xfrm>
           <a:prstGeom prst="rect">
             <a:avLst/>
@@ -3769,7 +5286,85 @@
               <a:buNone/>
             </a:pPr>
             <a:r>
-              <a:rPr lang="en-US" sz="1400" i="1" dirty="0">
+              <a:rPr lang="en-US" sz="3600" b="1" dirty="0">
+                <a:solidFill>
+                  <a:srgbClr val="0B1F33"/>
+                </a:solidFill>
+                <a:latin typeface="Cambria" pitchFamily="34" charset="0"/>
+                <a:ea typeface="Cambria" pitchFamily="34" charset="-122"/>
+                <a:cs typeface="Cambria" pitchFamily="34" charset="-120"/>
+              </a:rPr>
+              <a:t>0 s</a:t>
+            </a:r>
+            <a:endParaRPr lang="en-US" sz="3600" dirty="0"/>
+          </a:p>
+        </p:txBody>
+      </p:sp>
+      <p:sp>
+        <p:nvSpPr>
+          <p:cNvPr id="10" name="Text 7"/>
+          <p:cNvSpPr txBox="1"/>
+          <p:nvPr/>
+        </p:nvSpPr>
+        <p:spPr>
+          <a:xfrm>
+            <a:off x="6035040" y="3611880"/>
+            <a:ext cx="2468880" cy="640080"/>
+          </a:xfrm>
+          <a:prstGeom prst="rect">
+            <a:avLst/>
+          </a:prstGeom>
+          <a:noFill/>
+          <a:ln/>
+        </p:spPr>
+        <p:txBody>
+          <a:bodyPr wrap="square" lIns="0" tIns="0" rIns="0" bIns="0" rtlCol="0" anchor="t"/>
+          <a:lstStyle/>
+          <a:p>
+            <a:pPr indent="0" marL="0">
+              <a:buNone/>
+            </a:pPr>
+            <a:r>
+              <a:rPr lang="en-US" sz="1200" dirty="0">
+                <a:solidFill>
+                  <a:srgbClr val="1B2A38"/>
+                </a:solidFill>
+                <a:latin typeface="Calibri" pitchFamily="34" charset="0"/>
+                <a:ea typeface="Calibri" pitchFamily="34" charset="-122"/>
+                <a:cs typeface="Calibri" pitchFamily="34" charset="-120"/>
+              </a:rPr>
+              <a:t>90th percentile for the full model (baseline 3 s)</a:t>
+            </a:r>
+            <a:endParaRPr lang="en-US" sz="1200" dirty="0"/>
+          </a:p>
+        </p:txBody>
+      </p:sp>
+      <p:sp>
+        <p:nvSpPr>
+          <p:cNvPr id="11" name="Text 8"/>
+          <p:cNvSpPr txBox="1"/>
+          <p:nvPr/>
+        </p:nvSpPr>
+        <p:spPr>
+          <a:xfrm>
+            <a:off x="548640" y="4389120"/>
+            <a:ext cx="8046720" cy="365760"/>
+          </a:xfrm>
+          <a:prstGeom prst="rect">
+            <a:avLst/>
+          </a:prstGeom>
+          <a:noFill/>
+          <a:ln/>
+        </p:spPr>
+        <p:txBody>
+          <a:bodyPr wrap="square" lIns="0" tIns="0" rIns="0" bIns="0" rtlCol="0" anchor="ctr"/>
+          <a:lstStyle/>
+          <a:p>
+            <a:pPr indent="0" marL="0">
+              <a:buNone/>
+            </a:pPr>
+            <a:r>
+              <a:rPr lang="en-US" sz="1100" i="1" dirty="0">
                 <a:solidFill>
                   <a:srgbClr val="5B6B7A"/>
                 </a:solidFill>
@@ -3777,9 +5372,9 @@
                 <a:ea typeface="Calibri" pitchFamily="34" charset="-122"/>
                 <a:cs typeface="Calibri" pitchFamily="34" charset="-120"/>
               </a:rPr>
-              <a:t>Scope note: VeReMi simulates false-data attacks, not crash intent, and attackers act independently (about 30%). Colluding attackers are not tested.</a:t>
-            </a:r>
-            <a:endParaRPr lang="en-US" sz="1400" dirty="0"/>
+              <a:t>Latency counts from the first window that contains the sender; each window needs about 10 s of history. Mean of 3 seeds.</a:t>
+            </a:r>
+            <a:endParaRPr lang="en-US" sz="1100" dirty="0"/>
           </a:p>
         </p:txBody>
       </p:sp>
@@ -3794,6 +5389,171 @@
 <file path=ppt/slides/slide7.xml><?xml version="1.0" encoding="utf-8"?>
 <p:sld xmlns:a="http://schemas.openxmlformats.org/drawingml/2006/main" xmlns:r="http://schemas.openxmlformats.org/officeDocument/2006/relationships" xmlns:p="http://schemas.openxmlformats.org/presentationml/2006/main">
   <p:cSld name="Slide 7">
+    <p:bg>
+      <p:bgPr>
+        <a:solidFill>
+          <a:srgbClr val="FFFFFF"/>
+        </a:solidFill>
+      </p:bgPr>
+    </p:bg>
+    <p:spTree>
+      <p:nvGrpSpPr>
+        <p:cNvPr id="1" name=""/>
+        <p:cNvGrpSpPr/>
+        <p:nvPr/>
+      </p:nvGrpSpPr>
+      <p:grpSpPr>
+        <a:xfrm>
+          <a:off x="0" y="0"/>
+          <a:ext cx="0" cy="0"/>
+          <a:chOff x="0" y="0"/>
+          <a:chExt cx="0" cy="0"/>
+        </a:xfrm>
+      </p:grpSpPr>
+      <p:sp>
+        <p:nvSpPr>
+          <p:cNvPr id="2" name="Text 0"/>
+          <p:cNvSpPr txBox="1"/>
+          <p:nvPr/>
+        </p:nvSpPr>
+        <p:spPr>
+          <a:xfrm>
+            <a:off x="548640" y="320040"/>
+            <a:ext cx="8046720" cy="640080"/>
+          </a:xfrm>
+          <a:prstGeom prst="rect">
+            <a:avLst/>
+          </a:prstGeom>
+          <a:noFill/>
+          <a:ln/>
+        </p:spPr>
+        <p:txBody>
+          <a:bodyPr wrap="square" lIns="0" tIns="0" rIns="0" bIns="0" rtlCol="0" anchor="ctr"/>
+          <a:lstStyle/>
+          <a:p>
+            <a:pPr indent="0" marL="0">
+              <a:buNone/>
+            </a:pPr>
+            <a:r>
+              <a:rPr lang="en-US" sz="3200" b="1" dirty="0">
+                <a:solidFill>
+                  <a:srgbClr val="0B1F33"/>
+                </a:solidFill>
+                <a:latin typeface="Cambria" pitchFamily="34" charset="0"/>
+                <a:ea typeface="Cambria" pitchFamily="34" charset="-122"/>
+                <a:cs typeface="Cambria" pitchFamily="34" charset="-120"/>
+              </a:rPr>
+              <a:t>When neighbours are malicious too</a:t>
+            </a:r>
+            <a:endParaRPr lang="en-US" sz="3200" dirty="0"/>
+          </a:p>
+        </p:txBody>
+      </p:sp>
+      <p:graphicFrame>
+        <p:nvGraphicFramePr>
+          <p:cNvPr id="3" name="Chart 0" descr=""/>
+          <p:cNvGraphicFramePr/>
+          <p:nvPr/>
+        </p:nvGraphicFramePr>
+        <p:xfrm>
+          <a:off x="457200" y="1051560"/>
+          <a:ext cx="5303520" cy="3383280"/>
+        </p:xfrm>
+        <a:graphic xmlns:a="http://schemas.openxmlformats.org/drawingml/2006/main">
+          <a:graphicData uri="http://schemas.openxmlformats.org/drawingml/2006/chart">
+            <c:chart xmlns:c="http://schemas.openxmlformats.org/drawingml/2006/chart" r:id="rId1"/>
+          </a:graphicData>
+        </a:graphic>
+      </p:graphicFrame>
+      <p:sp>
+        <p:nvSpPr>
+          <p:cNvPr id="4" name="Text 1"/>
+          <p:cNvSpPr txBox="1"/>
+          <p:nvPr/>
+        </p:nvSpPr>
+        <p:spPr>
+          <a:xfrm>
+            <a:off x="6035040" y="1188720"/>
+            <a:ext cx="2651760" cy="1737360"/>
+          </a:xfrm>
+          <a:prstGeom prst="rect">
+            <a:avLst/>
+          </a:prstGeom>
+          <a:noFill/>
+          <a:ln/>
+        </p:spPr>
+        <p:txBody>
+          <a:bodyPr wrap="square" lIns="0" tIns="0" rIns="0" bIns="0" rtlCol="0" anchor="t"/>
+          <a:lstStyle/>
+          <a:p>
+            <a:pPr indent="0" marL="0">
+              <a:buNone/>
+            </a:pPr>
+            <a:r>
+              <a:rPr lang="en-US" sz="1400" dirty="0">
+                <a:solidFill>
+                  <a:srgbClr val="1B2A38"/>
+                </a:solidFill>
+                <a:latin typeface="Calibri" pitchFamily="34" charset="0"/>
+                <a:ea typeface="Calibri" pitchFamily="34" charset="-122"/>
+                <a:cs typeface="Calibri" pitchFamily="34" charset="-120"/>
+              </a:rPr>
+              <a:t>Recall barely moves, and false alarms do not rise, even when over half of the neighbours are attackers (0.971 vs 0.973 for the cleanest case).</a:t>
+            </a:r>
+            <a:endParaRPr lang="en-US" sz="1400" dirty="0"/>
+          </a:p>
+        </p:txBody>
+      </p:sp>
+      <p:sp>
+        <p:nvSpPr>
+          <p:cNvPr id="5" name="Text 2"/>
+          <p:cNvSpPr txBox="1"/>
+          <p:nvPr/>
+        </p:nvSpPr>
+        <p:spPr>
+          <a:xfrm>
+            <a:off x="6035040" y="3108960"/>
+            <a:ext cx="2651760" cy="1280160"/>
+          </a:xfrm>
+          <a:prstGeom prst="rect">
+            <a:avLst/>
+          </a:prstGeom>
+          <a:noFill/>
+          <a:ln/>
+        </p:spPr>
+        <p:txBody>
+          <a:bodyPr wrap="square" lIns="0" tIns="0" rIns="0" bIns="0" rtlCol="0" anchor="t"/>
+          <a:lstStyle/>
+          <a:p>
+            <a:pPr indent="0" marL="0">
+              <a:buNone/>
+            </a:pPr>
+            <a:r>
+              <a:rPr lang="en-US" sz="1200" i="1" dirty="0">
+                <a:solidFill>
+                  <a:srgbClr val="5B6B7A"/>
+                </a:solidFill>
+                <a:latin typeface="Calibri" pitchFamily="34" charset="0"/>
+                <a:ea typeface="Calibri" pitchFamily="34" charset="-122"/>
+                <a:cs typeface="Calibri" pitchFamily="34" charset="-120"/>
+              </a:rPr>
+              <a:t>Caveat: attackers here act independently (about 30%). Colluding attackers, and crash intent, are not modelled in VeReMi.</a:t>
+            </a:r>
+            <a:endParaRPr lang="en-US" sz="1200" dirty="0"/>
+          </a:p>
+        </p:txBody>
+      </p:sp>
+    </p:spTree>
+  </p:cSld>
+  <p:clrMapOvr>
+    <a:masterClrMapping/>
+  </p:clrMapOvr>
+</p:sld>
+</file>
+
+<file path=ppt/slides/slide8.xml><?xml version="1.0" encoding="utf-8"?>
+<p:sld xmlns:a="http://schemas.openxmlformats.org/drawingml/2006/main" xmlns:r="http://schemas.openxmlformats.org/officeDocument/2006/relationships" xmlns:p="http://schemas.openxmlformats.org/presentationml/2006/main">
+  <p:cSld name="Slide 8">
     <p:bg>
       <p:bgPr>
         <a:solidFill>
@@ -3891,27 +5651,6 @@
                 <a:ea typeface="Calibri" pitchFamily="34" charset="-122"/>
                 <a:cs typeface="Calibri" pitchFamily="34" charset="-120"/>
               </a:rPr>
-              <a:t>Finish extended metrics and malicious-neighbour analysis</a:t>
-            </a:r>
-            <a:endParaRPr lang="en-US" sz="1800" dirty="0"/>
-          </a:p>
-          <a:p>
-            <a:pPr marL="342900" indent="-342900">
-              <a:spcAft>
-                <a:spcPts val="1000"/>
-              </a:spcAft>
-              <a:buSzPct val="100000"/>
-              <a:buChar char="•"/>
-            </a:pPr>
-            <a:r>
-              <a:rPr lang="en-US" sz="1800" dirty="0">
-                <a:solidFill>
-                  <a:srgbClr val="FFFFFF"/>
-                </a:solidFill>
-                <a:latin typeface="Calibri" pitchFamily="34" charset="0"/>
-                <a:ea typeface="Calibri" pitchFamily="34" charset="-122"/>
-                <a:cs typeface="Calibri" pitchFamily="34" charset="-120"/>
-              </a:rPr>
               <a:t>Add more attack types: position offsets, DoS, Sybil (2 of about 20 so far)</a:t>
             </a:r>
             <a:endParaRPr lang="en-US" sz="1800" dirty="0"/>
@@ -3954,7 +5693,7 @@
                 <a:ea typeface="Calibri" pitchFamily="34" charset="-122"/>
                 <a:cs typeface="Calibri" pitchFamily="34" charset="-120"/>
               </a:rPr>
-              <a:t>Optional: spoofed-approach test for the crash scenario</a:t>
+              <a:t>Test colluding attackers and the spoofed-approach (crash) scenario</a:t>
             </a:r>
             <a:endParaRPr lang="en-US" sz="1800" dirty="0"/>
           </a:p>

</xml_diff>

<commit_message>
Describe VeReMi Extension as a public simulated benchmark, not real-world data
Co-Authored-By: Claude Sonnet 5.5 <noreply@anthropic.com>
Claude-Session: https://claude.ai/code/session_01PXyVqdKG827WeN1ceWaNxA
</commit_message>
<xml_diff>
--- a/presentation/progress_update.pptx
+++ b/presentation/progress_update.pptx
@@ -2450,7 +2450,7 @@
                 <a:ea typeface="Calibri" pitchFamily="34" charset="-122"/>
                 <a:cs typeface="Calibri" pitchFamily="34" charset="-120"/>
               </a:rPr>
-              <a:t>Evaluated on real VeReMi Extension data</a:t>
+              <a:t>Evaluated on the public VeReMi Extension benchmark</a:t>
             </a:r>
             <a:endParaRPr lang="en-US" sz="1600" dirty="0"/>
           </a:p>
@@ -3189,7 +3189,7 @@
                 <a:ea typeface="Cambria" pitchFamily="34" charset="-122"/>
                 <a:cs typeface="Cambria" pitchFamily="34" charset="-120"/>
               </a:rPr>
-              <a:t>Real data</a:t>
+              <a:t>Benchmark data</a:t>
             </a:r>
             <a:endParaRPr lang="en-US" sz="1800" dirty="0"/>
           </a:p>
@@ -3228,7 +3228,7 @@
                 <a:ea typeface="Calibri" pitchFamily="34" charset="-122"/>
                 <a:cs typeface="Calibri" pitchFamily="34" charset="-120"/>
               </a:rPr>
-              <a:t>VeReMi Extension from Zenodo: RandomPos and ConstSpeed attacks</a:t>
+              <a:t>VeReMi Extension (simulated traffic) from Zenodo: RandomPos and ConstSpeed attacks</a:t>
             </a:r>
             <a:endParaRPr lang="en-US" sz="1400" dirty="0"/>
           </a:p>
@@ -3441,7 +3441,7 @@
                 <a:ea typeface="Cambria" pitchFamily="34" charset="-122"/>
                 <a:cs typeface="Cambria" pitchFamily="34" charset="-120"/>
               </a:rPr>
-              <a:t>Real-data results (F1)</a:t>
+              <a:t>Benchmark results (F1)</a:t>
             </a:r>
             <a:endParaRPr lang="en-US" sz="3200" dirty="0"/>
           </a:p>
@@ -5672,7 +5672,7 @@
                 <a:ea typeface="Calibri" pitchFamily="34" charset="-122"/>
                 <a:cs typeface="Calibri" pitchFamily="34" charset="-120"/>
               </a:rPr>
-              <a:t>Rerun domain-transfer experiment on real data</a:t>
+              <a:t>Rerun domain-transfer experiment on the benchmark</a:t>
             </a:r>
             <a:endParaRPr lang="en-US" sz="1800" dirty="0"/>
           </a:p>

</xml_diff>

<commit_message>
Label deck results as preliminary / work in progress
Co-Authored-By: Claude Sonnet 5.5 <noreply@anthropic.com>
Claude-Session: https://claude.ai/code/session_01PXyVqdKG827WeN1ceWaNxA
</commit_message>
<xml_diff>
--- a/presentation/progress_update.pptx
+++ b/presentation/progress_update.pptx
@@ -2411,7 +2411,7 @@
                 <a:ea typeface="Calibri" pitchFamily="34" charset="-122"/>
                 <a:cs typeface="Calibri" pitchFamily="34" charset="-120"/>
               </a:rPr>
-              <a:t>Project progress update: what is done, what is left</a:t>
+              <a:t>Work in progress: preliminary results and next steps</a:t>
             </a:r>
             <a:endParaRPr lang="en-US" sz="2000" dirty="0"/>
           </a:p>
@@ -2802,7 +2802,7 @@
                 <a:ea typeface="Cambria" pitchFamily="34" charset="-122"/>
                 <a:cs typeface="Cambria" pitchFamily="34" charset="-120"/>
               </a:rPr>
-              <a:t>What is done</a:t>
+              <a:t>What is done so far</a:t>
             </a:r>
             <a:endParaRPr lang="en-US" sz="3200" dirty="0"/>
           </a:p>
@@ -3441,7 +3441,7 @@
                 <a:ea typeface="Cambria" pitchFamily="34" charset="-122"/>
                 <a:cs typeface="Cambria" pitchFamily="34" charset="-120"/>
               </a:rPr>
-              <a:t>Benchmark results (F1)</a:t>
+              <a:t>Preliminary results (F1)</a:t>
             </a:r>
             <a:endParaRPr lang="en-US" sz="3200" dirty="0"/>
           </a:p>
@@ -4031,7 +4031,7 @@
                 <a:ea typeface="Cambria" pitchFamily="34" charset="-122"/>
                 <a:cs typeface="Cambria" pitchFamily="34" charset="-120"/>
               </a:rPr>
-              <a:t>Full metric set and detection latency</a:t>
+              <a:t>Preliminary: full metrics and latency</a:t>
             </a:r>
             <a:endParaRPr lang="en-US" sz="3200" dirty="0"/>
           </a:p>

</xml_diff>

<commit_message>
Add Sybil attacks: 18 of 19 attack types, pseudonym tracking, identity features
- loader tracks senders by pseudonym (what a receiver sees); labels from the
  true vehicle; identity age (chained across pseudonym changes), handover
  distance and lockstep inputs -> 22 inputs; windows of the 14 original
  attacks are unchanged
- label_active: ground truth keyed by vehicle; DoS Sybil variants count as
  active (FLOOD_EXTRA=18,19)
- training robustness: models saved before scoring, per-epoch checkpoints
  (EPOCH_CKPT), configurable width/depth (MODEL_D, MODEL_L)
- results: 18-attack 3-model ensemble, message labels P 96.30 R 95.46
  F1 95.88 Acc 97.04 (vehicle F1 95.38); GridSybil recall 0.82 is the weak
  spot; neighbour attention about +1.3 F1 on 18 attacks
- paper: Sybil extension section and table (6 pages, fact-checked);
  README, HANDOFF, deck, blueprint, worksheet, plan and literature table
  updated

Co-Authored-By: Claude Opus 5.5 <noreply@anthropic.com>
</commit_message>
<xml_diff>
--- a/presentation/progress_update.pptx
+++ b/presentation/progress_update.pptx
@@ -14,9 +14,10 @@
     <p:sldId id="262" r:id="rId8"/>
     <p:sldId id="263" r:id="rId9"/>
     <p:sldId id="264" r:id="rId10"/>
+    <p:sldId id="265" r:id="rId11"/>
   </p:sldIdLst>
   <p:notesMasterIdLst>
-    <p:notesMasterId r:id="rId11"/>
+    <p:notesMasterId r:id="rId12"/>
   </p:notesMasterIdLst>
   <p:sldSz cx="9144000" cy="5143500"/>
   <p:notesSz cx="5143500" cy="9144000"/>
@@ -908,6 +909,94 @@
 </p:notes>
 </file>
 
+<file path=ppt/notesSlides/notesSlide10.xml><?xml version="1.0" encoding="utf-8"?>
+<p:notes xmlns:a="http://schemas.openxmlformats.org/drawingml/2006/main" xmlns:r="http://schemas.openxmlformats.org/officeDocument/2006/relationships" xmlns:p="http://schemas.openxmlformats.org/presentationml/2006/main">
+  <p:cSld>
+    <p:spTree>
+      <p:nvGrpSpPr>
+        <p:cNvPr id="1" name=""/>
+        <p:cNvGrpSpPr/>
+        <p:nvPr/>
+      </p:nvGrpSpPr>
+      <p:grpSpPr>
+        <a:xfrm>
+          <a:off x="0" y="0"/>
+          <a:ext cx="0" cy="0"/>
+          <a:chOff x="0" y="0"/>
+          <a:chExt cx="0" cy="0"/>
+        </a:xfrm>
+      </p:grpSpPr>
+      <p:sp>
+        <p:nvSpPr>
+          <p:cNvPr id="2" name="Slide Image Placeholder 1"/>
+          <p:cNvSpPr>
+            <a:spLocks noGrp="1" noRot="1" noChangeAspect="1"/>
+          </p:cNvSpPr>
+          <p:nvPr>
+            <p:ph type="sldImg"/>
+          </p:nvPr>
+        </p:nvSpPr>
+        <p:spPr/>
+      </p:sp>
+      <p:sp>
+        <p:nvSpPr>
+          <p:cNvPr id="3" name="Notes Placeholder 2"/>
+          <p:cNvSpPr>
+            <a:spLocks noGrp="1"/>
+          </p:cNvSpPr>
+          <p:nvPr>
+            <p:ph type="body" idx="1"/>
+          </p:nvPr>
+        </p:nvSpPr>
+        <p:spPr/>
+        <p:txBody>
+          <a:bodyPr/>
+          <a:lstStyle/>
+          <a:p>
+            <a:r>
+              <a:rPr lang="en-US" dirty="0"/>
+              <a:t/>
+            </a:r>
+            <a:endParaRPr lang="en-US" dirty="0"/>
+          </a:p>
+        </p:txBody>
+      </p:sp>
+      <p:sp>
+        <p:nvSpPr>
+          <p:cNvPr id="4" name="Slide Number Placeholder 3"/>
+          <p:cNvSpPr>
+            <a:spLocks noGrp="1"/>
+          </p:cNvSpPr>
+          <p:nvPr>
+            <p:ph type="sldNum" sz="quarter" idx="10"/>
+          </p:nvPr>
+        </p:nvSpPr>
+        <p:spPr/>
+        <p:txBody>
+          <a:bodyPr/>
+          <a:lstStyle/>
+          <a:p>
+            <a:fld id="{F7021451-1387-4CA6-816F-3879F97B5CBC}" type="slidenum">
+              <a:rPr lang="en-US"/>
+              <a:t>10</a:t>
+            </a:fld>
+            <a:endParaRPr lang="en-US"/>
+          </a:p>
+        </p:txBody>
+      </p:sp>
+    </p:spTree>
+    <p:extLst>
+      <p:ext uri="{BB962C8B-B14F-4D97-AF65-F5344CB8AC3E}">
+        <p14:creationId xmlns:p14="http://schemas.microsoft.com/office/powerpoint/2010/main" val="1024086991"/>
+      </p:ext>
+    </p:extLst>
+  </p:cSld>
+  <p:clrMapOvr>
+    <a:masterClrMapping/>
+  </p:clrMapOvr>
+</p:notes>
+</file>
+
 <file path=ppt/notesSlides/notesSlide2.xml><?xml version="1.0" encoding="utf-8"?>
 <p:notes xmlns:a="http://schemas.openxmlformats.org/drawingml/2006/main" xmlns:r="http://schemas.openxmlformats.org/officeDocument/2006/relationships" xmlns:p="http://schemas.openxmlformats.org/presentationml/2006/main">
   <p:cSld>
@@ -1482,7 +1571,7 @@
           <a:p>
             <a:r>
               <a:rPr lang="en-US" dirty="0"/>
-              <a:t>Report the comparison with its caveat; do not claim we beat the reference outright.</a:t>
+              <a:t>Report the comparison with its caveat; do not claim we beat the reference outright. This chart is the 14-attack system; on 18 attacks (with Sybil) all four numbers are below 97.37, see next slide.</a:t>
             </a:r>
             <a:endParaRPr lang="en-US" dirty="0"/>
           </a:p>
@@ -1570,7 +1659,7 @@
           <a:p>
             <a:r>
               <a:rPr lang="en-US" dirty="0"/>
-              <a:t/>
+              <a:t>The 14-attack results are unchanged. Sybil makes the task harder: fake identities are separate senders. On the 14 original attack runs this model's FPR is 1.6% (vs 0.6% for the 14-attack model) because it lowers its threshold to catch ghosts. A bigger model alone and receiver memory did not help.</a:t>
             </a:r>
             <a:endParaRPr lang="en-US" dirty="0"/>
           </a:p>
@@ -2015,7 +2104,7 @@
                 <a:ea typeface="Calibri" pitchFamily="34" charset="-122"/>
                 <a:cs typeface="Calibri" pitchFamily="34" charset="-120"/>
               </a:rPr>
-              <a:t>Final results on 14 attack types</a:t>
+              <a:t>Final results on 14 attack types, extended to 18 with Sybil</a:t>
             </a:r>
             <a:endParaRPr lang="en-US" sz="2000" dirty="0"/>
           </a:p>
@@ -2057,6 +2146,204 @@
               <a:t>Evaluated on the VeReMi Extension benchmark (simulated traffic, Zenodo 20090854)</a:t>
             </a:r>
             <a:endParaRPr lang="en-US" sz="1500" dirty="0"/>
+          </a:p>
+        </p:txBody>
+      </p:sp>
+    </p:spTree>
+  </p:cSld>
+  <p:clrMapOvr>
+    <a:masterClrMapping/>
+  </p:clrMapOvr>
+</p:sld>
+</file>
+
+<file path=ppt/slides/slide10.xml><?xml version="1.0" encoding="utf-8"?>
+<p:sld xmlns:a="http://schemas.openxmlformats.org/drawingml/2006/main" xmlns:r="http://schemas.openxmlformats.org/officeDocument/2006/relationships" xmlns:p="http://schemas.openxmlformats.org/presentationml/2006/main">
+  <p:cSld name="Slide 10">
+    <p:bg>
+      <p:bgPr>
+        <a:solidFill>
+          <a:srgbClr val="0B1F33"/>
+        </a:solidFill>
+      </p:bgPr>
+    </p:bg>
+    <p:spTree>
+      <p:nvGrpSpPr>
+        <p:cNvPr id="1" name=""/>
+        <p:cNvGrpSpPr/>
+        <p:nvPr/>
+      </p:nvGrpSpPr>
+      <p:grpSpPr>
+        <a:xfrm>
+          <a:off x="0" y="0"/>
+          <a:ext cx="0" cy="0"/>
+          <a:chOff x="0" y="0"/>
+          <a:chExt cx="0" cy="0"/>
+        </a:xfrm>
+      </p:grpSpPr>
+      <p:sp>
+        <p:nvSpPr>
+          <p:cNvPr id="2" name="Text 0"/>
+          <p:cNvSpPr txBox="1"/>
+          <p:nvPr/>
+        </p:nvSpPr>
+        <p:spPr>
+          <a:xfrm>
+            <a:off x="548640" y="320040"/>
+            <a:ext cx="8046720" cy="640080"/>
+          </a:xfrm>
+          <a:prstGeom prst="rect">
+            <a:avLst/>
+          </a:prstGeom>
+          <a:noFill/>
+          <a:ln/>
+        </p:spPr>
+        <p:txBody>
+          <a:bodyPr wrap="square" lIns="0" tIns="0" rIns="0" bIns="0" rtlCol="0" anchor="ctr"/>
+          <a:lstStyle/>
+          <a:p>
+            <a:pPr indent="0" marL="0">
+              <a:buNone/>
+            </a:pPr>
+            <a:r>
+              <a:rPr lang="en-US" sz="3000" b="1" dirty="0">
+                <a:solidFill>
+                  <a:srgbClr val="FFFFFF"/>
+                </a:solidFill>
+                <a:latin typeface="Cambria" pitchFamily="34" charset="0"/>
+                <a:ea typeface="Cambria" pitchFamily="34" charset="-122"/>
+                <a:cs typeface="Cambria" pitchFamily="34" charset="-120"/>
+              </a:rPr>
+              <a:t>Open items and next steps</a:t>
+            </a:r>
+            <a:endParaRPr lang="en-US" sz="3000" dirty="0"/>
+          </a:p>
+        </p:txBody>
+      </p:sp>
+      <p:sp>
+        <p:nvSpPr>
+          <p:cNvPr id="3" name="Text 1"/>
+          <p:cNvSpPr txBox="1"/>
+          <p:nvPr/>
+        </p:nvSpPr>
+        <p:spPr>
+          <a:xfrm>
+            <a:off x="548640" y="1188720"/>
+            <a:ext cx="8046720" cy="3291840"/>
+          </a:xfrm>
+          <a:prstGeom prst="rect">
+            <a:avLst/>
+          </a:prstGeom>
+          <a:noFill/>
+          <a:ln/>
+        </p:spPr>
+        <p:txBody>
+          <a:bodyPr wrap="square" lIns="0" tIns="0" rIns="0" bIns="0" rtlCol="0" anchor="t"/>
+          <a:lstStyle/>
+          <a:p>
+            <a:pPr marL="342900" indent="-342900">
+              <a:spcAft>
+                <a:spcPts val="1000"/>
+              </a:spcAft>
+              <a:buSzPct val="100000"/>
+              <a:buChar char="•"/>
+            </a:pPr>
+            <a:r>
+              <a:rPr lang="en-US" sz="1800" dirty="0">
+                <a:solidFill>
+                  <a:srgbClr val="FFFFFF"/>
+                </a:solidFill>
+                <a:latin typeface="Calibri" pitchFamily="34" charset="0"/>
+                <a:ea typeface="Calibri" pitchFamily="34" charset="-122"/>
+                <a:cs typeface="Calibri" pitchFamily="34" charset="-120"/>
+              </a:rPr>
+              <a:t>GridSybil ghosts that look honest on every content check (recall 0.823)</a:t>
+            </a:r>
+            <a:endParaRPr lang="en-US" sz="1800" dirty="0"/>
+          </a:p>
+          <a:p>
+            <a:pPr marL="342900" indent="-342900">
+              <a:spcAft>
+                <a:spcPts val="1000"/>
+              </a:spcAft>
+              <a:buSzPct val="100000"/>
+              <a:buChar char="•"/>
+            </a:pPr>
+            <a:r>
+              <a:rPr lang="en-US" sz="1800" dirty="0">
+                <a:solidFill>
+                  <a:srgbClr val="FFFFFF"/>
+                </a:solidFill>
+                <a:latin typeface="Calibri" pitchFamily="34" charset="0"/>
+                <a:ea typeface="Calibri" pitchFamily="34" charset="-122"/>
+                <a:cs typeface="Calibri" pitchFamily="34" charset="-120"/>
+              </a:rPr>
+              <a:t>Check on original VeReMi and VeReMi NextGen</a:t>
+            </a:r>
+            <a:endParaRPr lang="en-US" sz="1800" dirty="0"/>
+          </a:p>
+          <a:p>
+            <a:pPr marL="342900" indent="-342900">
+              <a:spcAft>
+                <a:spcPts val="1000"/>
+              </a:spcAft>
+              <a:buSzPct val="100000"/>
+              <a:buChar char="•"/>
+            </a:pPr>
+            <a:r>
+              <a:rPr lang="en-US" sz="1800" dirty="0">
+                <a:solidFill>
+                  <a:srgbClr val="FFFFFF"/>
+                </a:solidFill>
+                <a:latin typeface="Calibri" pitchFamily="34" charset="0"/>
+                <a:ea typeface="Calibri" pitchFamily="34" charset="-122"/>
+                <a:cs typeface="Calibri" pitchFamily="34" charset="-120"/>
+              </a:rPr>
+              <a:t>Run v2 on dense traffic; add a 3rd seed</a:t>
+            </a:r>
+            <a:endParaRPr lang="en-US" sz="1800" dirty="0"/>
+          </a:p>
+          <a:p>
+            <a:pPr marL="342900" indent="-342900">
+              <a:spcAft>
+                <a:spcPts val="1000"/>
+              </a:spcAft>
+              <a:buSzPct val="100000"/>
+              <a:buChar char="•"/>
+            </a:pPr>
+            <a:r>
+              <a:rPr lang="en-US" sz="1800" dirty="0">
+                <a:solidFill>
+                  <a:srgbClr val="FFFFFF"/>
+                </a:solidFill>
+                <a:latin typeface="Calibri" pitchFamily="34" charset="0"/>
+                <a:ea typeface="Calibri" pitchFamily="34" charset="-122"/>
+                <a:cs typeface="Calibri" pitchFamily="34" charset="-120"/>
+              </a:rPr>
+              <a:t>On-road consistent lies need an independent signal: signal strength, on-board sensors, roadside units</a:t>
+            </a:r>
+            <a:endParaRPr lang="en-US" sz="1800" dirty="0"/>
+          </a:p>
+          <a:p>
+            <a:pPr marL="342900" indent="-342900">
+              <a:spcAft>
+                <a:spcPts val="1000"/>
+              </a:spcAft>
+              <a:buSzPct val="100000"/>
+              <a:buChar char="•"/>
+            </a:pPr>
+            <a:r>
+              <a:rPr lang="en-US" sz="1800" dirty="0">
+                <a:solidFill>
+                  <a:srgbClr val="FFFFFF"/>
+                </a:solidFill>
+                <a:latin typeface="Calibri" pitchFamily="34" charset="0"/>
+                <a:ea typeface="Calibri" pitchFamily="34" charset="-122"/>
+                <a:cs typeface="Calibri" pitchFamily="34" charset="-120"/>
+              </a:rPr>
+              <a:t>Paper done: paper/main.pdf, IEEE conference format, 6 pages, 18 references</a:t>
+            </a:r>
+            <a:endParaRPr lang="en-US" sz="1800" dirty="0"/>
           </a:p>
         </p:txBody>
       </p:sp>
@@ -2548,7 +2835,7 @@
                 <a:ea typeface="Calibri" pitchFamily="34" charset="-122"/>
                 <a:cs typeface="Calibri" pitchFamily="34" charset="-120"/>
               </a:rPr>
-              <a:t>VeReMi Extension: 14 of 19 attack types (no Sybil; RandomSpeedOffset archive excluded as mislabeled)</a:t>
+              <a:t>VeReMi Extension: 14 of 19 attack types for the main results; extended to 18 of 19 with the four Sybil attacks (RandomSpeedOffset archive excluded as mislabeled)</a:t>
             </a:r>
             <a:endParaRPr lang="en-US" sz="1300" dirty="0"/>
           </a:p>
@@ -8325,7 +8612,7 @@
     <p:bg>
       <p:bgPr>
         <a:solidFill>
-          <a:srgbClr val="0B1F33"/>
+          <a:srgbClr val="FFFFFF"/>
         </a:solidFill>
       </p:bgPr>
     </p:bg>
@@ -8370,28 +8657,2080 @@
             <a:r>
               <a:rPr lang="en-US" sz="3000" b="1" dirty="0">
                 <a:solidFill>
-                  <a:srgbClr val="FFFFFF"/>
+                  <a:srgbClr val="0B1F33"/>
                 </a:solidFill>
                 <a:latin typeface="Cambria" pitchFamily="34" charset="0"/>
                 <a:ea typeface="Cambria" pitchFamily="34" charset="-122"/>
                 <a:cs typeface="Cambria" pitchFamily="34" charset="-120"/>
               </a:rPr>
-              <a:t>Open items and next steps</a:t>
+              <a:t>Extension: 18 attacks, including Sybil</a:t>
             </a:r>
             <a:endParaRPr lang="en-US" sz="3000" dirty="0"/>
           </a:p>
         </p:txBody>
       </p:sp>
+      <p:graphicFrame>
+        <p:nvGraphicFramePr>
+          <p:cNvPr id="10" name="Table 0"/>
+          <p:cNvGraphicFramePr>
+            <a:graphicFrameLocks noGrp="1"/>
+          </p:cNvGraphicFramePr>
+          <p:nvPr>
+            <p:extLst>
+              <p:ext uri="{D42A27DB-BD31-4B8C-83A1-F6EECF244321}">
+                <p14:modId xmlns:p14="http://schemas.microsoft.com/office/powerpoint/2010/main" val="1579011935"/>
+              </p:ext>
+            </p:extLst>
+          </p:nvPr>
+        </p:nvGraphicFramePr>
+        <p:xfrm>
+          <a:off x="548640" y="1051560"/>
+          <a:ext cx="5120640" cy="914400"/>
+        </p:xfrm>
+        <a:graphic>
+          <a:graphicData uri="http://schemas.openxmlformats.org/drawingml/2006/table">
+            <a:tbl>
+              <a:tblPr/>
+              <a:tblGrid>
+                <a:gridCol w="2194560"/>
+                <a:gridCol w="731520"/>
+                <a:gridCol w="731520"/>
+                <a:gridCol w="731520"/>
+                <a:gridCol w="731520"/>
+              </a:tblGrid>
+              <a:tr h="310896">
+                <a:tc>
+                  <a:txBody>
+                    <a:bodyPr/>
+                    <a:lstStyle/>
+                    <a:p>
+                      <a:pPr algn="ctr" indent="0" marL="0">
+                        <a:buNone/>
+                      </a:pPr>
+                      <a:r>
+                        <a:rPr lang="en-US" sz="1200" b="1" dirty="0">
+                          <a:solidFill>
+                            <a:srgbClr val="FFFFFF"/>
+                          </a:solidFill>
+                          <a:latin typeface="Calibri" pitchFamily="34" charset="0"/>
+                          <a:ea typeface="Calibri" pitchFamily="34" charset="-122"/>
+                          <a:cs typeface="Calibri" pitchFamily="34" charset="-120"/>
+                        </a:rPr>
+                        <a:t>18 attacks, 88,695 test windows</a:t>
+                      </a:r>
+                      <a:endParaRPr lang="en-US" sz="1200" dirty="0">
+                        <a:latin typeface="Calibri" charset="0"/>
+                        <a:ea typeface="Calibri" charset="0"/>
+                        <a:cs typeface="Calibri" charset="0"/>
+                      </a:endParaRPr>
+                    </a:p>
+                  </a:txBody>
+                  <a:tcPr marL="91440" marR="91440" marT="45720" marB="45720">
+                    <a:lnL w="9525" cap="flat" cmpd="sng" algn="ctr">
+                      <a:solidFill>
+                        <a:srgbClr val="D5DDE3"/>
+                      </a:solidFill>
+                      <a:prstDash val="solid"/>
+                      <a:round/>
+                      <a:headEnd type="none" w="med" len="med"/>
+                      <a:tailEnd type="none" w="med" len="med"/>
+                    </a:lnL>
+                    <a:lnR w="9525" cap="flat" cmpd="sng" algn="ctr">
+                      <a:solidFill>
+                        <a:srgbClr val="D5DDE3"/>
+                      </a:solidFill>
+                      <a:prstDash val="solid"/>
+                      <a:round/>
+                      <a:headEnd type="none" w="med" len="med"/>
+                      <a:tailEnd type="none" w="med" len="med"/>
+                    </a:lnR>
+                    <a:lnT w="9525" cap="flat" cmpd="sng" algn="ctr">
+                      <a:solidFill>
+                        <a:srgbClr val="D5DDE3"/>
+                      </a:solidFill>
+                      <a:prstDash val="solid"/>
+                      <a:round/>
+                      <a:headEnd type="none" w="med" len="med"/>
+                      <a:tailEnd type="none" w="med" len="med"/>
+                    </a:lnT>
+                    <a:lnB w="9525" cap="flat" cmpd="sng" algn="ctr">
+                      <a:solidFill>
+                        <a:srgbClr val="D5DDE3"/>
+                      </a:solidFill>
+                      <a:prstDash val="solid"/>
+                      <a:round/>
+                      <a:headEnd type="none" w="med" len="med"/>
+                      <a:tailEnd type="none" w="med" len="med"/>
+                    </a:lnB>
+                    <a:solidFill>
+                      <a:srgbClr val="0B1F33"/>
+                    </a:solidFill>
+                  </a:tcPr>
+                </a:tc>
+                <a:tc>
+                  <a:txBody>
+                    <a:bodyPr/>
+                    <a:lstStyle/>
+                    <a:p>
+                      <a:pPr algn="ctr" indent="0" marL="0">
+                        <a:buNone/>
+                      </a:pPr>
+                      <a:r>
+                        <a:rPr lang="en-US" sz="1200" b="1" dirty="0">
+                          <a:solidFill>
+                            <a:srgbClr val="FFFFFF"/>
+                          </a:solidFill>
+                          <a:latin typeface="Calibri" pitchFamily="34" charset="0"/>
+                          <a:ea typeface="Calibri" pitchFamily="34" charset="-122"/>
+                          <a:cs typeface="Calibri" pitchFamily="34" charset="-120"/>
+                        </a:rPr>
+                        <a:t>Precision</a:t>
+                      </a:r>
+                      <a:endParaRPr lang="en-US" sz="1200" dirty="0">
+                        <a:latin typeface="Calibri" charset="0"/>
+                        <a:ea typeface="Calibri" charset="0"/>
+                        <a:cs typeface="Calibri" charset="0"/>
+                      </a:endParaRPr>
+                    </a:p>
+                  </a:txBody>
+                  <a:tcPr marL="91440" marR="91440" marT="45720" marB="45720">
+                    <a:lnL w="9525" cap="flat" cmpd="sng" algn="ctr">
+                      <a:solidFill>
+                        <a:srgbClr val="D5DDE3"/>
+                      </a:solidFill>
+                      <a:prstDash val="solid"/>
+                      <a:round/>
+                      <a:headEnd type="none" w="med" len="med"/>
+                      <a:tailEnd type="none" w="med" len="med"/>
+                    </a:lnL>
+                    <a:lnR w="9525" cap="flat" cmpd="sng" algn="ctr">
+                      <a:solidFill>
+                        <a:srgbClr val="D5DDE3"/>
+                      </a:solidFill>
+                      <a:prstDash val="solid"/>
+                      <a:round/>
+                      <a:headEnd type="none" w="med" len="med"/>
+                      <a:tailEnd type="none" w="med" len="med"/>
+                    </a:lnR>
+                    <a:lnT w="9525" cap="flat" cmpd="sng" algn="ctr">
+                      <a:solidFill>
+                        <a:srgbClr val="D5DDE3"/>
+                      </a:solidFill>
+                      <a:prstDash val="solid"/>
+                      <a:round/>
+                      <a:headEnd type="none" w="med" len="med"/>
+                      <a:tailEnd type="none" w="med" len="med"/>
+                    </a:lnT>
+                    <a:lnB w="9525" cap="flat" cmpd="sng" algn="ctr">
+                      <a:solidFill>
+                        <a:srgbClr val="D5DDE3"/>
+                      </a:solidFill>
+                      <a:prstDash val="solid"/>
+                      <a:round/>
+                      <a:headEnd type="none" w="med" len="med"/>
+                      <a:tailEnd type="none" w="med" len="med"/>
+                    </a:lnB>
+                    <a:solidFill>
+                      <a:srgbClr val="0B1F33"/>
+                    </a:solidFill>
+                  </a:tcPr>
+                </a:tc>
+                <a:tc>
+                  <a:txBody>
+                    <a:bodyPr/>
+                    <a:lstStyle/>
+                    <a:p>
+                      <a:pPr algn="ctr" indent="0" marL="0">
+                        <a:buNone/>
+                      </a:pPr>
+                      <a:r>
+                        <a:rPr lang="en-US" sz="1200" b="1" dirty="0">
+                          <a:solidFill>
+                            <a:srgbClr val="FFFFFF"/>
+                          </a:solidFill>
+                          <a:latin typeface="Calibri" pitchFamily="34" charset="0"/>
+                          <a:ea typeface="Calibri" pitchFamily="34" charset="-122"/>
+                          <a:cs typeface="Calibri" pitchFamily="34" charset="-120"/>
+                        </a:rPr>
+                        <a:t>Recall</a:t>
+                      </a:r>
+                      <a:endParaRPr lang="en-US" sz="1200" dirty="0">
+                        <a:latin typeface="Calibri" charset="0"/>
+                        <a:ea typeface="Calibri" charset="0"/>
+                        <a:cs typeface="Calibri" charset="0"/>
+                      </a:endParaRPr>
+                    </a:p>
+                  </a:txBody>
+                  <a:tcPr marL="91440" marR="91440" marT="45720" marB="45720">
+                    <a:lnL w="9525" cap="flat" cmpd="sng" algn="ctr">
+                      <a:solidFill>
+                        <a:srgbClr val="D5DDE3"/>
+                      </a:solidFill>
+                      <a:prstDash val="solid"/>
+                      <a:round/>
+                      <a:headEnd type="none" w="med" len="med"/>
+                      <a:tailEnd type="none" w="med" len="med"/>
+                    </a:lnL>
+                    <a:lnR w="9525" cap="flat" cmpd="sng" algn="ctr">
+                      <a:solidFill>
+                        <a:srgbClr val="D5DDE3"/>
+                      </a:solidFill>
+                      <a:prstDash val="solid"/>
+                      <a:round/>
+                      <a:headEnd type="none" w="med" len="med"/>
+                      <a:tailEnd type="none" w="med" len="med"/>
+                    </a:lnR>
+                    <a:lnT w="9525" cap="flat" cmpd="sng" algn="ctr">
+                      <a:solidFill>
+                        <a:srgbClr val="D5DDE3"/>
+                      </a:solidFill>
+                      <a:prstDash val="solid"/>
+                      <a:round/>
+                      <a:headEnd type="none" w="med" len="med"/>
+                      <a:tailEnd type="none" w="med" len="med"/>
+                    </a:lnT>
+                    <a:lnB w="9525" cap="flat" cmpd="sng" algn="ctr">
+                      <a:solidFill>
+                        <a:srgbClr val="D5DDE3"/>
+                      </a:solidFill>
+                      <a:prstDash val="solid"/>
+                      <a:round/>
+                      <a:headEnd type="none" w="med" len="med"/>
+                      <a:tailEnd type="none" w="med" len="med"/>
+                    </a:lnB>
+                    <a:solidFill>
+                      <a:srgbClr val="0B1F33"/>
+                    </a:solidFill>
+                  </a:tcPr>
+                </a:tc>
+                <a:tc>
+                  <a:txBody>
+                    <a:bodyPr/>
+                    <a:lstStyle/>
+                    <a:p>
+                      <a:pPr algn="ctr" indent="0" marL="0">
+                        <a:buNone/>
+                      </a:pPr>
+                      <a:r>
+                        <a:rPr lang="en-US" sz="1200" b="1" dirty="0">
+                          <a:solidFill>
+                            <a:srgbClr val="FFFFFF"/>
+                          </a:solidFill>
+                          <a:latin typeface="Calibri" pitchFamily="34" charset="0"/>
+                          <a:ea typeface="Calibri" pitchFamily="34" charset="-122"/>
+                          <a:cs typeface="Calibri" pitchFamily="34" charset="-120"/>
+                        </a:rPr>
+                        <a:t>F1</a:t>
+                      </a:r>
+                      <a:endParaRPr lang="en-US" sz="1200" dirty="0">
+                        <a:latin typeface="Calibri" charset="0"/>
+                        <a:ea typeface="Calibri" charset="0"/>
+                        <a:cs typeface="Calibri" charset="0"/>
+                      </a:endParaRPr>
+                    </a:p>
+                  </a:txBody>
+                  <a:tcPr marL="91440" marR="91440" marT="45720" marB="45720">
+                    <a:lnL w="9525" cap="flat" cmpd="sng" algn="ctr">
+                      <a:solidFill>
+                        <a:srgbClr val="D5DDE3"/>
+                      </a:solidFill>
+                      <a:prstDash val="solid"/>
+                      <a:round/>
+                      <a:headEnd type="none" w="med" len="med"/>
+                      <a:tailEnd type="none" w="med" len="med"/>
+                    </a:lnL>
+                    <a:lnR w="9525" cap="flat" cmpd="sng" algn="ctr">
+                      <a:solidFill>
+                        <a:srgbClr val="D5DDE3"/>
+                      </a:solidFill>
+                      <a:prstDash val="solid"/>
+                      <a:round/>
+                      <a:headEnd type="none" w="med" len="med"/>
+                      <a:tailEnd type="none" w="med" len="med"/>
+                    </a:lnR>
+                    <a:lnT w="9525" cap="flat" cmpd="sng" algn="ctr">
+                      <a:solidFill>
+                        <a:srgbClr val="D5DDE3"/>
+                      </a:solidFill>
+                      <a:prstDash val="solid"/>
+                      <a:round/>
+                      <a:headEnd type="none" w="med" len="med"/>
+                      <a:tailEnd type="none" w="med" len="med"/>
+                    </a:lnT>
+                    <a:lnB w="9525" cap="flat" cmpd="sng" algn="ctr">
+                      <a:solidFill>
+                        <a:srgbClr val="D5DDE3"/>
+                      </a:solidFill>
+                      <a:prstDash val="solid"/>
+                      <a:round/>
+                      <a:headEnd type="none" w="med" len="med"/>
+                      <a:tailEnd type="none" w="med" len="med"/>
+                    </a:lnB>
+                    <a:solidFill>
+                      <a:srgbClr val="0B1F33"/>
+                    </a:solidFill>
+                  </a:tcPr>
+                </a:tc>
+                <a:tc>
+                  <a:txBody>
+                    <a:bodyPr/>
+                    <a:lstStyle/>
+                    <a:p>
+                      <a:pPr algn="ctr" indent="0" marL="0">
+                        <a:buNone/>
+                      </a:pPr>
+                      <a:r>
+                        <a:rPr lang="en-US" sz="1200" b="1" dirty="0">
+                          <a:solidFill>
+                            <a:srgbClr val="FFFFFF"/>
+                          </a:solidFill>
+                          <a:latin typeface="Calibri" pitchFamily="34" charset="0"/>
+                          <a:ea typeface="Calibri" pitchFamily="34" charset="-122"/>
+                          <a:cs typeface="Calibri" pitchFamily="34" charset="-120"/>
+                        </a:rPr>
+                        <a:t>Accuracy</a:t>
+                      </a:r>
+                      <a:endParaRPr lang="en-US" sz="1200" dirty="0">
+                        <a:latin typeface="Calibri" charset="0"/>
+                        <a:ea typeface="Calibri" charset="0"/>
+                        <a:cs typeface="Calibri" charset="0"/>
+                      </a:endParaRPr>
+                    </a:p>
+                  </a:txBody>
+                  <a:tcPr marL="91440" marR="91440" marT="45720" marB="45720">
+                    <a:lnL w="9525" cap="flat" cmpd="sng" algn="ctr">
+                      <a:solidFill>
+                        <a:srgbClr val="D5DDE3"/>
+                      </a:solidFill>
+                      <a:prstDash val="solid"/>
+                      <a:round/>
+                      <a:headEnd type="none" w="med" len="med"/>
+                      <a:tailEnd type="none" w="med" len="med"/>
+                    </a:lnL>
+                    <a:lnR w="9525" cap="flat" cmpd="sng" algn="ctr">
+                      <a:solidFill>
+                        <a:srgbClr val="D5DDE3"/>
+                      </a:solidFill>
+                      <a:prstDash val="solid"/>
+                      <a:round/>
+                      <a:headEnd type="none" w="med" len="med"/>
+                      <a:tailEnd type="none" w="med" len="med"/>
+                    </a:lnR>
+                    <a:lnT w="9525" cap="flat" cmpd="sng" algn="ctr">
+                      <a:solidFill>
+                        <a:srgbClr val="D5DDE3"/>
+                      </a:solidFill>
+                      <a:prstDash val="solid"/>
+                      <a:round/>
+                      <a:headEnd type="none" w="med" len="med"/>
+                      <a:tailEnd type="none" w="med" len="med"/>
+                    </a:lnT>
+                    <a:lnB w="9525" cap="flat" cmpd="sng" algn="ctr">
+                      <a:solidFill>
+                        <a:srgbClr val="D5DDE3"/>
+                      </a:solidFill>
+                      <a:prstDash val="solid"/>
+                      <a:round/>
+                      <a:headEnd type="none" w="med" len="med"/>
+                      <a:tailEnd type="none" w="med" len="med"/>
+                    </a:lnB>
+                    <a:solidFill>
+                      <a:srgbClr val="0B1F33"/>
+                    </a:solidFill>
+                  </a:tcPr>
+                </a:tc>
+              </a:tr>
+              <a:tr h="310896">
+                <a:tc>
+                  <a:txBody>
+                    <a:bodyPr/>
+                    <a:lstStyle/>
+                    <a:p>
+                      <a:pPr algn="l" indent="0" marL="0">
+                        <a:buNone/>
+                      </a:pPr>
+                      <a:r>
+                        <a:rPr lang="en-US" sz="1200" b="1" dirty="0">
+                          <a:solidFill>
+                            <a:srgbClr val="1B2A38"/>
+                          </a:solidFill>
+                          <a:latin typeface="Calibri" pitchFamily="34" charset="0"/>
+                          <a:ea typeface="Calibri" pitchFamily="34" charset="-122"/>
+                          <a:cs typeface="Calibri" pitchFamily="34" charset="-120"/>
+                        </a:rPr>
+                        <a:t>Ours, message labels</a:t>
+                      </a:r>
+                      <a:endParaRPr lang="en-US" sz="1200" dirty="0">
+                        <a:latin typeface="Calibri" charset="0"/>
+                        <a:ea typeface="Calibri" charset="0"/>
+                        <a:cs typeface="Calibri" charset="0"/>
+                      </a:endParaRPr>
+                    </a:p>
+                  </a:txBody>
+                  <a:tcPr marL="91440" marR="91440" marT="45720" marB="45720">
+                    <a:lnL w="9525" cap="flat" cmpd="sng" algn="ctr">
+                      <a:solidFill>
+                        <a:srgbClr val="D5DDE3"/>
+                      </a:solidFill>
+                      <a:prstDash val="solid"/>
+                      <a:round/>
+                      <a:headEnd type="none" w="med" len="med"/>
+                      <a:tailEnd type="none" w="med" len="med"/>
+                    </a:lnL>
+                    <a:lnR w="9525" cap="flat" cmpd="sng" algn="ctr">
+                      <a:solidFill>
+                        <a:srgbClr val="D5DDE3"/>
+                      </a:solidFill>
+                      <a:prstDash val="solid"/>
+                      <a:round/>
+                      <a:headEnd type="none" w="med" len="med"/>
+                      <a:tailEnd type="none" w="med" len="med"/>
+                    </a:lnR>
+                    <a:lnT w="9525" cap="flat" cmpd="sng" algn="ctr">
+                      <a:solidFill>
+                        <a:srgbClr val="D5DDE3"/>
+                      </a:solidFill>
+                      <a:prstDash val="solid"/>
+                      <a:round/>
+                      <a:headEnd type="none" w="med" len="med"/>
+                      <a:tailEnd type="none" w="med" len="med"/>
+                    </a:lnT>
+                    <a:lnB w="9525" cap="flat" cmpd="sng" algn="ctr">
+                      <a:solidFill>
+                        <a:srgbClr val="D5DDE3"/>
+                      </a:solidFill>
+                      <a:prstDash val="solid"/>
+                      <a:round/>
+                      <a:headEnd type="none" w="med" len="med"/>
+                      <a:tailEnd type="none" w="med" len="med"/>
+                    </a:lnB>
+                  </a:tcPr>
+                </a:tc>
+                <a:tc>
+                  <a:txBody>
+                    <a:bodyPr/>
+                    <a:lstStyle/>
+                    <a:p>
+                      <a:pPr algn="ctr" indent="0" marL="0">
+                        <a:buNone/>
+                      </a:pPr>
+                      <a:r>
+                        <a:rPr lang="en-US" sz="1200" b="1" dirty="0">
+                          <a:solidFill>
+                            <a:srgbClr val="1B2A38"/>
+                          </a:solidFill>
+                          <a:latin typeface="Calibri" pitchFamily="34" charset="0"/>
+                          <a:ea typeface="Calibri" pitchFamily="34" charset="-122"/>
+                          <a:cs typeface="Calibri" pitchFamily="34" charset="-120"/>
+                        </a:rPr>
+                        <a:t>96.30</a:t>
+                      </a:r>
+                      <a:endParaRPr lang="en-US" sz="1200" dirty="0">
+                        <a:latin typeface="Calibri" charset="0"/>
+                        <a:ea typeface="Calibri" charset="0"/>
+                        <a:cs typeface="Calibri" charset="0"/>
+                      </a:endParaRPr>
+                    </a:p>
+                  </a:txBody>
+                  <a:tcPr marL="91440" marR="91440" marT="45720" marB="45720">
+                    <a:lnL w="9525" cap="flat" cmpd="sng" algn="ctr">
+                      <a:solidFill>
+                        <a:srgbClr val="D5DDE3"/>
+                      </a:solidFill>
+                      <a:prstDash val="solid"/>
+                      <a:round/>
+                      <a:headEnd type="none" w="med" len="med"/>
+                      <a:tailEnd type="none" w="med" len="med"/>
+                    </a:lnL>
+                    <a:lnR w="9525" cap="flat" cmpd="sng" algn="ctr">
+                      <a:solidFill>
+                        <a:srgbClr val="D5DDE3"/>
+                      </a:solidFill>
+                      <a:prstDash val="solid"/>
+                      <a:round/>
+                      <a:headEnd type="none" w="med" len="med"/>
+                      <a:tailEnd type="none" w="med" len="med"/>
+                    </a:lnR>
+                    <a:lnT w="9525" cap="flat" cmpd="sng" algn="ctr">
+                      <a:solidFill>
+                        <a:srgbClr val="D5DDE3"/>
+                      </a:solidFill>
+                      <a:prstDash val="solid"/>
+                      <a:round/>
+                      <a:headEnd type="none" w="med" len="med"/>
+                      <a:tailEnd type="none" w="med" len="med"/>
+                    </a:lnT>
+                    <a:lnB w="9525" cap="flat" cmpd="sng" algn="ctr">
+                      <a:solidFill>
+                        <a:srgbClr val="D5DDE3"/>
+                      </a:solidFill>
+                      <a:prstDash val="solid"/>
+                      <a:round/>
+                      <a:headEnd type="none" w="med" len="med"/>
+                      <a:tailEnd type="none" w="med" len="med"/>
+                    </a:lnB>
+                  </a:tcPr>
+                </a:tc>
+                <a:tc>
+                  <a:txBody>
+                    <a:bodyPr/>
+                    <a:lstStyle/>
+                    <a:p>
+                      <a:pPr algn="ctr" indent="0" marL="0">
+                        <a:buNone/>
+                      </a:pPr>
+                      <a:r>
+                        <a:rPr lang="en-US" sz="1200" b="1" dirty="0">
+                          <a:solidFill>
+                            <a:srgbClr val="1B2A38"/>
+                          </a:solidFill>
+                          <a:latin typeface="Calibri" pitchFamily="34" charset="0"/>
+                          <a:ea typeface="Calibri" pitchFamily="34" charset="-122"/>
+                          <a:cs typeface="Calibri" pitchFamily="34" charset="-120"/>
+                        </a:rPr>
+                        <a:t>95.46</a:t>
+                      </a:r>
+                      <a:endParaRPr lang="en-US" sz="1200" dirty="0">
+                        <a:latin typeface="Calibri" charset="0"/>
+                        <a:ea typeface="Calibri" charset="0"/>
+                        <a:cs typeface="Calibri" charset="0"/>
+                      </a:endParaRPr>
+                    </a:p>
+                  </a:txBody>
+                  <a:tcPr marL="91440" marR="91440" marT="45720" marB="45720">
+                    <a:lnL w="9525" cap="flat" cmpd="sng" algn="ctr">
+                      <a:solidFill>
+                        <a:srgbClr val="D5DDE3"/>
+                      </a:solidFill>
+                      <a:prstDash val="solid"/>
+                      <a:round/>
+                      <a:headEnd type="none" w="med" len="med"/>
+                      <a:tailEnd type="none" w="med" len="med"/>
+                    </a:lnL>
+                    <a:lnR w="9525" cap="flat" cmpd="sng" algn="ctr">
+                      <a:solidFill>
+                        <a:srgbClr val="D5DDE3"/>
+                      </a:solidFill>
+                      <a:prstDash val="solid"/>
+                      <a:round/>
+                      <a:headEnd type="none" w="med" len="med"/>
+                      <a:tailEnd type="none" w="med" len="med"/>
+                    </a:lnR>
+                    <a:lnT w="9525" cap="flat" cmpd="sng" algn="ctr">
+                      <a:solidFill>
+                        <a:srgbClr val="D5DDE3"/>
+                      </a:solidFill>
+                      <a:prstDash val="solid"/>
+                      <a:round/>
+                      <a:headEnd type="none" w="med" len="med"/>
+                      <a:tailEnd type="none" w="med" len="med"/>
+                    </a:lnT>
+                    <a:lnB w="9525" cap="flat" cmpd="sng" algn="ctr">
+                      <a:solidFill>
+                        <a:srgbClr val="D5DDE3"/>
+                      </a:solidFill>
+                      <a:prstDash val="solid"/>
+                      <a:round/>
+                      <a:headEnd type="none" w="med" len="med"/>
+                      <a:tailEnd type="none" w="med" len="med"/>
+                    </a:lnB>
+                  </a:tcPr>
+                </a:tc>
+                <a:tc>
+                  <a:txBody>
+                    <a:bodyPr/>
+                    <a:lstStyle/>
+                    <a:p>
+                      <a:pPr algn="ctr" indent="0" marL="0">
+                        <a:buNone/>
+                      </a:pPr>
+                      <a:r>
+                        <a:rPr lang="en-US" sz="1200" b="1" dirty="0">
+                          <a:solidFill>
+                            <a:srgbClr val="1B2A38"/>
+                          </a:solidFill>
+                          <a:latin typeface="Calibri" pitchFamily="34" charset="0"/>
+                          <a:ea typeface="Calibri" pitchFamily="34" charset="-122"/>
+                          <a:cs typeface="Calibri" pitchFamily="34" charset="-120"/>
+                        </a:rPr>
+                        <a:t>95.88</a:t>
+                      </a:r>
+                      <a:endParaRPr lang="en-US" sz="1200" dirty="0">
+                        <a:latin typeface="Calibri" charset="0"/>
+                        <a:ea typeface="Calibri" charset="0"/>
+                        <a:cs typeface="Calibri" charset="0"/>
+                      </a:endParaRPr>
+                    </a:p>
+                  </a:txBody>
+                  <a:tcPr marL="91440" marR="91440" marT="45720" marB="45720">
+                    <a:lnL w="9525" cap="flat" cmpd="sng" algn="ctr">
+                      <a:solidFill>
+                        <a:srgbClr val="D5DDE3"/>
+                      </a:solidFill>
+                      <a:prstDash val="solid"/>
+                      <a:round/>
+                      <a:headEnd type="none" w="med" len="med"/>
+                      <a:tailEnd type="none" w="med" len="med"/>
+                    </a:lnL>
+                    <a:lnR w="9525" cap="flat" cmpd="sng" algn="ctr">
+                      <a:solidFill>
+                        <a:srgbClr val="D5DDE3"/>
+                      </a:solidFill>
+                      <a:prstDash val="solid"/>
+                      <a:round/>
+                      <a:headEnd type="none" w="med" len="med"/>
+                      <a:tailEnd type="none" w="med" len="med"/>
+                    </a:lnR>
+                    <a:lnT w="9525" cap="flat" cmpd="sng" algn="ctr">
+                      <a:solidFill>
+                        <a:srgbClr val="D5DDE3"/>
+                      </a:solidFill>
+                      <a:prstDash val="solid"/>
+                      <a:round/>
+                      <a:headEnd type="none" w="med" len="med"/>
+                      <a:tailEnd type="none" w="med" len="med"/>
+                    </a:lnT>
+                    <a:lnB w="9525" cap="flat" cmpd="sng" algn="ctr">
+                      <a:solidFill>
+                        <a:srgbClr val="D5DDE3"/>
+                      </a:solidFill>
+                      <a:prstDash val="solid"/>
+                      <a:round/>
+                      <a:headEnd type="none" w="med" len="med"/>
+                      <a:tailEnd type="none" w="med" len="med"/>
+                    </a:lnB>
+                  </a:tcPr>
+                </a:tc>
+                <a:tc>
+                  <a:txBody>
+                    <a:bodyPr/>
+                    <a:lstStyle/>
+                    <a:p>
+                      <a:pPr algn="ctr" indent="0" marL="0">
+                        <a:buNone/>
+                      </a:pPr>
+                      <a:r>
+                        <a:rPr lang="en-US" sz="1200" b="1" dirty="0">
+                          <a:solidFill>
+                            <a:srgbClr val="1B2A38"/>
+                          </a:solidFill>
+                          <a:latin typeface="Calibri" pitchFamily="34" charset="0"/>
+                          <a:ea typeface="Calibri" pitchFamily="34" charset="-122"/>
+                          <a:cs typeface="Calibri" pitchFamily="34" charset="-120"/>
+                        </a:rPr>
+                        <a:t>97.04</a:t>
+                      </a:r>
+                      <a:endParaRPr lang="en-US" sz="1200" dirty="0">
+                        <a:latin typeface="Calibri" charset="0"/>
+                        <a:ea typeface="Calibri" charset="0"/>
+                        <a:cs typeface="Calibri" charset="0"/>
+                      </a:endParaRPr>
+                    </a:p>
+                  </a:txBody>
+                  <a:tcPr marL="91440" marR="91440" marT="45720" marB="45720">
+                    <a:lnL w="9525" cap="flat" cmpd="sng" algn="ctr">
+                      <a:solidFill>
+                        <a:srgbClr val="D5DDE3"/>
+                      </a:solidFill>
+                      <a:prstDash val="solid"/>
+                      <a:round/>
+                      <a:headEnd type="none" w="med" len="med"/>
+                      <a:tailEnd type="none" w="med" len="med"/>
+                    </a:lnL>
+                    <a:lnR w="9525" cap="flat" cmpd="sng" algn="ctr">
+                      <a:solidFill>
+                        <a:srgbClr val="D5DDE3"/>
+                      </a:solidFill>
+                      <a:prstDash val="solid"/>
+                      <a:round/>
+                      <a:headEnd type="none" w="med" len="med"/>
+                      <a:tailEnd type="none" w="med" len="med"/>
+                    </a:lnR>
+                    <a:lnT w="9525" cap="flat" cmpd="sng" algn="ctr">
+                      <a:solidFill>
+                        <a:srgbClr val="D5DDE3"/>
+                      </a:solidFill>
+                      <a:prstDash val="solid"/>
+                      <a:round/>
+                      <a:headEnd type="none" w="med" len="med"/>
+                      <a:tailEnd type="none" w="med" len="med"/>
+                    </a:lnT>
+                    <a:lnB w="9525" cap="flat" cmpd="sng" algn="ctr">
+                      <a:solidFill>
+                        <a:srgbClr val="D5DDE3"/>
+                      </a:solidFill>
+                      <a:prstDash val="solid"/>
+                      <a:round/>
+                      <a:headEnd type="none" w="med" len="med"/>
+                      <a:tailEnd type="none" w="med" len="med"/>
+                    </a:lnB>
+                  </a:tcPr>
+                </a:tc>
+              </a:tr>
+              <a:tr h="310896">
+                <a:tc>
+                  <a:txBody>
+                    <a:bodyPr/>
+                    <a:lstStyle/>
+                    <a:p>
+                      <a:pPr algn="l" indent="0" marL="0">
+                        <a:buNone/>
+                      </a:pPr>
+                      <a:r>
+                        <a:rPr lang="en-US" sz="1200" dirty="0">
+                          <a:solidFill>
+                            <a:srgbClr val="1B2A38"/>
+                          </a:solidFill>
+                          <a:latin typeface="Calibri" pitchFamily="34" charset="0"/>
+                          <a:ea typeface="Calibri" pitchFamily="34" charset="-122"/>
+                          <a:cs typeface="Calibri" pitchFamily="34" charset="-120"/>
+                        </a:rPr>
+                        <a:t>Ours, vehicle labels</a:t>
+                      </a:r>
+                      <a:endParaRPr lang="en-US" sz="1200" dirty="0">
+                        <a:latin typeface="Calibri" charset="0"/>
+                        <a:ea typeface="Calibri" charset="0"/>
+                        <a:cs typeface="Calibri" charset="0"/>
+                      </a:endParaRPr>
+                    </a:p>
+                  </a:txBody>
+                  <a:tcPr marL="91440" marR="91440" marT="45720" marB="45720">
+                    <a:lnL w="9525" cap="flat" cmpd="sng" algn="ctr">
+                      <a:solidFill>
+                        <a:srgbClr val="D5DDE3"/>
+                      </a:solidFill>
+                      <a:prstDash val="solid"/>
+                      <a:round/>
+                      <a:headEnd type="none" w="med" len="med"/>
+                      <a:tailEnd type="none" w="med" len="med"/>
+                    </a:lnL>
+                    <a:lnR w="9525" cap="flat" cmpd="sng" algn="ctr">
+                      <a:solidFill>
+                        <a:srgbClr val="D5DDE3"/>
+                      </a:solidFill>
+                      <a:prstDash val="solid"/>
+                      <a:round/>
+                      <a:headEnd type="none" w="med" len="med"/>
+                      <a:tailEnd type="none" w="med" len="med"/>
+                    </a:lnR>
+                    <a:lnT w="9525" cap="flat" cmpd="sng" algn="ctr">
+                      <a:solidFill>
+                        <a:srgbClr val="D5DDE3"/>
+                      </a:solidFill>
+                      <a:prstDash val="solid"/>
+                      <a:round/>
+                      <a:headEnd type="none" w="med" len="med"/>
+                      <a:tailEnd type="none" w="med" len="med"/>
+                    </a:lnT>
+                    <a:lnB w="9525" cap="flat" cmpd="sng" algn="ctr">
+                      <a:solidFill>
+                        <a:srgbClr val="D5DDE3"/>
+                      </a:solidFill>
+                      <a:prstDash val="solid"/>
+                      <a:round/>
+                      <a:headEnd type="none" w="med" len="med"/>
+                      <a:tailEnd type="none" w="med" len="med"/>
+                    </a:lnB>
+                  </a:tcPr>
+                </a:tc>
+                <a:tc>
+                  <a:txBody>
+                    <a:bodyPr/>
+                    <a:lstStyle/>
+                    <a:p>
+                      <a:pPr algn="ctr" indent="0" marL="0">
+                        <a:buNone/>
+                      </a:pPr>
+                      <a:r>
+                        <a:rPr lang="en-US" sz="1200" dirty="0">
+                          <a:solidFill>
+                            <a:srgbClr val="1B2A38"/>
+                          </a:solidFill>
+                          <a:latin typeface="Calibri" pitchFamily="34" charset="0"/>
+                          <a:ea typeface="Calibri" pitchFamily="34" charset="-122"/>
+                          <a:cs typeface="Calibri" pitchFamily="34" charset="-120"/>
+                        </a:rPr>
+                        <a:t>96.33</a:t>
+                      </a:r>
+                      <a:endParaRPr lang="en-US" sz="1200" dirty="0">
+                        <a:latin typeface="Calibri" charset="0"/>
+                        <a:ea typeface="Calibri" charset="0"/>
+                        <a:cs typeface="Calibri" charset="0"/>
+                      </a:endParaRPr>
+                    </a:p>
+                  </a:txBody>
+                  <a:tcPr marL="91440" marR="91440" marT="45720" marB="45720">
+                    <a:lnL w="9525" cap="flat" cmpd="sng" algn="ctr">
+                      <a:solidFill>
+                        <a:srgbClr val="D5DDE3"/>
+                      </a:solidFill>
+                      <a:prstDash val="solid"/>
+                      <a:round/>
+                      <a:headEnd type="none" w="med" len="med"/>
+                      <a:tailEnd type="none" w="med" len="med"/>
+                    </a:lnL>
+                    <a:lnR w="9525" cap="flat" cmpd="sng" algn="ctr">
+                      <a:solidFill>
+                        <a:srgbClr val="D5DDE3"/>
+                      </a:solidFill>
+                      <a:prstDash val="solid"/>
+                      <a:round/>
+                      <a:headEnd type="none" w="med" len="med"/>
+                      <a:tailEnd type="none" w="med" len="med"/>
+                    </a:lnR>
+                    <a:lnT w="9525" cap="flat" cmpd="sng" algn="ctr">
+                      <a:solidFill>
+                        <a:srgbClr val="D5DDE3"/>
+                      </a:solidFill>
+                      <a:prstDash val="solid"/>
+                      <a:round/>
+                      <a:headEnd type="none" w="med" len="med"/>
+                      <a:tailEnd type="none" w="med" len="med"/>
+                    </a:lnT>
+                    <a:lnB w="9525" cap="flat" cmpd="sng" algn="ctr">
+                      <a:solidFill>
+                        <a:srgbClr val="D5DDE3"/>
+                      </a:solidFill>
+                      <a:prstDash val="solid"/>
+                      <a:round/>
+                      <a:headEnd type="none" w="med" len="med"/>
+                      <a:tailEnd type="none" w="med" len="med"/>
+                    </a:lnB>
+                  </a:tcPr>
+                </a:tc>
+                <a:tc>
+                  <a:txBody>
+                    <a:bodyPr/>
+                    <a:lstStyle/>
+                    <a:p>
+                      <a:pPr algn="ctr" indent="0" marL="0">
+                        <a:buNone/>
+                      </a:pPr>
+                      <a:r>
+                        <a:rPr lang="en-US" sz="1200" dirty="0">
+                          <a:solidFill>
+                            <a:srgbClr val="1B2A38"/>
+                          </a:solidFill>
+                          <a:latin typeface="Calibri" pitchFamily="34" charset="0"/>
+                          <a:ea typeface="Calibri" pitchFamily="34" charset="-122"/>
+                          <a:cs typeface="Calibri" pitchFamily="34" charset="-120"/>
+                        </a:rPr>
+                        <a:t>94.44</a:t>
+                      </a:r>
+                      <a:endParaRPr lang="en-US" sz="1200" dirty="0">
+                        <a:latin typeface="Calibri" charset="0"/>
+                        <a:ea typeface="Calibri" charset="0"/>
+                        <a:cs typeface="Calibri" charset="0"/>
+                      </a:endParaRPr>
+                    </a:p>
+                  </a:txBody>
+                  <a:tcPr marL="91440" marR="91440" marT="45720" marB="45720">
+                    <a:lnL w="9525" cap="flat" cmpd="sng" algn="ctr">
+                      <a:solidFill>
+                        <a:srgbClr val="D5DDE3"/>
+                      </a:solidFill>
+                      <a:prstDash val="solid"/>
+                      <a:round/>
+                      <a:headEnd type="none" w="med" len="med"/>
+                      <a:tailEnd type="none" w="med" len="med"/>
+                    </a:lnL>
+                    <a:lnR w="9525" cap="flat" cmpd="sng" algn="ctr">
+                      <a:solidFill>
+                        <a:srgbClr val="D5DDE3"/>
+                      </a:solidFill>
+                      <a:prstDash val="solid"/>
+                      <a:round/>
+                      <a:headEnd type="none" w="med" len="med"/>
+                      <a:tailEnd type="none" w="med" len="med"/>
+                    </a:lnR>
+                    <a:lnT w="9525" cap="flat" cmpd="sng" algn="ctr">
+                      <a:solidFill>
+                        <a:srgbClr val="D5DDE3"/>
+                      </a:solidFill>
+                      <a:prstDash val="solid"/>
+                      <a:round/>
+                      <a:headEnd type="none" w="med" len="med"/>
+                      <a:tailEnd type="none" w="med" len="med"/>
+                    </a:lnT>
+                    <a:lnB w="9525" cap="flat" cmpd="sng" algn="ctr">
+                      <a:solidFill>
+                        <a:srgbClr val="D5DDE3"/>
+                      </a:solidFill>
+                      <a:prstDash val="solid"/>
+                      <a:round/>
+                      <a:headEnd type="none" w="med" len="med"/>
+                      <a:tailEnd type="none" w="med" len="med"/>
+                    </a:lnB>
+                  </a:tcPr>
+                </a:tc>
+                <a:tc>
+                  <a:txBody>
+                    <a:bodyPr/>
+                    <a:lstStyle/>
+                    <a:p>
+                      <a:pPr algn="ctr" indent="0" marL="0">
+                        <a:buNone/>
+                      </a:pPr>
+                      <a:r>
+                        <a:rPr lang="en-US" sz="1200" dirty="0">
+                          <a:solidFill>
+                            <a:srgbClr val="1B2A38"/>
+                          </a:solidFill>
+                          <a:latin typeface="Calibri" pitchFamily="34" charset="0"/>
+                          <a:ea typeface="Calibri" pitchFamily="34" charset="-122"/>
+                          <a:cs typeface="Calibri" pitchFamily="34" charset="-120"/>
+                        </a:rPr>
+                        <a:t>95.38</a:t>
+                      </a:r>
+                      <a:endParaRPr lang="en-US" sz="1200" dirty="0">
+                        <a:latin typeface="Calibri" charset="0"/>
+                        <a:ea typeface="Calibri" charset="0"/>
+                        <a:cs typeface="Calibri" charset="0"/>
+                      </a:endParaRPr>
+                    </a:p>
+                  </a:txBody>
+                  <a:tcPr marL="91440" marR="91440" marT="45720" marB="45720">
+                    <a:lnL w="9525" cap="flat" cmpd="sng" algn="ctr">
+                      <a:solidFill>
+                        <a:srgbClr val="D5DDE3"/>
+                      </a:solidFill>
+                      <a:prstDash val="solid"/>
+                      <a:round/>
+                      <a:headEnd type="none" w="med" len="med"/>
+                      <a:tailEnd type="none" w="med" len="med"/>
+                    </a:lnL>
+                    <a:lnR w="9525" cap="flat" cmpd="sng" algn="ctr">
+                      <a:solidFill>
+                        <a:srgbClr val="D5DDE3"/>
+                      </a:solidFill>
+                      <a:prstDash val="solid"/>
+                      <a:round/>
+                      <a:headEnd type="none" w="med" len="med"/>
+                      <a:tailEnd type="none" w="med" len="med"/>
+                    </a:lnR>
+                    <a:lnT w="9525" cap="flat" cmpd="sng" algn="ctr">
+                      <a:solidFill>
+                        <a:srgbClr val="D5DDE3"/>
+                      </a:solidFill>
+                      <a:prstDash val="solid"/>
+                      <a:round/>
+                      <a:headEnd type="none" w="med" len="med"/>
+                      <a:tailEnd type="none" w="med" len="med"/>
+                    </a:lnT>
+                    <a:lnB w="9525" cap="flat" cmpd="sng" algn="ctr">
+                      <a:solidFill>
+                        <a:srgbClr val="D5DDE3"/>
+                      </a:solidFill>
+                      <a:prstDash val="solid"/>
+                      <a:round/>
+                      <a:headEnd type="none" w="med" len="med"/>
+                      <a:tailEnd type="none" w="med" len="med"/>
+                    </a:lnB>
+                  </a:tcPr>
+                </a:tc>
+                <a:tc>
+                  <a:txBody>
+                    <a:bodyPr/>
+                    <a:lstStyle/>
+                    <a:p>
+                      <a:pPr algn="ctr" indent="0" marL="0">
+                        <a:buNone/>
+                      </a:pPr>
+                      <a:r>
+                        <a:rPr lang="en-US" sz="1200" dirty="0">
+                          <a:solidFill>
+                            <a:srgbClr val="1B2A38"/>
+                          </a:solidFill>
+                          <a:latin typeface="Calibri" pitchFamily="34" charset="0"/>
+                          <a:ea typeface="Calibri" pitchFamily="34" charset="-122"/>
+                          <a:cs typeface="Calibri" pitchFamily="34" charset="-120"/>
+                        </a:rPr>
+                        <a:t>96.66</a:t>
+                      </a:r>
+                      <a:endParaRPr lang="en-US" sz="1200" dirty="0">
+                        <a:latin typeface="Calibri" charset="0"/>
+                        <a:ea typeface="Calibri" charset="0"/>
+                        <a:cs typeface="Calibri" charset="0"/>
+                      </a:endParaRPr>
+                    </a:p>
+                  </a:txBody>
+                  <a:tcPr marL="91440" marR="91440" marT="45720" marB="45720">
+                    <a:lnL w="9525" cap="flat" cmpd="sng" algn="ctr">
+                      <a:solidFill>
+                        <a:srgbClr val="D5DDE3"/>
+                      </a:solidFill>
+                      <a:prstDash val="solid"/>
+                      <a:round/>
+                      <a:headEnd type="none" w="med" len="med"/>
+                      <a:tailEnd type="none" w="med" len="med"/>
+                    </a:lnL>
+                    <a:lnR w="9525" cap="flat" cmpd="sng" algn="ctr">
+                      <a:solidFill>
+                        <a:srgbClr val="D5DDE3"/>
+                      </a:solidFill>
+                      <a:prstDash val="solid"/>
+                      <a:round/>
+                      <a:headEnd type="none" w="med" len="med"/>
+                      <a:tailEnd type="none" w="med" len="med"/>
+                    </a:lnR>
+                    <a:lnT w="9525" cap="flat" cmpd="sng" algn="ctr">
+                      <a:solidFill>
+                        <a:srgbClr val="D5DDE3"/>
+                      </a:solidFill>
+                      <a:prstDash val="solid"/>
+                      <a:round/>
+                      <a:headEnd type="none" w="med" len="med"/>
+                      <a:tailEnd type="none" w="med" len="med"/>
+                    </a:lnT>
+                    <a:lnB w="9525" cap="flat" cmpd="sng" algn="ctr">
+                      <a:solidFill>
+                        <a:srgbClr val="D5DDE3"/>
+                      </a:solidFill>
+                      <a:prstDash val="solid"/>
+                      <a:round/>
+                      <a:headEnd type="none" w="med" len="med"/>
+                      <a:tailEnd type="none" w="med" len="med"/>
+                    </a:lnB>
+                  </a:tcPr>
+                </a:tc>
+              </a:tr>
+              <a:tr h="310896">
+                <a:tc>
+                  <a:txBody>
+                    <a:bodyPr/>
+                    <a:lstStyle/>
+                    <a:p>
+                      <a:pPr algn="l" indent="0" marL="0">
+                        <a:buNone/>
+                      </a:pPr>
+                      <a:r>
+                        <a:rPr lang="en-US" sz="1200" dirty="0">
+                          <a:solidFill>
+                            <a:srgbClr val="1B2A38"/>
+                          </a:solidFill>
+                          <a:latin typeface="Calibri" pitchFamily="34" charset="0"/>
+                          <a:ea typeface="Calibri" pitchFamily="34" charset="-122"/>
+                          <a:cs typeface="Calibri" pitchFamily="34" charset="-120"/>
+                        </a:rPr>
+                        <a:t>No neighbour attention, message</a:t>
+                      </a:r>
+                      <a:endParaRPr lang="en-US" sz="1200" dirty="0">
+                        <a:latin typeface="Calibri" charset="0"/>
+                        <a:ea typeface="Calibri" charset="0"/>
+                        <a:cs typeface="Calibri" charset="0"/>
+                      </a:endParaRPr>
+                    </a:p>
+                  </a:txBody>
+                  <a:tcPr marL="91440" marR="91440" marT="45720" marB="45720">
+                    <a:lnL w="9525" cap="flat" cmpd="sng" algn="ctr">
+                      <a:solidFill>
+                        <a:srgbClr val="D5DDE3"/>
+                      </a:solidFill>
+                      <a:prstDash val="solid"/>
+                      <a:round/>
+                      <a:headEnd type="none" w="med" len="med"/>
+                      <a:tailEnd type="none" w="med" len="med"/>
+                    </a:lnL>
+                    <a:lnR w="9525" cap="flat" cmpd="sng" algn="ctr">
+                      <a:solidFill>
+                        <a:srgbClr val="D5DDE3"/>
+                      </a:solidFill>
+                      <a:prstDash val="solid"/>
+                      <a:round/>
+                      <a:headEnd type="none" w="med" len="med"/>
+                      <a:tailEnd type="none" w="med" len="med"/>
+                    </a:lnR>
+                    <a:lnT w="9525" cap="flat" cmpd="sng" algn="ctr">
+                      <a:solidFill>
+                        <a:srgbClr val="D5DDE3"/>
+                      </a:solidFill>
+                      <a:prstDash val="solid"/>
+                      <a:round/>
+                      <a:headEnd type="none" w="med" len="med"/>
+                      <a:tailEnd type="none" w="med" len="med"/>
+                    </a:lnT>
+                    <a:lnB w="9525" cap="flat" cmpd="sng" algn="ctr">
+                      <a:solidFill>
+                        <a:srgbClr val="D5DDE3"/>
+                      </a:solidFill>
+                      <a:prstDash val="solid"/>
+                      <a:round/>
+                      <a:headEnd type="none" w="med" len="med"/>
+                      <a:tailEnd type="none" w="med" len="med"/>
+                    </a:lnB>
+                  </a:tcPr>
+                </a:tc>
+                <a:tc>
+                  <a:txBody>
+                    <a:bodyPr/>
+                    <a:lstStyle/>
+                    <a:p>
+                      <a:pPr algn="ctr" indent="0" marL="0">
+                        <a:buNone/>
+                      </a:pPr>
+                      <a:r>
+                        <a:rPr lang="en-US" sz="1200" dirty="0">
+                          <a:solidFill>
+                            <a:srgbClr val="1B2A38"/>
+                          </a:solidFill>
+                          <a:latin typeface="Calibri" pitchFamily="34" charset="0"/>
+                          <a:ea typeface="Calibri" pitchFamily="34" charset="-122"/>
+                          <a:cs typeface="Calibri" pitchFamily="34" charset="-120"/>
+                        </a:rPr>
+                        <a:t>96.28</a:t>
+                      </a:r>
+                      <a:endParaRPr lang="en-US" sz="1200" dirty="0">
+                        <a:latin typeface="Calibri" charset="0"/>
+                        <a:ea typeface="Calibri" charset="0"/>
+                        <a:cs typeface="Calibri" charset="0"/>
+                      </a:endParaRPr>
+                    </a:p>
+                  </a:txBody>
+                  <a:tcPr marL="91440" marR="91440" marT="45720" marB="45720">
+                    <a:lnL w="9525" cap="flat" cmpd="sng" algn="ctr">
+                      <a:solidFill>
+                        <a:srgbClr val="D5DDE3"/>
+                      </a:solidFill>
+                      <a:prstDash val="solid"/>
+                      <a:round/>
+                      <a:headEnd type="none" w="med" len="med"/>
+                      <a:tailEnd type="none" w="med" len="med"/>
+                    </a:lnL>
+                    <a:lnR w="9525" cap="flat" cmpd="sng" algn="ctr">
+                      <a:solidFill>
+                        <a:srgbClr val="D5DDE3"/>
+                      </a:solidFill>
+                      <a:prstDash val="solid"/>
+                      <a:round/>
+                      <a:headEnd type="none" w="med" len="med"/>
+                      <a:tailEnd type="none" w="med" len="med"/>
+                    </a:lnR>
+                    <a:lnT w="9525" cap="flat" cmpd="sng" algn="ctr">
+                      <a:solidFill>
+                        <a:srgbClr val="D5DDE3"/>
+                      </a:solidFill>
+                      <a:prstDash val="solid"/>
+                      <a:round/>
+                      <a:headEnd type="none" w="med" len="med"/>
+                      <a:tailEnd type="none" w="med" len="med"/>
+                    </a:lnT>
+                    <a:lnB w="9525" cap="flat" cmpd="sng" algn="ctr">
+                      <a:solidFill>
+                        <a:srgbClr val="D5DDE3"/>
+                      </a:solidFill>
+                      <a:prstDash val="solid"/>
+                      <a:round/>
+                      <a:headEnd type="none" w="med" len="med"/>
+                      <a:tailEnd type="none" w="med" len="med"/>
+                    </a:lnB>
+                  </a:tcPr>
+                </a:tc>
+                <a:tc>
+                  <a:txBody>
+                    <a:bodyPr/>
+                    <a:lstStyle/>
+                    <a:p>
+                      <a:pPr algn="ctr" indent="0" marL="0">
+                        <a:buNone/>
+                      </a:pPr>
+                      <a:r>
+                        <a:rPr lang="en-US" sz="1200" dirty="0">
+                          <a:solidFill>
+                            <a:srgbClr val="1B2A38"/>
+                          </a:solidFill>
+                          <a:latin typeface="Calibri" pitchFamily="34" charset="0"/>
+                          <a:ea typeface="Calibri" pitchFamily="34" charset="-122"/>
+                          <a:cs typeface="Calibri" pitchFamily="34" charset="-120"/>
+                        </a:rPr>
+                        <a:t>92.69</a:t>
+                      </a:r>
+                      <a:endParaRPr lang="en-US" sz="1200" dirty="0">
+                        <a:latin typeface="Calibri" charset="0"/>
+                        <a:ea typeface="Calibri" charset="0"/>
+                        <a:cs typeface="Calibri" charset="0"/>
+                      </a:endParaRPr>
+                    </a:p>
+                  </a:txBody>
+                  <a:tcPr marL="91440" marR="91440" marT="45720" marB="45720">
+                    <a:lnL w="9525" cap="flat" cmpd="sng" algn="ctr">
+                      <a:solidFill>
+                        <a:srgbClr val="D5DDE3"/>
+                      </a:solidFill>
+                      <a:prstDash val="solid"/>
+                      <a:round/>
+                      <a:headEnd type="none" w="med" len="med"/>
+                      <a:tailEnd type="none" w="med" len="med"/>
+                    </a:lnL>
+                    <a:lnR w="9525" cap="flat" cmpd="sng" algn="ctr">
+                      <a:solidFill>
+                        <a:srgbClr val="D5DDE3"/>
+                      </a:solidFill>
+                      <a:prstDash val="solid"/>
+                      <a:round/>
+                      <a:headEnd type="none" w="med" len="med"/>
+                      <a:tailEnd type="none" w="med" len="med"/>
+                    </a:lnR>
+                    <a:lnT w="9525" cap="flat" cmpd="sng" algn="ctr">
+                      <a:solidFill>
+                        <a:srgbClr val="D5DDE3"/>
+                      </a:solidFill>
+                      <a:prstDash val="solid"/>
+                      <a:round/>
+                      <a:headEnd type="none" w="med" len="med"/>
+                      <a:tailEnd type="none" w="med" len="med"/>
+                    </a:lnT>
+                    <a:lnB w="9525" cap="flat" cmpd="sng" algn="ctr">
+                      <a:solidFill>
+                        <a:srgbClr val="D5DDE3"/>
+                      </a:solidFill>
+                      <a:prstDash val="solid"/>
+                      <a:round/>
+                      <a:headEnd type="none" w="med" len="med"/>
+                      <a:tailEnd type="none" w="med" len="med"/>
+                    </a:lnB>
+                  </a:tcPr>
+                </a:tc>
+                <a:tc>
+                  <a:txBody>
+                    <a:bodyPr/>
+                    <a:lstStyle/>
+                    <a:p>
+                      <a:pPr algn="ctr" indent="0" marL="0">
+                        <a:buNone/>
+                      </a:pPr>
+                      <a:r>
+                        <a:rPr lang="en-US" sz="1200" dirty="0">
+                          <a:solidFill>
+                            <a:srgbClr val="1B2A38"/>
+                          </a:solidFill>
+                          <a:latin typeface="Calibri" pitchFamily="34" charset="0"/>
+                          <a:ea typeface="Calibri" pitchFamily="34" charset="-122"/>
+                          <a:cs typeface="Calibri" pitchFamily="34" charset="-120"/>
+                        </a:rPr>
+                        <a:t>94.45</a:t>
+                      </a:r>
+                      <a:endParaRPr lang="en-US" sz="1200" dirty="0">
+                        <a:latin typeface="Calibri" charset="0"/>
+                        <a:ea typeface="Calibri" charset="0"/>
+                        <a:cs typeface="Calibri" charset="0"/>
+                      </a:endParaRPr>
+                    </a:p>
+                  </a:txBody>
+                  <a:tcPr marL="91440" marR="91440" marT="45720" marB="45720">
+                    <a:lnL w="9525" cap="flat" cmpd="sng" algn="ctr">
+                      <a:solidFill>
+                        <a:srgbClr val="D5DDE3"/>
+                      </a:solidFill>
+                      <a:prstDash val="solid"/>
+                      <a:round/>
+                      <a:headEnd type="none" w="med" len="med"/>
+                      <a:tailEnd type="none" w="med" len="med"/>
+                    </a:lnL>
+                    <a:lnR w="9525" cap="flat" cmpd="sng" algn="ctr">
+                      <a:solidFill>
+                        <a:srgbClr val="D5DDE3"/>
+                      </a:solidFill>
+                      <a:prstDash val="solid"/>
+                      <a:round/>
+                      <a:headEnd type="none" w="med" len="med"/>
+                      <a:tailEnd type="none" w="med" len="med"/>
+                    </a:lnR>
+                    <a:lnT w="9525" cap="flat" cmpd="sng" algn="ctr">
+                      <a:solidFill>
+                        <a:srgbClr val="D5DDE3"/>
+                      </a:solidFill>
+                      <a:prstDash val="solid"/>
+                      <a:round/>
+                      <a:headEnd type="none" w="med" len="med"/>
+                      <a:tailEnd type="none" w="med" len="med"/>
+                    </a:lnT>
+                    <a:lnB w="9525" cap="flat" cmpd="sng" algn="ctr">
+                      <a:solidFill>
+                        <a:srgbClr val="D5DDE3"/>
+                      </a:solidFill>
+                      <a:prstDash val="solid"/>
+                      <a:round/>
+                      <a:headEnd type="none" w="med" len="med"/>
+                      <a:tailEnd type="none" w="med" len="med"/>
+                    </a:lnB>
+                  </a:tcPr>
+                </a:tc>
+                <a:tc>
+                  <a:txBody>
+                    <a:bodyPr/>
+                    <a:lstStyle/>
+                    <a:p>
+                      <a:pPr algn="ctr" indent="0" marL="0">
+                        <a:buNone/>
+                      </a:pPr>
+                      <a:r>
+                        <a:rPr lang="en-US" sz="1200" dirty="0">
+                          <a:solidFill>
+                            <a:srgbClr val="1B2A38"/>
+                          </a:solidFill>
+                          <a:latin typeface="Calibri" pitchFamily="34" charset="0"/>
+                          <a:ea typeface="Calibri" pitchFamily="34" charset="-122"/>
+                          <a:cs typeface="Calibri" pitchFamily="34" charset="-120"/>
+                        </a:rPr>
+                        <a:t>96.07</a:t>
+                      </a:r>
+                      <a:endParaRPr lang="en-US" sz="1200" dirty="0">
+                        <a:latin typeface="Calibri" charset="0"/>
+                        <a:ea typeface="Calibri" charset="0"/>
+                        <a:cs typeface="Calibri" charset="0"/>
+                      </a:endParaRPr>
+                    </a:p>
+                  </a:txBody>
+                  <a:tcPr marL="91440" marR="91440" marT="45720" marB="45720">
+                    <a:lnL w="9525" cap="flat" cmpd="sng" algn="ctr">
+                      <a:solidFill>
+                        <a:srgbClr val="D5DDE3"/>
+                      </a:solidFill>
+                      <a:prstDash val="solid"/>
+                      <a:round/>
+                      <a:headEnd type="none" w="med" len="med"/>
+                      <a:tailEnd type="none" w="med" len="med"/>
+                    </a:lnL>
+                    <a:lnR w="9525" cap="flat" cmpd="sng" algn="ctr">
+                      <a:solidFill>
+                        <a:srgbClr val="D5DDE3"/>
+                      </a:solidFill>
+                      <a:prstDash val="solid"/>
+                      <a:round/>
+                      <a:headEnd type="none" w="med" len="med"/>
+                      <a:tailEnd type="none" w="med" len="med"/>
+                    </a:lnR>
+                    <a:lnT w="9525" cap="flat" cmpd="sng" algn="ctr">
+                      <a:solidFill>
+                        <a:srgbClr val="D5DDE3"/>
+                      </a:solidFill>
+                      <a:prstDash val="solid"/>
+                      <a:round/>
+                      <a:headEnd type="none" w="med" len="med"/>
+                      <a:tailEnd type="none" w="med" len="med"/>
+                    </a:lnT>
+                    <a:lnB w="9525" cap="flat" cmpd="sng" algn="ctr">
+                      <a:solidFill>
+                        <a:srgbClr val="D5DDE3"/>
+                      </a:solidFill>
+                      <a:prstDash val="solid"/>
+                      <a:round/>
+                      <a:headEnd type="none" w="med" len="med"/>
+                      <a:tailEnd type="none" w="med" len="med"/>
+                    </a:lnB>
+                  </a:tcPr>
+                </a:tc>
+              </a:tr>
+            </a:tbl>
+          </a:graphicData>
+        </a:graphic>
+      </p:graphicFrame>
+      <p:graphicFrame>
+        <p:nvGraphicFramePr>
+          <p:cNvPr id="19" name="Table 1"/>
+          <p:cNvGraphicFramePr>
+            <a:graphicFrameLocks noGrp="1"/>
+          </p:cNvGraphicFramePr>
+          <p:nvPr>
+            <p:extLst>
+              <p:ext uri="{D42A27DB-BD31-4B8C-83A1-F6EECF244321}">
+                <p14:modId xmlns:p14="http://schemas.microsoft.com/office/powerpoint/2010/main" val="1579011935"/>
+              </p:ext>
+            </p:extLst>
+          </p:nvPr>
+        </p:nvGraphicFramePr>
+        <p:xfrm>
+          <a:off x="5897880" y="1051560"/>
+          <a:ext cx="2743200" cy="914400"/>
+        </p:xfrm>
+        <a:graphic>
+          <a:graphicData uri="http://schemas.openxmlformats.org/drawingml/2006/table">
+            <a:tbl>
+              <a:tblPr/>
+              <a:tblGrid>
+                <a:gridCol w="2011680"/>
+                <a:gridCol w="731520"/>
+              </a:tblGrid>
+              <a:tr h="310896">
+                <a:tc>
+                  <a:txBody>
+                    <a:bodyPr/>
+                    <a:lstStyle/>
+                    <a:p>
+                      <a:pPr algn="ctr" indent="0" marL="0">
+                        <a:buNone/>
+                      </a:pPr>
+                      <a:r>
+                        <a:rPr lang="en-US" sz="1200" b="1" dirty="0">
+                          <a:solidFill>
+                            <a:srgbClr val="FFFFFF"/>
+                          </a:solidFill>
+                          <a:latin typeface="Calibri" pitchFamily="34" charset="0"/>
+                          <a:ea typeface="Calibri" pitchFamily="34" charset="-122"/>
+                          <a:cs typeface="Calibri" pitchFamily="34" charset="-120"/>
+                        </a:rPr>
+                        <a:t>Sybil attack</a:t>
+                      </a:r>
+                      <a:endParaRPr lang="en-US" sz="1200" dirty="0">
+                        <a:latin typeface="Calibri" charset="0"/>
+                        <a:ea typeface="Calibri" charset="0"/>
+                        <a:cs typeface="Calibri" charset="0"/>
+                      </a:endParaRPr>
+                    </a:p>
+                  </a:txBody>
+                  <a:tcPr marL="91440" marR="91440" marT="45720" marB="45720">
+                    <a:lnL w="9525" cap="flat" cmpd="sng" algn="ctr">
+                      <a:solidFill>
+                        <a:srgbClr val="D5DDE3"/>
+                      </a:solidFill>
+                      <a:prstDash val="solid"/>
+                      <a:round/>
+                      <a:headEnd type="none" w="med" len="med"/>
+                      <a:tailEnd type="none" w="med" len="med"/>
+                    </a:lnL>
+                    <a:lnR w="9525" cap="flat" cmpd="sng" algn="ctr">
+                      <a:solidFill>
+                        <a:srgbClr val="D5DDE3"/>
+                      </a:solidFill>
+                      <a:prstDash val="solid"/>
+                      <a:round/>
+                      <a:headEnd type="none" w="med" len="med"/>
+                      <a:tailEnd type="none" w="med" len="med"/>
+                    </a:lnR>
+                    <a:lnT w="9525" cap="flat" cmpd="sng" algn="ctr">
+                      <a:solidFill>
+                        <a:srgbClr val="D5DDE3"/>
+                      </a:solidFill>
+                      <a:prstDash val="solid"/>
+                      <a:round/>
+                      <a:headEnd type="none" w="med" len="med"/>
+                      <a:tailEnd type="none" w="med" len="med"/>
+                    </a:lnT>
+                    <a:lnB w="9525" cap="flat" cmpd="sng" algn="ctr">
+                      <a:solidFill>
+                        <a:srgbClr val="D5DDE3"/>
+                      </a:solidFill>
+                      <a:prstDash val="solid"/>
+                      <a:round/>
+                      <a:headEnd type="none" w="med" len="med"/>
+                      <a:tailEnd type="none" w="med" len="med"/>
+                    </a:lnB>
+                    <a:solidFill>
+                      <a:srgbClr val="0B1F33"/>
+                    </a:solidFill>
+                  </a:tcPr>
+                </a:tc>
+                <a:tc>
+                  <a:txBody>
+                    <a:bodyPr/>
+                    <a:lstStyle/>
+                    <a:p>
+                      <a:pPr algn="ctr" indent="0" marL="0">
+                        <a:buNone/>
+                      </a:pPr>
+                      <a:r>
+                        <a:rPr lang="en-US" sz="1200" b="1" dirty="0">
+                          <a:solidFill>
+                            <a:srgbClr val="FFFFFF"/>
+                          </a:solidFill>
+                          <a:latin typeface="Calibri" pitchFamily="34" charset="0"/>
+                          <a:ea typeface="Calibri" pitchFamily="34" charset="-122"/>
+                          <a:cs typeface="Calibri" pitchFamily="34" charset="-120"/>
+                        </a:rPr>
+                        <a:t>Recall</a:t>
+                      </a:r>
+                      <a:endParaRPr lang="en-US" sz="1200" dirty="0">
+                        <a:latin typeface="Calibri" charset="0"/>
+                        <a:ea typeface="Calibri" charset="0"/>
+                        <a:cs typeface="Calibri" charset="0"/>
+                      </a:endParaRPr>
+                    </a:p>
+                  </a:txBody>
+                  <a:tcPr marL="91440" marR="91440" marT="45720" marB="45720">
+                    <a:lnL w="9525" cap="flat" cmpd="sng" algn="ctr">
+                      <a:solidFill>
+                        <a:srgbClr val="D5DDE3"/>
+                      </a:solidFill>
+                      <a:prstDash val="solid"/>
+                      <a:round/>
+                      <a:headEnd type="none" w="med" len="med"/>
+                      <a:tailEnd type="none" w="med" len="med"/>
+                    </a:lnL>
+                    <a:lnR w="9525" cap="flat" cmpd="sng" algn="ctr">
+                      <a:solidFill>
+                        <a:srgbClr val="D5DDE3"/>
+                      </a:solidFill>
+                      <a:prstDash val="solid"/>
+                      <a:round/>
+                      <a:headEnd type="none" w="med" len="med"/>
+                      <a:tailEnd type="none" w="med" len="med"/>
+                    </a:lnR>
+                    <a:lnT w="9525" cap="flat" cmpd="sng" algn="ctr">
+                      <a:solidFill>
+                        <a:srgbClr val="D5DDE3"/>
+                      </a:solidFill>
+                      <a:prstDash val="solid"/>
+                      <a:round/>
+                      <a:headEnd type="none" w="med" len="med"/>
+                      <a:tailEnd type="none" w="med" len="med"/>
+                    </a:lnT>
+                    <a:lnB w="9525" cap="flat" cmpd="sng" algn="ctr">
+                      <a:solidFill>
+                        <a:srgbClr val="D5DDE3"/>
+                      </a:solidFill>
+                      <a:prstDash val="solid"/>
+                      <a:round/>
+                      <a:headEnd type="none" w="med" len="med"/>
+                      <a:tailEnd type="none" w="med" len="med"/>
+                    </a:lnB>
+                    <a:solidFill>
+                      <a:srgbClr val="0B1F33"/>
+                    </a:solidFill>
+                  </a:tcPr>
+                </a:tc>
+              </a:tr>
+              <a:tr h="310896">
+                <a:tc>
+                  <a:txBody>
+                    <a:bodyPr/>
+                    <a:lstStyle/>
+                    <a:p>
+                      <a:pPr algn="l" indent="0" marL="0">
+                        <a:buNone/>
+                      </a:pPr>
+                      <a:r>
+                        <a:rPr lang="en-US" sz="1200" dirty="0">
+                          <a:solidFill>
+                            <a:srgbClr val="1B2A38"/>
+                          </a:solidFill>
+                          <a:latin typeface="Calibri" pitchFamily="34" charset="0"/>
+                          <a:ea typeface="Calibri" pitchFamily="34" charset="-122"/>
+                          <a:cs typeface="Calibri" pitchFamily="34" charset="-120"/>
+                        </a:rPr>
+                        <a:t>GridSybil (largest, 20,598 slots)</a:t>
+                      </a:r>
+                      <a:endParaRPr lang="en-US" sz="1200" dirty="0">
+                        <a:latin typeface="Calibri" charset="0"/>
+                        <a:ea typeface="Calibri" charset="0"/>
+                        <a:cs typeface="Calibri" charset="0"/>
+                      </a:endParaRPr>
+                    </a:p>
+                  </a:txBody>
+                  <a:tcPr marL="91440" marR="91440" marT="45720" marB="45720">
+                    <a:lnL w="9525" cap="flat" cmpd="sng" algn="ctr">
+                      <a:solidFill>
+                        <a:srgbClr val="D5DDE3"/>
+                      </a:solidFill>
+                      <a:prstDash val="solid"/>
+                      <a:round/>
+                      <a:headEnd type="none" w="med" len="med"/>
+                      <a:tailEnd type="none" w="med" len="med"/>
+                    </a:lnL>
+                    <a:lnR w="9525" cap="flat" cmpd="sng" algn="ctr">
+                      <a:solidFill>
+                        <a:srgbClr val="D5DDE3"/>
+                      </a:solidFill>
+                      <a:prstDash val="solid"/>
+                      <a:round/>
+                      <a:headEnd type="none" w="med" len="med"/>
+                      <a:tailEnd type="none" w="med" len="med"/>
+                    </a:lnR>
+                    <a:lnT w="9525" cap="flat" cmpd="sng" algn="ctr">
+                      <a:solidFill>
+                        <a:srgbClr val="D5DDE3"/>
+                      </a:solidFill>
+                      <a:prstDash val="solid"/>
+                      <a:round/>
+                      <a:headEnd type="none" w="med" len="med"/>
+                      <a:tailEnd type="none" w="med" len="med"/>
+                    </a:lnT>
+                    <a:lnB w="9525" cap="flat" cmpd="sng" algn="ctr">
+                      <a:solidFill>
+                        <a:srgbClr val="D5DDE3"/>
+                      </a:solidFill>
+                      <a:prstDash val="solid"/>
+                      <a:round/>
+                      <a:headEnd type="none" w="med" len="med"/>
+                      <a:tailEnd type="none" w="med" len="med"/>
+                    </a:lnB>
+                  </a:tcPr>
+                </a:tc>
+                <a:tc>
+                  <a:txBody>
+                    <a:bodyPr/>
+                    <a:lstStyle/>
+                    <a:p>
+                      <a:pPr algn="ctr" indent="0" marL="0">
+                        <a:buNone/>
+                      </a:pPr>
+                      <a:r>
+                        <a:rPr lang="en-US" sz="1200" b="1" dirty="0">
+                          <a:solidFill>
+                            <a:srgbClr val="1B2A38"/>
+                          </a:solidFill>
+                          <a:latin typeface="Calibri" pitchFamily="34" charset="0"/>
+                          <a:ea typeface="Calibri" pitchFamily="34" charset="-122"/>
+                          <a:cs typeface="Calibri" pitchFamily="34" charset="-120"/>
+                        </a:rPr>
+                        <a:t>0.823</a:t>
+                      </a:r>
+                      <a:endParaRPr lang="en-US" sz="1200" dirty="0">
+                        <a:latin typeface="Calibri" charset="0"/>
+                        <a:ea typeface="Calibri" charset="0"/>
+                        <a:cs typeface="Calibri" charset="0"/>
+                      </a:endParaRPr>
+                    </a:p>
+                  </a:txBody>
+                  <a:tcPr marL="91440" marR="91440" marT="45720" marB="45720">
+                    <a:lnL w="9525" cap="flat" cmpd="sng" algn="ctr">
+                      <a:solidFill>
+                        <a:srgbClr val="D5DDE3"/>
+                      </a:solidFill>
+                      <a:prstDash val="solid"/>
+                      <a:round/>
+                      <a:headEnd type="none" w="med" len="med"/>
+                      <a:tailEnd type="none" w="med" len="med"/>
+                    </a:lnL>
+                    <a:lnR w="9525" cap="flat" cmpd="sng" algn="ctr">
+                      <a:solidFill>
+                        <a:srgbClr val="D5DDE3"/>
+                      </a:solidFill>
+                      <a:prstDash val="solid"/>
+                      <a:round/>
+                      <a:headEnd type="none" w="med" len="med"/>
+                      <a:tailEnd type="none" w="med" len="med"/>
+                    </a:lnR>
+                    <a:lnT w="9525" cap="flat" cmpd="sng" algn="ctr">
+                      <a:solidFill>
+                        <a:srgbClr val="D5DDE3"/>
+                      </a:solidFill>
+                      <a:prstDash val="solid"/>
+                      <a:round/>
+                      <a:headEnd type="none" w="med" len="med"/>
+                      <a:tailEnd type="none" w="med" len="med"/>
+                    </a:lnT>
+                    <a:lnB w="9525" cap="flat" cmpd="sng" algn="ctr">
+                      <a:solidFill>
+                        <a:srgbClr val="D5DDE3"/>
+                      </a:solidFill>
+                      <a:prstDash val="solid"/>
+                      <a:round/>
+                      <a:headEnd type="none" w="med" len="med"/>
+                      <a:tailEnd type="none" w="med" len="med"/>
+                    </a:lnB>
+                  </a:tcPr>
+                </a:tc>
+              </a:tr>
+              <a:tr h="310896">
+                <a:tc>
+                  <a:txBody>
+                    <a:bodyPr/>
+                    <a:lstStyle/>
+                    <a:p>
+                      <a:pPr algn="l" indent="0" marL="0">
+                        <a:buNone/>
+                      </a:pPr>
+                      <a:r>
+                        <a:rPr lang="en-US" sz="1200" dirty="0">
+                          <a:solidFill>
+                            <a:srgbClr val="1B2A38"/>
+                          </a:solidFill>
+                          <a:latin typeface="Calibri" pitchFamily="34" charset="0"/>
+                          <a:ea typeface="Calibri" pitchFamily="34" charset="-122"/>
+                          <a:cs typeface="Calibri" pitchFamily="34" charset="-120"/>
+                        </a:rPr>
+                        <a:t>DataReplaySybil</a:t>
+                      </a:r>
+                      <a:endParaRPr lang="en-US" sz="1200" dirty="0">
+                        <a:latin typeface="Calibri" charset="0"/>
+                        <a:ea typeface="Calibri" charset="0"/>
+                        <a:cs typeface="Calibri" charset="0"/>
+                      </a:endParaRPr>
+                    </a:p>
+                  </a:txBody>
+                  <a:tcPr marL="91440" marR="91440" marT="45720" marB="45720">
+                    <a:lnL w="9525" cap="flat" cmpd="sng" algn="ctr">
+                      <a:solidFill>
+                        <a:srgbClr val="D5DDE3"/>
+                      </a:solidFill>
+                      <a:prstDash val="solid"/>
+                      <a:round/>
+                      <a:headEnd type="none" w="med" len="med"/>
+                      <a:tailEnd type="none" w="med" len="med"/>
+                    </a:lnL>
+                    <a:lnR w="9525" cap="flat" cmpd="sng" algn="ctr">
+                      <a:solidFill>
+                        <a:srgbClr val="D5DDE3"/>
+                      </a:solidFill>
+                      <a:prstDash val="solid"/>
+                      <a:round/>
+                      <a:headEnd type="none" w="med" len="med"/>
+                      <a:tailEnd type="none" w="med" len="med"/>
+                    </a:lnR>
+                    <a:lnT w="9525" cap="flat" cmpd="sng" algn="ctr">
+                      <a:solidFill>
+                        <a:srgbClr val="D5DDE3"/>
+                      </a:solidFill>
+                      <a:prstDash val="solid"/>
+                      <a:round/>
+                      <a:headEnd type="none" w="med" len="med"/>
+                      <a:tailEnd type="none" w="med" len="med"/>
+                    </a:lnT>
+                    <a:lnB w="9525" cap="flat" cmpd="sng" algn="ctr">
+                      <a:solidFill>
+                        <a:srgbClr val="D5DDE3"/>
+                      </a:solidFill>
+                      <a:prstDash val="solid"/>
+                      <a:round/>
+                      <a:headEnd type="none" w="med" len="med"/>
+                      <a:tailEnd type="none" w="med" len="med"/>
+                    </a:lnB>
+                  </a:tcPr>
+                </a:tc>
+                <a:tc>
+                  <a:txBody>
+                    <a:bodyPr/>
+                    <a:lstStyle/>
+                    <a:p>
+                      <a:pPr algn="ctr" indent="0" marL="0">
+                        <a:buNone/>
+                      </a:pPr>
+                      <a:r>
+                        <a:rPr lang="en-US" sz="1200" dirty="0">
+                          <a:solidFill>
+                            <a:srgbClr val="1B2A38"/>
+                          </a:solidFill>
+                          <a:latin typeface="Calibri" pitchFamily="34" charset="0"/>
+                          <a:ea typeface="Calibri" pitchFamily="34" charset="-122"/>
+                          <a:cs typeface="Calibri" pitchFamily="34" charset="-120"/>
+                        </a:rPr>
+                        <a:t>0.914</a:t>
+                      </a:r>
+                      <a:endParaRPr lang="en-US" sz="1200" dirty="0">
+                        <a:latin typeface="Calibri" charset="0"/>
+                        <a:ea typeface="Calibri" charset="0"/>
+                        <a:cs typeface="Calibri" charset="0"/>
+                      </a:endParaRPr>
+                    </a:p>
+                  </a:txBody>
+                  <a:tcPr marL="91440" marR="91440" marT="45720" marB="45720">
+                    <a:lnL w="9525" cap="flat" cmpd="sng" algn="ctr">
+                      <a:solidFill>
+                        <a:srgbClr val="D5DDE3"/>
+                      </a:solidFill>
+                      <a:prstDash val="solid"/>
+                      <a:round/>
+                      <a:headEnd type="none" w="med" len="med"/>
+                      <a:tailEnd type="none" w="med" len="med"/>
+                    </a:lnL>
+                    <a:lnR w="9525" cap="flat" cmpd="sng" algn="ctr">
+                      <a:solidFill>
+                        <a:srgbClr val="D5DDE3"/>
+                      </a:solidFill>
+                      <a:prstDash val="solid"/>
+                      <a:round/>
+                      <a:headEnd type="none" w="med" len="med"/>
+                      <a:tailEnd type="none" w="med" len="med"/>
+                    </a:lnR>
+                    <a:lnT w="9525" cap="flat" cmpd="sng" algn="ctr">
+                      <a:solidFill>
+                        <a:srgbClr val="D5DDE3"/>
+                      </a:solidFill>
+                      <a:prstDash val="solid"/>
+                      <a:round/>
+                      <a:headEnd type="none" w="med" len="med"/>
+                      <a:tailEnd type="none" w="med" len="med"/>
+                    </a:lnT>
+                    <a:lnB w="9525" cap="flat" cmpd="sng" algn="ctr">
+                      <a:solidFill>
+                        <a:srgbClr val="D5DDE3"/>
+                      </a:solidFill>
+                      <a:prstDash val="solid"/>
+                      <a:round/>
+                      <a:headEnd type="none" w="med" len="med"/>
+                      <a:tailEnd type="none" w="med" len="med"/>
+                    </a:lnB>
+                  </a:tcPr>
+                </a:tc>
+              </a:tr>
+              <a:tr h="310896">
+                <a:tc>
+                  <a:txBody>
+                    <a:bodyPr/>
+                    <a:lstStyle/>
+                    <a:p>
+                      <a:pPr algn="l" indent="0" marL="0">
+                        <a:buNone/>
+                      </a:pPr>
+                      <a:r>
+                        <a:rPr lang="en-US" sz="1200" dirty="0">
+                          <a:solidFill>
+                            <a:srgbClr val="1B2A38"/>
+                          </a:solidFill>
+                          <a:latin typeface="Calibri" pitchFamily="34" charset="0"/>
+                          <a:ea typeface="Calibri" pitchFamily="34" charset="-122"/>
+                          <a:cs typeface="Calibri" pitchFamily="34" charset="-120"/>
+                        </a:rPr>
+                        <a:t>DoSDisruptiveSybil</a:t>
+                      </a:r>
+                      <a:endParaRPr lang="en-US" sz="1200" dirty="0">
+                        <a:latin typeface="Calibri" charset="0"/>
+                        <a:ea typeface="Calibri" charset="0"/>
+                        <a:cs typeface="Calibri" charset="0"/>
+                      </a:endParaRPr>
+                    </a:p>
+                  </a:txBody>
+                  <a:tcPr marL="91440" marR="91440" marT="45720" marB="45720">
+                    <a:lnL w="9525" cap="flat" cmpd="sng" algn="ctr">
+                      <a:solidFill>
+                        <a:srgbClr val="D5DDE3"/>
+                      </a:solidFill>
+                      <a:prstDash val="solid"/>
+                      <a:round/>
+                      <a:headEnd type="none" w="med" len="med"/>
+                      <a:tailEnd type="none" w="med" len="med"/>
+                    </a:lnL>
+                    <a:lnR w="9525" cap="flat" cmpd="sng" algn="ctr">
+                      <a:solidFill>
+                        <a:srgbClr val="D5DDE3"/>
+                      </a:solidFill>
+                      <a:prstDash val="solid"/>
+                      <a:round/>
+                      <a:headEnd type="none" w="med" len="med"/>
+                      <a:tailEnd type="none" w="med" len="med"/>
+                    </a:lnR>
+                    <a:lnT w="9525" cap="flat" cmpd="sng" algn="ctr">
+                      <a:solidFill>
+                        <a:srgbClr val="D5DDE3"/>
+                      </a:solidFill>
+                      <a:prstDash val="solid"/>
+                      <a:round/>
+                      <a:headEnd type="none" w="med" len="med"/>
+                      <a:tailEnd type="none" w="med" len="med"/>
+                    </a:lnT>
+                    <a:lnB w="9525" cap="flat" cmpd="sng" algn="ctr">
+                      <a:solidFill>
+                        <a:srgbClr val="D5DDE3"/>
+                      </a:solidFill>
+                      <a:prstDash val="solid"/>
+                      <a:round/>
+                      <a:headEnd type="none" w="med" len="med"/>
+                      <a:tailEnd type="none" w="med" len="med"/>
+                    </a:lnB>
+                  </a:tcPr>
+                </a:tc>
+                <a:tc>
+                  <a:txBody>
+                    <a:bodyPr/>
+                    <a:lstStyle/>
+                    <a:p>
+                      <a:pPr algn="ctr" indent="0" marL="0">
+                        <a:buNone/>
+                      </a:pPr>
+                      <a:r>
+                        <a:rPr lang="en-US" sz="1200" dirty="0">
+                          <a:solidFill>
+                            <a:srgbClr val="1B2A38"/>
+                          </a:solidFill>
+                          <a:latin typeface="Calibri" pitchFamily="34" charset="0"/>
+                          <a:ea typeface="Calibri" pitchFamily="34" charset="-122"/>
+                          <a:cs typeface="Calibri" pitchFamily="34" charset="-120"/>
+                        </a:rPr>
+                        <a:t>0.969</a:t>
+                      </a:r>
+                      <a:endParaRPr lang="en-US" sz="1200" dirty="0">
+                        <a:latin typeface="Calibri" charset="0"/>
+                        <a:ea typeface="Calibri" charset="0"/>
+                        <a:cs typeface="Calibri" charset="0"/>
+                      </a:endParaRPr>
+                    </a:p>
+                  </a:txBody>
+                  <a:tcPr marL="91440" marR="91440" marT="45720" marB="45720">
+                    <a:lnL w="9525" cap="flat" cmpd="sng" algn="ctr">
+                      <a:solidFill>
+                        <a:srgbClr val="D5DDE3"/>
+                      </a:solidFill>
+                      <a:prstDash val="solid"/>
+                      <a:round/>
+                      <a:headEnd type="none" w="med" len="med"/>
+                      <a:tailEnd type="none" w="med" len="med"/>
+                    </a:lnL>
+                    <a:lnR w="9525" cap="flat" cmpd="sng" algn="ctr">
+                      <a:solidFill>
+                        <a:srgbClr val="D5DDE3"/>
+                      </a:solidFill>
+                      <a:prstDash val="solid"/>
+                      <a:round/>
+                      <a:headEnd type="none" w="med" len="med"/>
+                      <a:tailEnd type="none" w="med" len="med"/>
+                    </a:lnR>
+                    <a:lnT w="9525" cap="flat" cmpd="sng" algn="ctr">
+                      <a:solidFill>
+                        <a:srgbClr val="D5DDE3"/>
+                      </a:solidFill>
+                      <a:prstDash val="solid"/>
+                      <a:round/>
+                      <a:headEnd type="none" w="med" len="med"/>
+                      <a:tailEnd type="none" w="med" len="med"/>
+                    </a:lnT>
+                    <a:lnB w="9525" cap="flat" cmpd="sng" algn="ctr">
+                      <a:solidFill>
+                        <a:srgbClr val="D5DDE3"/>
+                      </a:solidFill>
+                      <a:prstDash val="solid"/>
+                      <a:round/>
+                      <a:headEnd type="none" w="med" len="med"/>
+                      <a:tailEnd type="none" w="med" len="med"/>
+                    </a:lnB>
+                  </a:tcPr>
+                </a:tc>
+              </a:tr>
+              <a:tr h="310896">
+                <a:tc>
+                  <a:txBody>
+                    <a:bodyPr/>
+                    <a:lstStyle/>
+                    <a:p>
+                      <a:pPr algn="l" indent="0" marL="0">
+                        <a:buNone/>
+                      </a:pPr>
+                      <a:r>
+                        <a:rPr lang="en-US" sz="1200" dirty="0">
+                          <a:solidFill>
+                            <a:srgbClr val="1B2A38"/>
+                          </a:solidFill>
+                          <a:latin typeface="Calibri" pitchFamily="34" charset="0"/>
+                          <a:ea typeface="Calibri" pitchFamily="34" charset="-122"/>
+                          <a:cs typeface="Calibri" pitchFamily="34" charset="-120"/>
+                        </a:rPr>
+                        <a:t>DoSRandomSybil</a:t>
+                      </a:r>
+                      <a:endParaRPr lang="en-US" sz="1200" dirty="0">
+                        <a:latin typeface="Calibri" charset="0"/>
+                        <a:ea typeface="Calibri" charset="0"/>
+                        <a:cs typeface="Calibri" charset="0"/>
+                      </a:endParaRPr>
+                    </a:p>
+                  </a:txBody>
+                  <a:tcPr marL="91440" marR="91440" marT="45720" marB="45720">
+                    <a:lnL w="9525" cap="flat" cmpd="sng" algn="ctr">
+                      <a:solidFill>
+                        <a:srgbClr val="D5DDE3"/>
+                      </a:solidFill>
+                      <a:prstDash val="solid"/>
+                      <a:round/>
+                      <a:headEnd type="none" w="med" len="med"/>
+                      <a:tailEnd type="none" w="med" len="med"/>
+                    </a:lnL>
+                    <a:lnR w="9525" cap="flat" cmpd="sng" algn="ctr">
+                      <a:solidFill>
+                        <a:srgbClr val="D5DDE3"/>
+                      </a:solidFill>
+                      <a:prstDash val="solid"/>
+                      <a:round/>
+                      <a:headEnd type="none" w="med" len="med"/>
+                      <a:tailEnd type="none" w="med" len="med"/>
+                    </a:lnR>
+                    <a:lnT w="9525" cap="flat" cmpd="sng" algn="ctr">
+                      <a:solidFill>
+                        <a:srgbClr val="D5DDE3"/>
+                      </a:solidFill>
+                      <a:prstDash val="solid"/>
+                      <a:round/>
+                      <a:headEnd type="none" w="med" len="med"/>
+                      <a:tailEnd type="none" w="med" len="med"/>
+                    </a:lnT>
+                    <a:lnB w="9525" cap="flat" cmpd="sng" algn="ctr">
+                      <a:solidFill>
+                        <a:srgbClr val="D5DDE3"/>
+                      </a:solidFill>
+                      <a:prstDash val="solid"/>
+                      <a:round/>
+                      <a:headEnd type="none" w="med" len="med"/>
+                      <a:tailEnd type="none" w="med" len="med"/>
+                    </a:lnB>
+                  </a:tcPr>
+                </a:tc>
+                <a:tc>
+                  <a:txBody>
+                    <a:bodyPr/>
+                    <a:lstStyle/>
+                    <a:p>
+                      <a:pPr algn="ctr" indent="0" marL="0">
+                        <a:buNone/>
+                      </a:pPr>
+                      <a:r>
+                        <a:rPr lang="en-US" sz="1200" dirty="0">
+                          <a:solidFill>
+                            <a:srgbClr val="1B2A38"/>
+                          </a:solidFill>
+                          <a:latin typeface="Calibri" pitchFamily="34" charset="0"/>
+                          <a:ea typeface="Calibri" pitchFamily="34" charset="-122"/>
+                          <a:cs typeface="Calibri" pitchFamily="34" charset="-120"/>
+                        </a:rPr>
+                        <a:t>0.997</a:t>
+                      </a:r>
+                      <a:endParaRPr lang="en-US" sz="1200" dirty="0">
+                        <a:latin typeface="Calibri" charset="0"/>
+                        <a:ea typeface="Calibri" charset="0"/>
+                        <a:cs typeface="Calibri" charset="0"/>
+                      </a:endParaRPr>
+                    </a:p>
+                  </a:txBody>
+                  <a:tcPr marL="91440" marR="91440" marT="45720" marB="45720">
+                    <a:lnL w="9525" cap="flat" cmpd="sng" algn="ctr">
+                      <a:solidFill>
+                        <a:srgbClr val="D5DDE3"/>
+                      </a:solidFill>
+                      <a:prstDash val="solid"/>
+                      <a:round/>
+                      <a:headEnd type="none" w="med" len="med"/>
+                      <a:tailEnd type="none" w="med" len="med"/>
+                    </a:lnL>
+                    <a:lnR w="9525" cap="flat" cmpd="sng" algn="ctr">
+                      <a:solidFill>
+                        <a:srgbClr val="D5DDE3"/>
+                      </a:solidFill>
+                      <a:prstDash val="solid"/>
+                      <a:round/>
+                      <a:headEnd type="none" w="med" len="med"/>
+                      <a:tailEnd type="none" w="med" len="med"/>
+                    </a:lnR>
+                    <a:lnT w="9525" cap="flat" cmpd="sng" algn="ctr">
+                      <a:solidFill>
+                        <a:srgbClr val="D5DDE3"/>
+                      </a:solidFill>
+                      <a:prstDash val="solid"/>
+                      <a:round/>
+                      <a:headEnd type="none" w="med" len="med"/>
+                      <a:tailEnd type="none" w="med" len="med"/>
+                    </a:lnT>
+                    <a:lnB w="9525" cap="flat" cmpd="sng" algn="ctr">
+                      <a:solidFill>
+                        <a:srgbClr val="D5DDE3"/>
+                      </a:solidFill>
+                      <a:prstDash val="solid"/>
+                      <a:round/>
+                      <a:headEnd type="none" w="med" len="med"/>
+                      <a:tailEnd type="none" w="med" len="med"/>
+                    </a:lnB>
+                  </a:tcPr>
+                </a:tc>
+              </a:tr>
+            </a:tbl>
+          </a:graphicData>
+        </a:graphic>
+      </p:graphicFrame>
       <p:sp>
         <p:nvSpPr>
-          <p:cNvPr id="3" name="Text 1"/>
+          <p:cNvPr id="5" name="Text 1"/>
           <p:cNvSpPr txBox="1"/>
           <p:nvPr/>
         </p:nvSpPr>
         <p:spPr>
           <a:xfrm>
-            <a:off x="548640" y="1188720"/>
-            <a:ext cx="8046720" cy="3291840"/>
+            <a:off x="548640" y="2743200"/>
+            <a:ext cx="8092440" cy="1737360"/>
           </a:xfrm>
           <a:prstGeom prst="rect">
             <a:avLst/>
@@ -8403,109 +10742,103 @@
           <a:bodyPr wrap="square" lIns="0" tIns="0" rIns="0" bIns="0" rtlCol="0" anchor="t"/>
           <a:lstStyle/>
           <a:p>
-            <a:pPr marL="342900" indent="-342900">
+            <a:pPr indent="0" marL="0">
               <a:spcAft>
-                <a:spcPts val="1000"/>
+                <a:spcPts val="600"/>
               </a:spcAft>
-              <a:buSzPct val="100000"/>
-              <a:buChar char="•"/>
+              <a:buNone/>
             </a:pPr>
             <a:r>
-              <a:rPr lang="en-US" sz="1800" dirty="0">
+              <a:rPr lang="en-US" sz="1300" dirty="0">
                 <a:solidFill>
-                  <a:srgbClr val="FFFFFF"/>
+                  <a:srgbClr val="1B2A38"/>
                 </a:solidFill>
                 <a:latin typeface="Calibri" pitchFamily="34" charset="0"/>
                 <a:ea typeface="Calibri" pitchFamily="34" charset="-122"/>
                 <a:cs typeface="Calibri" pitchFamily="34" charset="-120"/>
               </a:rPr>
-              <a:t>Sybil attacks (not covered yet)</a:t>
+              <a:t>Senders are tracked by pseudonym (what a receiver sees); three new inputs: identity age, handover distance, lockstep. Final = mean of 3 models. Message-label FPR 2.07%.</a:t>
             </a:r>
-            <a:endParaRPr lang="en-US" sz="1800" dirty="0"/>
+            <a:endParaRPr lang="en-US" sz="1300" dirty="0"/>
           </a:p>
           <a:p>
-            <a:pPr marL="342900" indent="-342900">
+            <a:pPr indent="0" marL="0">
               <a:spcAft>
-                <a:spcPts val="1000"/>
+                <a:spcPts val="600"/>
               </a:spcAft>
-              <a:buSzPct val="100000"/>
-              <a:buChar char="•"/>
+              <a:buNone/>
             </a:pPr>
             <a:r>
-              <a:rPr lang="en-US" sz="1800" dirty="0">
+              <a:rPr lang="en-US" sz="1300" b="1" dirty="0">
                 <a:solidFill>
-                  <a:srgbClr val="FFFFFF"/>
+                  <a:srgbClr val="1C7C7D"/>
                 </a:solidFill>
                 <a:latin typeface="Calibri" pitchFamily="34" charset="0"/>
                 <a:ea typeface="Calibri" pitchFamily="34" charset="-122"/>
                 <a:cs typeface="Calibri" pitchFamily="34" charset="-120"/>
               </a:rPr>
-              <a:t>Check on original VeReMi and VeReMi NextGen</a:t>
+              <a:t>Neighbour attention helps more with Sybil: +1.4 F1 (vs +0.3 on 14 attacks).</a:t>
             </a:r>
-            <a:endParaRPr lang="en-US" sz="1800" dirty="0"/>
+            <a:endParaRPr lang="en-US" sz="1300" dirty="0"/>
           </a:p>
           <a:p>
-            <a:pPr marL="342900" indent="-342900">
+            <a:pPr indent="0" marL="0">
               <a:spcAft>
-                <a:spcPts val="1000"/>
+                <a:spcPts val="600"/>
               </a:spcAft>
-              <a:buSzPct val="100000"/>
-              <a:buChar char="•"/>
+              <a:buNone/>
             </a:pPr>
             <a:r>
-              <a:rPr lang="en-US" sz="1800" dirty="0">
+              <a:rPr lang="en-US" sz="1300" b="1" dirty="0">
                 <a:solidFill>
-                  <a:srgbClr val="FFFFFF"/>
+                  <a:srgbClr val="C0392B"/>
                 </a:solidFill>
                 <a:latin typeface="Calibri" pitchFamily="34" charset="0"/>
                 <a:ea typeface="Calibri" pitchFamily="34" charset="-122"/>
                 <a:cs typeface="Calibri" pitchFamily="34" charset="-120"/>
               </a:rPr>
-              <a:t>Run v2 on dense traffic; add a 3rd seed</a:t>
+              <a:t>Honest result: on 18 attacks all four numbers are below the 97.37% reference. Missed GridSybil ghosts look honest on every content check; they need an independent signal.</a:t>
             </a:r>
-            <a:endParaRPr lang="en-US" sz="1800" dirty="0"/>
+            <a:endParaRPr lang="en-US" sz="1300" dirty="0"/>
           </a:p>
+        </p:txBody>
+      </p:sp>
+      <p:sp>
+        <p:nvSpPr>
+          <p:cNvPr id="6" name="Text 2"/>
+          <p:cNvSpPr txBox="1"/>
+          <p:nvPr/>
+        </p:nvSpPr>
+        <p:spPr>
+          <a:xfrm>
+            <a:off x="548640" y="4526280"/>
+            <a:ext cx="8046720" cy="365760"/>
+          </a:xfrm>
+          <a:prstGeom prst="rect">
+            <a:avLst/>
+          </a:prstGeom>
+          <a:noFill/>
+          <a:ln/>
+        </p:spPr>
+        <p:txBody>
+          <a:bodyPr wrap="square" lIns="0" tIns="0" rIns="0" bIns="0" rtlCol="0" anchor="ctr"/>
+          <a:lstStyle/>
           <a:p>
-            <a:pPr marL="342900" indent="-342900">
-              <a:spcAft>
-                <a:spcPts val="1000"/>
-              </a:spcAft>
-              <a:buSzPct val="100000"/>
-              <a:buChar char="•"/>
+            <a:pPr indent="0" marL="0">
+              <a:buNone/>
             </a:pPr>
             <a:r>
-              <a:rPr lang="en-US" sz="1800" dirty="0">
+              <a:rPr lang="en-US" sz="1050" i="1" dirty="0">
                 <a:solidFill>
-                  <a:srgbClr val="FFFFFF"/>
+                  <a:srgbClr val="5B6B7A"/>
                 </a:solidFill>
                 <a:latin typeface="Calibri" pitchFamily="34" charset="0"/>
                 <a:ea typeface="Calibri" pitchFamily="34" charset="-122"/>
                 <a:cs typeface="Calibri" pitchFamily="34" charset="-120"/>
               </a:rPr>
-              <a:t>On-road consistent lies need an independent signal: signal strength, on-board sensors, roadside units</a:t>
+              <a:t>All values in % except recall per attack (message labels). Source: results/results_v18_final.json, paper/tables_v18.tex.</a:t>
             </a:r>
-            <a:endParaRPr lang="en-US" sz="1800" dirty="0"/>
-          </a:p>
-          <a:p>
-            <a:pPr marL="342900" indent="-342900">
-              <a:spcAft>
-                <a:spcPts val="1000"/>
-              </a:spcAft>
-              <a:buSzPct val="100000"/>
-              <a:buChar char="•"/>
-            </a:pPr>
-            <a:r>
-              <a:rPr lang="en-US" sz="1800" dirty="0">
-                <a:solidFill>
-                  <a:srgbClr val="FFFFFF"/>
-                </a:solidFill>
-                <a:latin typeface="Calibri" pitchFamily="34" charset="0"/>
-                <a:ea typeface="Calibri" pitchFamily="34" charset="-122"/>
-                <a:cs typeface="Calibri" pitchFamily="34" charset="-120"/>
-              </a:rPr>
-              <a:t>Paper done: paper/main.pdf, IEEE conference format, 6 pages, 18 references</a:t>
-            </a:r>
-            <a:endParaRPr lang="en-US" sz="1800" dirty="0"/>
+            <a:endParaRPr lang="en-US" sz="1050" dirty="0"/>
           </a:p>
         </p:txBody>
       </p:sp>

</xml_diff>